<commit_message>
Final analysis pass: README results block, deck with the measured conclusions, PCIe/C2C wording, counter table from the active tray
Co-Authored-By: Claude Fable 5.1 <noreply@anthropic.com>
</commit_message>
<xml_diff>
--- a/slides/compass.pptx
+++ b/slides/compass.pptx
@@ -5669,7 +5669,7 @@
               </a:defRPr>
             </a:pPr>
             <a:r>
-              <a:t>• Evidence: rail port_xmit_data vs 200 Gb/s line rate per rail; NVLink TX/RX bytes; pause/CNP counters; per-rank spread and the slowest rank</a:t>
+              <a:t>• Evidence: bytes on the wire (port_xmit_data, verified against ethtool) equal the two-node minimum S per direction; one rail carried 411 Gb/s — so a rail is a 4-plane 800 Gb/s port, not the 200 Gb/s sysfs reports</a:t>
             </a:r>
           </a:p>
           <a:p>
@@ -5684,7 +5684,7 @@
               </a:defRPr>
             </a:pPr>
             <a:r>
-              <a:t>• RDMA path scales with rails claimed (1 → 2 → 4): the NIC count, not the GPU, is the ceiling on that path</a:t>
+              <a:t>• RDMA path scales with rails claimed (1 → 2 → 4) and each rail sits at ~55 % of 800 Gb/s; CNP/ECN/out-of-sequence counters flat; NIC and GPU at PCIe Gen6 x16 → not the wire, not congestion, not PCIe</a:t>
             </a:r>
           </a:p>
           <a:p>
@@ -5699,7 +5699,22 @@
               </a:defRPr>
             </a:pPr>
             <a:r>
-              <a:t>• Cross-tray NVLink is an order of magnitude above the four rails: the topology decides the transport, the transport decides the ceiling</a:t>
+              <a:t>• What remains: the per-rail injection path (one NCCL connection per GPU–NIC pair, GDR across the Grace socket over C2C) — a narrowed hypothesis, with the next experiment named (channels per NIC, GPU–NIC placement)</a:t>
+            </a:r>
+          </a:p>
+          <a:p>
+            <a:pPr>
+              <a:spcAft>
+                <a:spcPts val="600"/>
+              </a:spcAft>
+              <a:defRPr sz="1200">
+                <a:solidFill>
+                  <a:srgbClr val="0B0B0B"/>
+                </a:solidFill>
+              </a:defRPr>
+            </a:pPr>
+            <a:r>
+              <a:t>• Cross-tray NVLink at 835 GB/s is ~2× the four rails together: the topology decides the transport, the transport decides the ceiling</a:t>
             </a:r>
           </a:p>
         </p:txBody>
@@ -6229,7 +6244,7 @@
               </a:defRPr>
             </a:pPr>
             <a:r>
-              <a:t>• Hypothesis (written before the run): a single QP per peer leaves rail bandwidth idle at large messages; more QPs spread the flow and raise busbw; trade-off is per-QP state and out-of-order handling (out_of_sequence, packet_seq_err)</a:t>
+              <a:t>• Hypothesis (written before the run): a single QP per peer leaves rail bandwidth idle (rails at ~55 %); more QPs spread the flow and raise busbw; trade-off is per-QP state and out-of-order handling (out_of_sequence, packet_seq_err)</a:t>
             </a:r>
           </a:p>
           <a:p>
@@ -6244,7 +6259,7 @@
               </a:defRPr>
             </a:pPr>
             <a:r>
-              <a:t>• Change: QPS_PER_CONNECTION 1 → 2 → 4 with SPLIT_DATA_ON_QPS=1; 5 repeats each at 16 MiB / 512 MiB / 4 GiB</a:t>
+              <a:t>• Change: QPS_PER_CONNECTION 1 → 2 → 4 with SPLIT_DATA_ON_QPS=1; 5 repeats each at 16 MiB / 512 MiB / 4 GiB; nothing else touched</a:t>
             </a:r>
           </a:p>
           <a:p>
@@ -6259,7 +6274,22 @@
               </a:defRPr>
             </a:pPr>
             <a:r>
-              <a:t>• Measurement and conclusion: see the table — a negative or null result is reported as such (Welch p-value per cell)</a:t>
+              <a:t>• Measurement: QPs=2 −4/−9/−8 %, QPs=4 −19/−32/−29 % (Welch p &lt; 0.001 at every size for QPs=4); counter window at QPs=4: 338 Gb/s per rail vs 482, reordering and congestion counters still zero</a:t>
+            </a:r>
+          </a:p>
+          <a:p>
+            <a:pPr>
+              <a:spcAft>
+                <a:spcPts val="600"/>
+              </a:spcAft>
+              <a:defRPr sz="1200">
+                <a:solidFill>
+                  <a:srgbClr val="0B0B0B"/>
+                </a:solidFill>
+              </a:defRPr>
+            </a:pPr>
+            <a:r>
+              <a:t>• Conclusion — negative: the headroom is real but this knob cannot reach it; splitting messages across QPs shrinks each work request. Keep the default; the ceiling is on the injection side</a:t>
             </a:r>
           </a:p>
         </p:txBody>
@@ -7296,7 +7326,22 @@
               </a:defRPr>
             </a:pPr>
             <a:r>
-              <a:t>• GPUDirect off, buffer sizes, algorithms (Ring/Tree/NVLS), socket threads on the TCP path</a:t>
+              <a:t>• GPUDirect off (−38 %, same bytes on the wire, 1.6× the time), buffer sizes (noise), NVLS vs Ring on NVLink (474 vs 388 GB/s algbw), Tree invalid for the all-gather, socket threads (7× on TCP)</a:t>
+            </a:r>
+          </a:p>
+          <a:p>
+            <a:pPr>
+              <a:spcAft>
+                <a:spcPts val="600"/>
+              </a:spcAft>
+              <a:defRPr sz="1400">
+                <a:solidFill>
+                  <a:srgbClr val="0B0B0B"/>
+                </a:solidFill>
+              </a:defRPr>
+            </a:pPr>
+            <a:r>
+              <a:t>• DDP bucket 25 → 200 MiB over the rails: 2090 → 2769 samples/s (+32 %), comm fraction 91 % → 32 % — change how often you talk before how you talk</a:t>
             </a:r>
           </a:p>
         </p:txBody>

</xml_diff>

<commit_message>
Demo runbook with measured timings and talking points (DRA, dranet fork, Cilium, GID, NCCL tuning, training, dashboard), demo-gid.sh, three new slides; deck rebuilt
Co-Authored-By: Claude Fable 5.1 <noreply@anthropic.com>
</commit_message>
<xml_diff>
--- a/slides/compass.pptx
+++ b/slides/compass.pptx
@@ -14,6 +14,9 @@
     <p:sldId id="262" r:id="rId13"/>
     <p:sldId id="263" r:id="rId14"/>
     <p:sldId id="264" r:id="rId15"/>
+    <p:sldId id="265" r:id="rId16"/>
+    <p:sldId id="266" r:id="rId17"/>
+    <p:sldId id="267" r:id="rId18"/>
   </p:sldIdLst>
   <p:sldSz cx="12191695" cy="6858000" type="screen4x3"/>
   <p:notesSz cx="6858000" cy="9144000"/>
@@ -3151,6 +3154,1171 @@
 </p:sld>
 </file>
 
+<file path=ppt/slides/slide10.xml><?xml version="1.0" encoding="utf-8"?>
+<p:sld xmlns:a="http://schemas.openxmlformats.org/drawingml/2006/main" xmlns:p="http://schemas.openxmlformats.org/presentationml/2006/main" xmlns:r="http://schemas.openxmlformats.org/officeDocument/2006/relationships">
+  <p:cSld>
+    <p:spTree>
+      <p:nvGrpSpPr>
+        <p:cNvPr id="1" name=""/>
+        <p:cNvGrpSpPr/>
+        <p:nvPr/>
+      </p:nvGrpSpPr>
+      <p:grpSpPr/>
+      <p:sp>
+        <p:nvSpPr>
+          <p:cNvPr id="2" name="TextBox 1"/>
+          <p:cNvSpPr txBox="1"/>
+          <p:nvPr/>
+        </p:nvSpPr>
+        <p:spPr>
+          <a:xfrm>
+            <a:off x="457200" y="274320"/>
+            <a:ext cx="11247120" cy="822960"/>
+          </a:xfrm>
+          <a:prstGeom prst="rect">
+            <a:avLst/>
+          </a:prstGeom>
+          <a:noFill/>
+        </p:spPr>
+        <p:txBody>
+          <a:bodyPr wrap="none">
+            <a:spAutoFit/>
+          </a:bodyPr>
+          <a:lstStyle/>
+          <a:p>
+            <a:pPr>
+              <a:defRPr sz="2600" b="1">
+                <a:solidFill>
+                  <a:srgbClr val="0B0B0B"/>
+                </a:solidFill>
+              </a:defRPr>
+            </a:pPr>
+            <a:r>
+              <a:t>5 · Sensitivity appendix</a:t>
+            </a:r>
+          </a:p>
+        </p:txBody>
+      </p:sp>
+      <p:sp>
+        <p:nvSpPr>
+          <p:cNvPr id="3" name="TextBox 2"/>
+          <p:cNvSpPr txBox="1"/>
+          <p:nvPr/>
+        </p:nvSpPr>
+        <p:spPr>
+          <a:xfrm>
+            <a:off x="548640" y="1188720"/>
+            <a:ext cx="5486400" cy="5029200"/>
+          </a:xfrm>
+          <a:prstGeom prst="rect">
+            <a:avLst/>
+          </a:prstGeom>
+          <a:noFill/>
+        </p:spPr>
+        <p:txBody>
+          <a:bodyPr wrap="square">
+            <a:spAutoFit/>
+          </a:bodyPr>
+          <a:lstStyle/>
+          <a:p>
+            <a:pPr>
+              <a:spcAft>
+                <a:spcPts val="600"/>
+              </a:spcAft>
+              <a:defRPr sz="1400">
+                <a:solidFill>
+                  <a:srgbClr val="0B0B0B"/>
+                </a:solidFill>
+              </a:defRPr>
+            </a:pPr>
+            <a:r>
+              <a:t>• GPUDirect off (−38 %, same bytes on the wire, 1.6× the time), buffer sizes (noise), NVLS vs Ring on NVLink (474 vs 388 GB/s algbw), Tree invalid for the all-gather, socket threads (7× on TCP)</a:t>
+            </a:r>
+          </a:p>
+          <a:p>
+            <a:pPr>
+              <a:spcAft>
+                <a:spcPts val="600"/>
+              </a:spcAft>
+              <a:defRPr sz="1400">
+                <a:solidFill>
+                  <a:srgbClr val="0B0B0B"/>
+                </a:solidFill>
+              </a:defRPr>
+            </a:pPr>
+            <a:r>
+              <a:t>• DDP bucket 25 → 200 MiB over the rails: 2090 → 2769 samples/s (+32 %), comm fraction 91 % → 32 % — change how often you talk before how you talk</a:t>
+            </a:r>
+          </a:p>
+        </p:txBody>
+      </p:sp>
+      <p:graphicFrame>
+        <p:nvGraphicFramePr>
+          <p:cNvPr id="4" name="Table 3"/>
+          <p:cNvGraphicFramePr>
+            <a:graphicFrameLocks noGrp="1"/>
+          </p:cNvGraphicFramePr>
+          <p:nvPr/>
+        </p:nvGraphicFramePr>
+        <p:xfrm>
+          <a:off x="6217920" y="1188720"/>
+          <a:ext cx="5486400" cy="3291839"/>
+        </p:xfrm>
+        <a:graphic>
+          <a:graphicData uri="http://schemas.openxmlformats.org/drawingml/2006/table">
+            <a:tbl>
+              <a:tblPr firstRow="1" bandRow="1">
+                <a:tableStyleId>{5C22544A-7EE6-4342-B048-85BDC9FD1C3A}</a:tableStyleId>
+              </a:tblPr>
+              <a:tblGrid>
+                <a:gridCol w="1371600"/>
+                <a:gridCol w="1371600"/>
+                <a:gridCol w="1371600"/>
+                <a:gridCol w="1371600"/>
+              </a:tblGrid>
+              <a:tr h="274319">
+                <a:tc>
+                  <a:txBody>
+                    <a:bodyPr/>
+                    <a:lstStyle/>
+                    <a:p>
+                      <a:pPr>
+                        <a:defRPr sz="900" b="1"/>
+                      </a:pPr>
+                      <a:r>
+                        <a:t>run_id</a:t>
+                      </a:r>
+                    </a:p>
+                  </a:txBody>
+                  <a:tcPr/>
+                </a:tc>
+                <a:tc>
+                  <a:txBody>
+                    <a:bodyPr/>
+                    <a:lstStyle/>
+                    <a:p>
+                      <a:pPr>
+                        <a:defRPr sz="900" b="1"/>
+                      </a:pPr>
+                      <a:r>
+                        <a:t>16MiB</a:t>
+                      </a:r>
+                    </a:p>
+                  </a:txBody>
+                  <a:tcPr/>
+                </a:tc>
+                <a:tc>
+                  <a:txBody>
+                    <a:bodyPr/>
+                    <a:lstStyle/>
+                    <a:p>
+                      <a:pPr>
+                        <a:defRPr sz="900" b="1"/>
+                      </a:pPr>
+                      <a:r>
+                        <a:t>512MiB</a:t>
+                      </a:r>
+                    </a:p>
+                  </a:txBody>
+                  <a:tcPr/>
+                </a:tc>
+                <a:tc>
+                  <a:txBody>
+                    <a:bodyPr/>
+                    <a:lstStyle/>
+                    <a:p>
+                      <a:pPr>
+                        <a:defRPr sz="900" b="1"/>
+                      </a:pPr>
+                      <a:r>
+                        <a:t>4GiB</a:t>
+                      </a:r>
+                    </a:p>
+                  </a:txBody>
+                  <a:tcPr/>
+                </a:tc>
+              </a:tr>
+              <a:tr h="274319">
+                <a:tc>
+                  <a:txBody>
+                    <a:bodyPr/>
+                    <a:lstStyle/>
+                    <a:p>
+                      <a:pPr>
+                        <a:defRPr sz="900"/>
+                      </a:pPr>
+                      <a:r>
+                        <a:t>e5-algo-nvls</a:t>
+                      </a:r>
+                    </a:p>
+                  </a:txBody>
+                  <a:tcPr/>
+                </a:tc>
+                <a:tc>
+                  <a:txBody>
+                    <a:bodyPr/>
+                    <a:lstStyle/>
+                    <a:p>
+                      <a:pPr>
+                        <a:defRPr sz="900"/>
+                      </a:pPr>
+                      <a:r>
+                        <a:t>297</a:t>
+                      </a:r>
+                    </a:p>
+                  </a:txBody>
+                  <a:tcPr/>
+                </a:tc>
+                <a:tc>
+                  <a:txBody>
+                    <a:bodyPr/>
+                    <a:lstStyle/>
+                    <a:p>
+                      <a:pPr>
+                        <a:defRPr sz="900"/>
+                      </a:pPr>
+                      <a:r>
+                        <a:t>695</a:t>
+                      </a:r>
+                    </a:p>
+                  </a:txBody>
+                  <a:tcPr/>
+                </a:tc>
+                <a:tc>
+                  <a:txBody>
+                    <a:bodyPr/>
+                    <a:lstStyle/>
+                    <a:p>
+                      <a:pPr>
+                        <a:defRPr sz="900"/>
+                      </a:pPr>
+                      <a:r>
+                        <a:t>830</a:t>
+                      </a:r>
+                    </a:p>
+                  </a:txBody>
+                  <a:tcPr/>
+                </a:tc>
+              </a:tr>
+              <a:tr h="274319">
+                <a:tc>
+                  <a:txBody>
+                    <a:bodyPr/>
+                    <a:lstStyle/>
+                    <a:p>
+                      <a:pPr>
+                        <a:defRPr sz="900"/>
+                      </a:pPr>
+                      <a:r>
+                        <a:t>e5-algo-ring</a:t>
+                      </a:r>
+                    </a:p>
+                  </a:txBody>
+                  <a:tcPr/>
+                </a:tc>
+                <a:tc>
+                  <a:txBody>
+                    <a:bodyPr/>
+                    <a:lstStyle/>
+                    <a:p>
+                      <a:pPr>
+                        <a:defRPr sz="900"/>
+                      </a:pPr>
+                      <a:r>
+                        <a:t>327</a:t>
+                      </a:r>
+                    </a:p>
+                  </a:txBody>
+                  <a:tcPr/>
+                </a:tc>
+                <a:tc>
+                  <a:txBody>
+                    <a:bodyPr/>
+                    <a:lstStyle/>
+                    <a:p>
+                      <a:pPr>
+                        <a:defRPr sz="900"/>
+                      </a:pPr>
+                      <a:r>
+                        <a:t>635</a:t>
+                      </a:r>
+                    </a:p>
+                  </a:txBody>
+                  <a:tcPr/>
+                </a:tc>
+                <a:tc>
+                  <a:txBody>
+                    <a:bodyPr/>
+                    <a:lstStyle/>
+                    <a:p>
+                      <a:pPr>
+                        <a:defRPr sz="900"/>
+                      </a:pPr>
+                      <a:r>
+                        <a:t>679</a:t>
+                      </a:r>
+                    </a:p>
+                  </a:txBody>
+                  <a:tcPr/>
+                </a:tc>
+              </a:tr>
+              <a:tr h="274319">
+                <a:tc>
+                  <a:txBody>
+                    <a:bodyPr/>
+                    <a:lstStyle/>
+                    <a:p>
+                      <a:pPr>
+                        <a:defRPr sz="900"/>
+                      </a:pPr>
+                      <a:r>
+                        <a:t>e5-buffsize16m</a:t>
+                      </a:r>
+                    </a:p>
+                  </a:txBody>
+                  <a:tcPr/>
+                </a:tc>
+                <a:tc>
+                  <a:txBody>
+                    <a:bodyPr/>
+                    <a:lstStyle/>
+                    <a:p>
+                      <a:pPr>
+                        <a:defRPr sz="900"/>
+                      </a:pPr>
+                      <a:r>
+                        <a:t>101</a:t>
+                      </a:r>
+                    </a:p>
+                  </a:txBody>
+                  <a:tcPr/>
+                </a:tc>
+                <a:tc>
+                  <a:txBody>
+                    <a:bodyPr/>
+                    <a:lstStyle/>
+                    <a:p>
+                      <a:pPr>
+                        <a:defRPr sz="900"/>
+                      </a:pPr>
+                      <a:r>
+                        <a:t>420</a:t>
+                      </a:r>
+                    </a:p>
+                  </a:txBody>
+                  <a:tcPr/>
+                </a:tc>
+                <a:tc>
+                  <a:txBody>
+                    <a:bodyPr/>
+                    <a:lstStyle/>
+                    <a:p>
+                      <a:pPr>
+                        <a:defRPr sz="900"/>
+                      </a:pPr>
+                      <a:r>
+                        <a:t>393</a:t>
+                      </a:r>
+                    </a:p>
+                  </a:txBody>
+                  <a:tcPr/>
+                </a:tc>
+              </a:tr>
+              <a:tr h="274319">
+                <a:tc>
+                  <a:txBody>
+                    <a:bodyPr/>
+                    <a:lstStyle/>
+                    <a:p>
+                      <a:pPr>
+                        <a:defRPr sz="900"/>
+                      </a:pPr>
+                      <a:r>
+                        <a:t>e5-buffsize4m</a:t>
+                      </a:r>
+                    </a:p>
+                  </a:txBody>
+                  <a:tcPr/>
+                </a:tc>
+                <a:tc>
+                  <a:txBody>
+                    <a:bodyPr/>
+                    <a:lstStyle/>
+                    <a:p>
+                      <a:pPr>
+                        <a:defRPr sz="900"/>
+                      </a:pPr>
+                      <a:r>
+                        <a:t>102</a:t>
+                      </a:r>
+                    </a:p>
+                  </a:txBody>
+                  <a:tcPr/>
+                </a:tc>
+                <a:tc>
+                  <a:txBody>
+                    <a:bodyPr/>
+                    <a:lstStyle/>
+                    <a:p>
+                      <a:pPr>
+                        <a:defRPr sz="900"/>
+                      </a:pPr>
+                      <a:r>
+                        <a:t>402</a:t>
+                      </a:r>
+                    </a:p>
+                  </a:txBody>
+                  <a:tcPr/>
+                </a:tc>
+                <a:tc>
+                  <a:txBody>
+                    <a:bodyPr/>
+                    <a:lstStyle/>
+                    <a:p>
+                      <a:pPr>
+                        <a:defRPr sz="900"/>
+                      </a:pPr>
+                      <a:r>
+                        <a:t>419</a:t>
+                      </a:r>
+                    </a:p>
+                  </a:txBody>
+                  <a:tcPr/>
+                </a:tc>
+              </a:tr>
+              <a:tr h="274319">
+                <a:tc>
+                  <a:txBody>
+                    <a:bodyPr/>
+                    <a:lstStyle/>
+                    <a:p>
+                      <a:pPr>
+                        <a:defRPr sz="900"/>
+                      </a:pPr>
+                      <a:r>
+                        <a:t>e5-counters-gdr-off</a:t>
+                      </a:r>
+                    </a:p>
+                  </a:txBody>
+                  <a:tcPr/>
+                </a:tc>
+                <a:tc>
+                  <a:txBody>
+                    <a:bodyPr/>
+                    <a:lstStyle/>
+                    <a:p>
+                      <a:pPr>
+                        <a:defRPr sz="900"/>
+                      </a:pPr>
+                      <a:r>
+                        <a:t>nan</a:t>
+                      </a:r>
+                    </a:p>
+                  </a:txBody>
+                  <a:tcPr/>
+                </a:tc>
+                <a:tc>
+                  <a:txBody>
+                    <a:bodyPr/>
+                    <a:lstStyle/>
+                    <a:p>
+                      <a:pPr>
+                        <a:defRPr sz="900"/>
+                      </a:pPr>
+                      <a:r>
+                        <a:t>nan</a:t>
+                      </a:r>
+                    </a:p>
+                  </a:txBody>
+                  <a:tcPr/>
+                </a:tc>
+                <a:tc>
+                  <a:txBody>
+                    <a:bodyPr/>
+                    <a:lstStyle/>
+                    <a:p>
+                      <a:pPr>
+                        <a:defRPr sz="900"/>
+                      </a:pPr>
+                      <a:r>
+                        <a:t>253</a:t>
+                      </a:r>
+                    </a:p>
+                  </a:txBody>
+                  <a:tcPr/>
+                </a:tc>
+              </a:tr>
+              <a:tr h="274319">
+                <a:tc>
+                  <a:txBody>
+                    <a:bodyPr/>
+                    <a:lstStyle/>
+                    <a:p>
+                      <a:pPr>
+                        <a:defRPr sz="900"/>
+                      </a:pPr>
+                      <a:r>
+                        <a:t>e5-counters-nvlink</a:t>
+                      </a:r>
+                    </a:p>
+                  </a:txBody>
+                  <a:tcPr/>
+                </a:tc>
+                <a:tc>
+                  <a:txBody>
+                    <a:bodyPr/>
+                    <a:lstStyle/>
+                    <a:p>
+                      <a:pPr>
+                        <a:defRPr sz="900"/>
+                      </a:pPr>
+                      <a:r>
+                        <a:t>nan</a:t>
+                      </a:r>
+                    </a:p>
+                  </a:txBody>
+                  <a:tcPr/>
+                </a:tc>
+                <a:tc>
+                  <a:txBody>
+                    <a:bodyPr/>
+                    <a:lstStyle/>
+                    <a:p>
+                      <a:pPr>
+                        <a:defRPr sz="900"/>
+                      </a:pPr>
+                      <a:r>
+                        <a:t>nan</a:t>
+                      </a:r>
+                    </a:p>
+                  </a:txBody>
+                  <a:tcPr/>
+                </a:tc>
+                <a:tc>
+                  <a:txBody>
+                    <a:bodyPr/>
+                    <a:lstStyle/>
+                    <a:p>
+                      <a:pPr>
+                        <a:defRPr sz="900"/>
+                      </a:pPr>
+                      <a:r>
+                        <a:t>833</a:t>
+                      </a:r>
+                    </a:p>
+                  </a:txBody>
+                  <a:tcPr/>
+                </a:tc>
+              </a:tr>
+              <a:tr h="274319">
+                <a:tc>
+                  <a:txBody>
+                    <a:bodyPr/>
+                    <a:lstStyle/>
+                    <a:p>
+                      <a:pPr>
+                        <a:defRPr sz="900"/>
+                      </a:pPr>
+                      <a:r>
+                        <a:t>e5-counters-rails1</a:t>
+                      </a:r>
+                    </a:p>
+                  </a:txBody>
+                  <a:tcPr/>
+                </a:tc>
+                <a:tc>
+                  <a:txBody>
+                    <a:bodyPr/>
+                    <a:lstStyle/>
+                    <a:p>
+                      <a:pPr>
+                        <a:defRPr sz="900"/>
+                      </a:pPr>
+                      <a:r>
+                        <a:t>nan</a:t>
+                      </a:r>
+                    </a:p>
+                  </a:txBody>
+                  <a:tcPr/>
+                </a:tc>
+                <a:tc>
+                  <a:txBody>
+                    <a:bodyPr/>
+                    <a:lstStyle/>
+                    <a:p>
+                      <a:pPr>
+                        <a:defRPr sz="900"/>
+                      </a:pPr>
+                      <a:r>
+                        <a:t>nan</a:t>
+                      </a:r>
+                    </a:p>
+                  </a:txBody>
+                  <a:tcPr/>
+                </a:tc>
+                <a:tc>
+                  <a:txBody>
+                    <a:bodyPr/>
+                    <a:lstStyle/>
+                    <a:p>
+                      <a:pPr>
+                        <a:defRPr sz="900"/>
+                      </a:pPr>
+                      <a:r>
+                        <a:t>87.8</a:t>
+                      </a:r>
+                    </a:p>
+                  </a:txBody>
+                  <a:tcPr/>
+                </a:tc>
+              </a:tr>
+              <a:tr h="274319">
+                <a:tc>
+                  <a:txBody>
+                    <a:bodyPr/>
+                    <a:lstStyle/>
+                    <a:p>
+                      <a:pPr>
+                        <a:defRPr sz="900"/>
+                      </a:pPr>
+                      <a:r>
+                        <a:t>e5-counters-rdma</a:t>
+                      </a:r>
+                    </a:p>
+                  </a:txBody>
+                  <a:tcPr/>
+                </a:tc>
+                <a:tc>
+                  <a:txBody>
+                    <a:bodyPr/>
+                    <a:lstStyle/>
+                    <a:p>
+                      <a:pPr>
+                        <a:defRPr sz="900"/>
+                      </a:pPr>
+                      <a:r>
+                        <a:t>nan</a:t>
+                      </a:r>
+                    </a:p>
+                  </a:txBody>
+                  <a:tcPr/>
+                </a:tc>
+                <a:tc>
+                  <a:txBody>
+                    <a:bodyPr/>
+                    <a:lstStyle/>
+                    <a:p>
+                      <a:pPr>
+                        <a:defRPr sz="900"/>
+                      </a:pPr>
+                      <a:r>
+                        <a:t>nan</a:t>
+                      </a:r>
+                    </a:p>
+                  </a:txBody>
+                  <a:tcPr/>
+                </a:tc>
+                <a:tc>
+                  <a:txBody>
+                    <a:bodyPr/>
+                    <a:lstStyle/>
+                    <a:p>
+                      <a:pPr>
+                        <a:defRPr sz="900"/>
+                      </a:pPr>
+                      <a:r>
+                        <a:t>410</a:t>
+                      </a:r>
+                    </a:p>
+                  </a:txBody>
+                  <a:tcPr/>
+                </a:tc>
+              </a:tr>
+              <a:tr h="274319">
+                <a:tc>
+                  <a:txBody>
+                    <a:bodyPr/>
+                    <a:lstStyle/>
+                    <a:p>
+                      <a:pPr>
+                        <a:defRPr sz="900"/>
+                      </a:pPr>
+                      <a:r>
+                        <a:t>e5-counters-rdma-qps4</a:t>
+                      </a:r>
+                    </a:p>
+                  </a:txBody>
+                  <a:tcPr/>
+                </a:tc>
+                <a:tc>
+                  <a:txBody>
+                    <a:bodyPr/>
+                    <a:lstStyle/>
+                    <a:p>
+                      <a:pPr>
+                        <a:defRPr sz="900"/>
+                      </a:pPr>
+                      <a:r>
+                        <a:t>nan</a:t>
+                      </a:r>
+                    </a:p>
+                  </a:txBody>
+                  <a:tcPr/>
+                </a:tc>
+                <a:tc>
+                  <a:txBody>
+                    <a:bodyPr/>
+                    <a:lstStyle/>
+                    <a:p>
+                      <a:pPr>
+                        <a:defRPr sz="900"/>
+                      </a:pPr>
+                      <a:r>
+                        <a:t>nan</a:t>
+                      </a:r>
+                    </a:p>
+                  </a:txBody>
+                  <a:tcPr/>
+                </a:tc>
+                <a:tc>
+                  <a:txBody>
+                    <a:bodyPr/>
+                    <a:lstStyle/>
+                    <a:p>
+                      <a:pPr>
+                        <a:defRPr sz="900"/>
+                      </a:pPr>
+                      <a:r>
+                        <a:t>301</a:t>
+                      </a:r>
+                    </a:p>
+                  </a:txBody>
+                  <a:tcPr/>
+                </a:tc>
+              </a:tr>
+              <a:tr h="274319">
+                <a:tc>
+                  <a:txBody>
+                    <a:bodyPr/>
+                    <a:lstStyle/>
+                    <a:p>
+                      <a:pPr>
+                        <a:defRPr sz="900"/>
+                      </a:pPr>
+                      <a:r>
+                        <a:t>e5-gdr-off</a:t>
+                      </a:r>
+                    </a:p>
+                  </a:txBody>
+                  <a:tcPr/>
+                </a:tc>
+                <a:tc>
+                  <a:txBody>
+                    <a:bodyPr/>
+                    <a:lstStyle/>
+                    <a:p>
+                      <a:pPr>
+                        <a:defRPr sz="900"/>
+                      </a:pPr>
+                      <a:r>
+                        <a:t>107</a:t>
+                      </a:r>
+                    </a:p>
+                  </a:txBody>
+                  <a:tcPr/>
+                </a:tc>
+                <a:tc>
+                  <a:txBody>
+                    <a:bodyPr/>
+                    <a:lstStyle/>
+                    <a:p>
+                      <a:pPr>
+                        <a:defRPr sz="900"/>
+                      </a:pPr>
+                      <a:r>
+                        <a:t>222</a:t>
+                      </a:r>
+                    </a:p>
+                  </a:txBody>
+                  <a:tcPr/>
+                </a:tc>
+                <a:tc>
+                  <a:txBody>
+                    <a:bodyPr/>
+                    <a:lstStyle/>
+                    <a:p>
+                      <a:pPr>
+                        <a:defRPr sz="900"/>
+                      </a:pPr>
+                      <a:r>
+                        <a:t>247</a:t>
+                      </a:r>
+                    </a:p>
+                  </a:txBody>
+                  <a:tcPr/>
+                </a:tc>
+              </a:tr>
+              <a:tr h="274330">
+                <a:tc>
+                  <a:txBody>
+                    <a:bodyPr/>
+                    <a:lstStyle/>
+                    <a:p>
+                      <a:pPr>
+                        <a:defRPr sz="900"/>
+                      </a:pPr>
+                      <a:r>
+                        <a:t>e5-sock-nthreads4</a:t>
+                      </a:r>
+                    </a:p>
+                  </a:txBody>
+                  <a:tcPr/>
+                </a:tc>
+                <a:tc>
+                  <a:txBody>
+                    <a:bodyPr/>
+                    <a:lstStyle/>
+                    <a:p>
+                      <a:pPr>
+                        <a:defRPr sz="900"/>
+                      </a:pPr>
+                      <a:r>
+                        <a:t>10.3</a:t>
+                      </a:r>
+                    </a:p>
+                  </a:txBody>
+                  <a:tcPr/>
+                </a:tc>
+                <a:tc>
+                  <a:txBody>
+                    <a:bodyPr/>
+                    <a:lstStyle/>
+                    <a:p>
+                      <a:pPr>
+                        <a:defRPr sz="900"/>
+                      </a:pPr>
+                      <a:r>
+                        <a:t>21.6</a:t>
+                      </a:r>
+                    </a:p>
+                  </a:txBody>
+                  <a:tcPr/>
+                </a:tc>
+                <a:tc>
+                  <a:txBody>
+                    <a:bodyPr/>
+                    <a:lstStyle/>
+                    <a:p>
+                      <a:pPr>
+                        <a:defRPr sz="900"/>
+                      </a:pPr>
+                      <a:r>
+                        <a:t>29.4</a:t>
+                      </a:r>
+                    </a:p>
+                  </a:txBody>
+                  <a:tcPr/>
+                </a:tc>
+              </a:tr>
+            </a:tbl>
+          </a:graphicData>
+        </a:graphic>
+      </p:graphicFrame>
+    </p:spTree>
+  </p:cSld>
+  <p:clrMapOvr>
+    <a:masterClrMapping/>
+  </p:clrMapOvr>
+</p:sld>
+</file>
+
+<file path=ppt/slides/slide11.xml><?xml version="1.0" encoding="utf-8"?>
+<p:sld xmlns:a="http://schemas.openxmlformats.org/drawingml/2006/main" xmlns:p="http://schemas.openxmlformats.org/presentationml/2006/main" xmlns:r="http://schemas.openxmlformats.org/officeDocument/2006/relationships">
+  <p:cSld>
+    <p:spTree>
+      <p:nvGrpSpPr>
+        <p:cNvPr id="1" name=""/>
+        <p:cNvGrpSpPr/>
+        <p:nvPr/>
+      </p:nvGrpSpPr>
+      <p:grpSpPr/>
+      <p:sp>
+        <p:nvSpPr>
+          <p:cNvPr id="2" name="TextBox 1"/>
+          <p:cNvSpPr txBox="1"/>
+          <p:nvPr/>
+        </p:nvSpPr>
+        <p:spPr>
+          <a:xfrm>
+            <a:off x="457200" y="274320"/>
+            <a:ext cx="11247120" cy="822960"/>
+          </a:xfrm>
+          <a:prstGeom prst="rect">
+            <a:avLst/>
+          </a:prstGeom>
+          <a:noFill/>
+        </p:spPr>
+        <p:txBody>
+          <a:bodyPr wrap="none">
+            <a:spAutoFit/>
+          </a:bodyPr>
+          <a:lstStyle/>
+          <a:p>
+            <a:pPr>
+              <a:defRPr sz="2600" b="1">
+                <a:solidFill>
+                  <a:srgbClr val="0B0B0B"/>
+                </a:solidFill>
+              </a:defRPr>
+            </a:pPr>
+            <a:r>
+              <a:t>5 · Extending to production multi-node GPU systems</a:t>
+            </a:r>
+          </a:p>
+        </p:txBody>
+      </p:sp>
+      <p:sp>
+        <p:nvSpPr>
+          <p:cNvPr id="3" name="TextBox 2"/>
+          <p:cNvSpPr txBox="1"/>
+          <p:nvPr/>
+        </p:nvSpPr>
+        <p:spPr>
+          <a:xfrm>
+            <a:off x="548640" y="1188720"/>
+            <a:ext cx="10972800" cy="5029200"/>
+          </a:xfrm>
+          <a:prstGeom prst="rect">
+            <a:avLst/>
+          </a:prstGeom>
+          <a:noFill/>
+        </p:spPr>
+        <p:txBody>
+          <a:bodyPr wrap="square">
+            <a:spAutoFit/>
+          </a:bodyPr>
+          <a:lstStyle/>
+          <a:p>
+            <a:pPr>
+              <a:spcAft>
+                <a:spcPts val="600"/>
+              </a:spcAft>
+              <a:defRPr sz="1400">
+                <a:solidFill>
+                  <a:srgbClr val="0B0B0B"/>
+                </a:solidFill>
+              </a:defRPr>
+            </a:pPr>
+            <a:r>
+              <a:t>• Same manifests scale by nnodes: one pod per tray, one claim per pod; rails per pod and GID discovery stay per-node decisions</a:t>
+            </a:r>
+          </a:p>
+          <a:p>
+            <a:pPr>
+              <a:spcAft>
+                <a:spcPts val="600"/>
+              </a:spcAft>
+              <a:defRPr sz="1400">
+                <a:solidFill>
+                  <a:srgbClr val="0B0B0B"/>
+                </a:solidFill>
+              </a:defRPr>
+            </a:pPr>
+            <a:r>
+              <a:t>• Fleet health: the counters watched here (rail bytes, CNPs, pause, NVLink errors, transport fallbacks) become alert rules; a silent NET/Socket fallback is a FAIL, not a slow run</a:t>
+            </a:r>
+          </a:p>
+          <a:p>
+            <a:pPr>
+              <a:spcAft>
+                <a:spcPts val="600"/>
+              </a:spcAft>
+              <a:defRPr sz="1400">
+                <a:solidFill>
+                  <a:srgbClr val="0B0B0B"/>
+                </a:solidFill>
+              </a:defRPr>
+            </a:pPr>
+            <a:r>
+              <a:t>• Gang scheduling (Kueue) and topology labels (NVLink clique, fabric block) place jobs where the fast path exists</a:t>
+            </a:r>
+          </a:p>
+          <a:p>
+            <a:pPr>
+              <a:spcAft>
+                <a:spcPts val="600"/>
+              </a:spcAft>
+              <a:defRPr sz="1400">
+                <a:solidFill>
+                  <a:srgbClr val="0B0B0B"/>
+                </a:solidFill>
+              </a:defRPr>
+            </a:pPr>
+            <a:r>
+              <a:t>• Rack-scale: multi-node NVLink inside the clique, the rails between racks; floors are calibrated per width and message size</a:t>
+            </a:r>
+          </a:p>
+        </p:txBody>
+      </p:sp>
+    </p:spTree>
+  </p:cSld>
+  <p:clrMapOvr>
+    <a:masterClrMapping/>
+  </p:clrMapOvr>
+</p:sld>
+</file>
+
+<file path=ppt/slides/slide12.xml><?xml version="1.0" encoding="utf-8"?>
+<p:sld xmlns:a="http://schemas.openxmlformats.org/drawingml/2006/main" xmlns:p="http://schemas.openxmlformats.org/presentationml/2006/main" xmlns:r="http://schemas.openxmlformats.org/officeDocument/2006/relationships">
+  <p:cSld>
+    <p:spTree>
+      <p:nvGrpSpPr>
+        <p:cNvPr id="1" name=""/>
+        <p:cNvGrpSpPr/>
+        <p:nvPr/>
+      </p:nvGrpSpPr>
+      <p:grpSpPr/>
+      <p:sp>
+        <p:nvSpPr>
+          <p:cNvPr id="2" name="TextBox 1"/>
+          <p:cNvSpPr txBox="1"/>
+          <p:nvPr/>
+        </p:nvSpPr>
+        <p:spPr>
+          <a:xfrm>
+            <a:off x="457200" y="274320"/>
+            <a:ext cx="11247120" cy="822960"/>
+          </a:xfrm>
+          <a:prstGeom prst="rect">
+            <a:avLst/>
+          </a:prstGeom>
+          <a:noFill/>
+        </p:spPr>
+        <p:txBody>
+          <a:bodyPr wrap="none">
+            <a:spAutoFit/>
+          </a:bodyPr>
+          <a:lstStyle/>
+          <a:p>
+            <a:pPr>
+              <a:defRPr sz="2600" b="1">
+                <a:solidFill>
+                  <a:srgbClr val="0B0B0B"/>
+                </a:solidFill>
+              </a:defRPr>
+            </a:pPr>
+            <a:r>
+              <a:t>Live demo plan (docs/demo.md)</a:t>
+            </a:r>
+          </a:p>
+        </p:txBody>
+      </p:sp>
+      <p:sp>
+        <p:nvSpPr>
+          <p:cNvPr id="3" name="TextBox 2"/>
+          <p:cNvSpPr txBox="1"/>
+          <p:nvPr/>
+        </p:nvSpPr>
+        <p:spPr>
+          <a:xfrm>
+            <a:off x="548640" y="1188720"/>
+            <a:ext cx="10972800" cy="5029200"/>
+          </a:xfrm>
+          <a:prstGeom prst="rect">
+            <a:avLst/>
+          </a:prstGeom>
+          <a:noFill/>
+        </p:spPr>
+        <p:txBody>
+          <a:bodyPr wrap="square">
+            <a:spAutoFit/>
+          </a:bodyPr>
+          <a:lstStyle/>
+          <a:p>
+            <a:pPr>
+              <a:spcAft>
+                <a:spcPts val="600"/>
+              </a:spcAft>
+              <a:defRPr sz="1400">
+                <a:solidFill>
+                  <a:srgbClr val="0B0B0B"/>
+                </a:solidFill>
+              </a:defRPr>
+            </a:pPr>
+            <a:r>
+              <a:t>• Bring-up (~7 min, talk over it): preflight 45 s → k8s-up ~4 min → GPU Operator in DRA mode ~1.5 min → dranet fork + DeviceClass ~1 min</a:t>
+            </a:r>
+          </a:p>
+          <a:p>
+            <a:pPr>
+              <a:spcAft>
+                <a:spcPts val="600"/>
+              </a:spcAft>
+              <a:defRPr sz="1400">
+                <a:solidFill>
+                  <a:srgbClr val="0B0B0B"/>
+                </a:solidFill>
+              </a:defRPr>
+            </a:pPr>
+            <a:r>
+              <a:t>• Probe (~1 min warm): host GID table vs pod GID table, host still owns the VF, pingpong on the discovered GID</a:t>
+            </a:r>
+          </a:p>
+          <a:p>
+            <a:pPr>
+              <a:spcAft>
+                <a:spcPts val="600"/>
+              </a:spcAft>
+              <a:defRPr sz="1400">
+                <a:solidFill>
+                  <a:srgbClr val="0B0B0B"/>
+                </a:solidFill>
+              </a:defRPr>
+            </a:pPr>
+            <a:r>
+              <a:t>• Three counter-window cells (~1 min each): NVLink, 4 rails, 1 rail — watched live on the fabric dashboard</a:t>
+            </a:r>
+          </a:p>
+          <a:p>
+            <a:pPr>
+              <a:spcAft>
+                <a:spcPts val="600"/>
+              </a:spcAft>
+              <a:defRPr sz="1400">
+                <a:solidFill>
+                  <a:srgbClr val="0B0B0B"/>
+                </a:solidFill>
+              </a:defRPr>
+            </a:pPr>
+            <a:r>
+              <a:t>• Dashboard tour: NVLink bytes per GPU → rails at ~480 Gb/s each → flat CNP/ECN/out-of-sequence → TCP cells show up only on the management NIC and host CPU</a:t>
+            </a:r>
+          </a:p>
+          <a:p>
+            <a:pPr>
+              <a:spcAft>
+                <a:spcPts val="600"/>
+              </a:spcAft>
+              <a:defRPr sz="1400">
+                <a:solidFill>
+                  <a:srgbClr val="0B0B0B"/>
+                </a:solidFill>
+              </a:defRPr>
+            </a:pPr>
+            <a:r>
+              <a:t>• Fallback: everything in results/ is committed and regenerable (make analyze); teardown k8s-down ~3 min, trays verified clean</a:t>
+            </a:r>
+          </a:p>
+        </p:txBody>
+      </p:sp>
+    </p:spTree>
+  </p:cSld>
+  <p:clrMapOvr>
+    <a:masterClrMapping/>
+  </p:clrMapOvr>
+</p:sld>
+</file>
+
 <file path=ppt/slides/slide2.xml><?xml version="1.0" encoding="utf-8"?>
 <p:sld xmlns:a="http://schemas.openxmlformats.org/drawingml/2006/main" xmlns:p="http://schemas.openxmlformats.org/presentationml/2006/main" xmlns:r="http://schemas.openxmlformats.org/officeDocument/2006/relationships">
   <p:cSld>
@@ -3318,6 +4486,278 @@
 </file>
 
 <file path=ppt/slides/slide3.xml><?xml version="1.0" encoding="utf-8"?>
+<p:sld xmlns:a="http://schemas.openxmlformats.org/drawingml/2006/main" xmlns:p="http://schemas.openxmlformats.org/presentationml/2006/main" xmlns:r="http://schemas.openxmlformats.org/officeDocument/2006/relationships">
+  <p:cSld>
+    <p:spTree>
+      <p:nvGrpSpPr>
+        <p:cNvPr id="1" name=""/>
+        <p:cNvGrpSpPr/>
+        <p:nvPr/>
+      </p:nvGrpSpPr>
+      <p:grpSpPr/>
+      <p:sp>
+        <p:nvSpPr>
+          <p:cNvPr id="2" name="TextBox 1"/>
+          <p:cNvSpPr txBox="1"/>
+          <p:nvPr/>
+        </p:nvSpPr>
+        <p:spPr>
+          <a:xfrm>
+            <a:off x="457200" y="274320"/>
+            <a:ext cx="11247120" cy="822960"/>
+          </a:xfrm>
+          <a:prstGeom prst="rect">
+            <a:avLst/>
+          </a:prstGeom>
+          <a:noFill/>
+        </p:spPr>
+        <p:txBody>
+          <a:bodyPr wrap="none">
+            <a:spAutoFit/>
+          </a:bodyPr>
+          <a:lstStyle/>
+          <a:p>
+            <a:pPr>
+              <a:defRPr sz="2600" b="1">
+                <a:solidFill>
+                  <a:srgbClr val="0B0B0B"/>
+                </a:solidFill>
+              </a:defRPr>
+            </a:pPr>
+            <a:r>
+              <a:t>1 · Why DRA, why dranet (the fork), why Cilium</a:t>
+            </a:r>
+          </a:p>
+        </p:txBody>
+      </p:sp>
+      <p:sp>
+        <p:nvSpPr>
+          <p:cNvPr id="3" name="TextBox 2"/>
+          <p:cNvSpPr txBox="1"/>
+          <p:nvPr/>
+        </p:nvSpPr>
+        <p:spPr>
+          <a:xfrm>
+            <a:off x="548640" y="1188720"/>
+            <a:ext cx="10972800" cy="5029200"/>
+          </a:xfrm>
+          <a:prstGeom prst="rect">
+            <a:avLst/>
+          </a:prstGeom>
+          <a:noFill/>
+        </p:spPr>
+        <p:txBody>
+          <a:bodyPr wrap="square">
+            <a:spAutoFit/>
+          </a:bodyPr>
+          <a:lstStyle/>
+          <a:p>
+            <a:pPr>
+              <a:spcAft>
+                <a:spcPts val="600"/>
+              </a:spcAft>
+              <a:defRPr sz="1400">
+                <a:solidFill>
+                  <a:srgbClr val="0B0B0B"/>
+                </a:solidFill>
+              </a:defRPr>
+            </a:pPr>
+            <a:r>
+              <a:t>• DRA (GA in Kubernetes 1.34): GPUs and NICs are structured devices with attributes; a ResourceClaim per pod against a DeviceClass — one mechanism for both device kinds, visible to the scheduler</a:t>
+            </a:r>
+          </a:p>
+          <a:p>
+            <a:pPr>
+              <a:spcAft>
+                <a:spcPts val="600"/>
+              </a:spcAft>
+              <a:defRPr sz="1400">
+                <a:solidFill>
+                  <a:srgbClr val="0B0B0B"/>
+                </a:solidFill>
+              </a:defRPr>
+            </a:pPr>
+            <a:r>
+              <a:t>• dranet upstream moves the NIC into the pod; on this site that drains the tray (host health check inventories the rails). The fork adds IPVLAN children: the VF stays on the host, the pod gets a child with its own SLAAC address, RDMA reached in shared netns mode — no hostNetwork, no privilege, host inventory unchanged</a:t>
+            </a:r>
+          </a:p>
+          <a:p>
+            <a:pPr>
+              <a:spcAft>
+                <a:spcPts val="600"/>
+              </a:spcAft>
+              <a:defRPr sz="1400">
+                <a:solidFill>
+                  <a:srgbClr val="0B0B0B"/>
+                </a:solidFill>
+              </a:defRPr>
+            </a:pPr>
+            <a:r>
+              <a:t>• Shared RDMA netns mode can only be set with no pod namespace alive → the bootstrap sets it on the fresh tray before k3s and restores it at teardown (do-no-harm on borrowed hardware)</a:t>
+            </a:r>
+          </a:p>
+          <a:p>
+            <a:pPr>
+              <a:spcAft>
+                <a:spcPts val="600"/>
+              </a:spcAft>
+              <a:defRPr sz="1400">
+                <a:solidFill>
+                  <a:srgbClr val="0B0B0B"/>
+                </a:solidFill>
+              </a:defRPr>
+            </a:pPr>
+            <a:r>
+              <a:t>• Cilium 1.20: eBPF kube-proxy replacement (no iptables churn on a host whose health check watches routes), geneve tunnel on the management NIC (site never learns pod CIDRs, no BGP, no LB IPs), Hubble for flow evidence — and the data plane never touches it</a:t>
+            </a:r>
+          </a:p>
+        </p:txBody>
+      </p:sp>
+    </p:spTree>
+  </p:cSld>
+  <p:clrMapOvr>
+    <a:masterClrMapping/>
+  </p:clrMapOvr>
+</p:sld>
+</file>
+
+<file path=ppt/slides/slide4.xml><?xml version="1.0" encoding="utf-8"?>
+<p:sld xmlns:a="http://schemas.openxmlformats.org/drawingml/2006/main" xmlns:p="http://schemas.openxmlformats.org/presentationml/2006/main" xmlns:r="http://schemas.openxmlformats.org/officeDocument/2006/relationships">
+  <p:cSld>
+    <p:spTree>
+      <p:nvGrpSpPr>
+        <p:cNvPr id="1" name=""/>
+        <p:cNvGrpSpPr/>
+        <p:nvPr/>
+      </p:nvGrpSpPr>
+      <p:grpSpPr/>
+      <p:sp>
+        <p:nvSpPr>
+          <p:cNvPr id="2" name="TextBox 1"/>
+          <p:cNvSpPr txBox="1"/>
+          <p:nvPr/>
+        </p:nvSpPr>
+        <p:spPr>
+          <a:xfrm>
+            <a:off x="457200" y="274320"/>
+            <a:ext cx="11247120" cy="822960"/>
+          </a:xfrm>
+          <a:prstGeom prst="rect">
+            <a:avLst/>
+          </a:prstGeom>
+          <a:noFill/>
+        </p:spPr>
+        <p:txBody>
+          <a:bodyPr wrap="none">
+            <a:spAutoFit/>
+          </a:bodyPr>
+          <a:lstStyle/>
+          <a:p>
+            <a:pPr>
+              <a:defRPr sz="2600" b="1">
+                <a:solidFill>
+                  <a:srgbClr val="0B0B0B"/>
+                </a:solidFill>
+              </a:defRPr>
+            </a:pPr>
+            <a:r>
+              <a:t>1 · The RoCE GID index: discovered, not assumed</a:t>
+            </a:r>
+          </a:p>
+        </p:txBody>
+      </p:sp>
+      <p:sp>
+        <p:nvSpPr>
+          <p:cNvPr id="3" name="TextBox 2"/>
+          <p:cNvSpPr txBox="1"/>
+          <p:nvPr/>
+        </p:nvSpPr>
+        <p:spPr>
+          <a:xfrm>
+            <a:off x="548640" y="1188720"/>
+            <a:ext cx="10972800" cy="5029200"/>
+          </a:xfrm>
+          <a:prstGeom prst="rect">
+            <a:avLst/>
+          </a:prstGeom>
+          <a:noFill/>
+        </p:spPr>
+        <p:txBody>
+          <a:bodyPr wrap="square">
+            <a:spAutoFit/>
+          </a:bodyPr>
+          <a:lstStyle/>
+          <a:p>
+            <a:pPr>
+              <a:spcAft>
+                <a:spcPts val="600"/>
+              </a:spcAft>
+              <a:defRPr sz="1400">
+                <a:solidFill>
+                  <a:srgbClr val="0B0B0B"/>
+                </a:solidFill>
+              </a:defRPr>
+            </a:pPr>
+            <a:r>
+              <a:t>• GID table = two entries per IP address (RoCE v1, RoCE v2): link-local at 0/1, the VF's global at 2/3 → index 3 on the host</a:t>
+            </a:r>
+          </a:p>
+          <a:p>
+            <a:pPr>
+              <a:spcAft>
+                <a:spcPts val="600"/>
+              </a:spcAft>
+              <a:defRPr sz="1400">
+                <a:solidFill>
+                  <a:srgbClr val="0B0B0B"/>
+                </a:solidFill>
+              </a:defRPr>
+            </a:pPr>
+            <a:r>
+              <a:t>• In the pod the IPVLAN child's addresses land at 4–7 (namespace-scoped view) → index 7; a second pod on the same rail would be 11</a:t>
+            </a:r>
+          </a:p>
+          <a:p>
+            <a:pPr>
+              <a:spcAft>
+                <a:spcPts val="600"/>
+              </a:spcAft>
+              <a:defRPr sz="1400">
+                <a:solidFill>
+                  <a:srgbClr val="0B0B0B"/>
+                </a:solidFill>
+              </a:defRPr>
+            </a:pPr>
+            <a:r>
+              <a:t>• bench/gid.py: only HCAs whose uverbs char device is in the pod; RoCE v2 + global; every claimed rail must agree; exported as NCCL_IB_GID_INDEX by the pre-check after a router solicitation (a fresh child has link-local only)</a:t>
+            </a:r>
+          </a:p>
+          <a:p>
+            <a:pPr>
+              <a:spcAft>
+                <a:spcPts val="600"/>
+              </a:spcAft>
+              <a:defRPr sz="1400">
+                <a:solidFill>
+                  <a:srgbClr val="0B0B0B"/>
+                </a:solidFill>
+              </a:defRPr>
+            </a:pPr>
+            <a:r>
+              <a:t>• Wrong index = QP connect failures or a connected communicator moving zero bytes; ibv_rc_pingpong on index 7: 12–15 µs at 4 KiB, ~120 µs per 1 MiB round trip</a:t>
+            </a:r>
+          </a:p>
+        </p:txBody>
+      </p:sp>
+    </p:spTree>
+  </p:cSld>
+  <p:clrMapOvr>
+    <a:masterClrMapping/>
+  </p:clrMapOvr>
+</p:sld>
+</file>
+
+<file path=ppt/slides/slide5.xml><?xml version="1.0" encoding="utf-8"?>
 <p:sld xmlns:a="http://schemas.openxmlformats.org/drawingml/2006/main" xmlns:p="http://schemas.openxmlformats.org/presentationml/2006/main" xmlns:r="http://schemas.openxmlformats.org/officeDocument/2006/relationships">
   <p:cSld>
     <p:spTree>
@@ -3938,7 +5378,7 @@
 </p:sld>
 </file>
 
-<file path=ppt/slides/slide4.xml><?xml version="1.0" encoding="utf-8"?>
+<file path=ppt/slides/slide6.xml><?xml version="1.0" encoding="utf-8"?>
 <p:sld xmlns:a="http://schemas.openxmlformats.org/drawingml/2006/main" xmlns:p="http://schemas.openxmlformats.org/presentationml/2006/main" xmlns:r="http://schemas.openxmlformats.org/officeDocument/2006/relationships">
   <p:cSld>
     <p:spTree>
@@ -4324,7 +5764,7 @@
 </p:sld>
 </file>
 
-<file path=ppt/slides/slide5.xml><?xml version="1.0" encoding="utf-8"?>
+<file path=ppt/slides/slide7.xml><?xml version="1.0" encoding="utf-8"?>
 <p:sld xmlns:a="http://schemas.openxmlformats.org/drawingml/2006/main" xmlns:p="http://schemas.openxmlformats.org/presentationml/2006/main" xmlns:r="http://schemas.openxmlformats.org/officeDocument/2006/relationships">
   <p:cSld>
     <p:spTree>
@@ -5567,7 +7007,7 @@
 </p:sld>
 </file>
 
-<file path=ppt/slides/slide6.xml><?xml version="1.0" encoding="utf-8"?>
+<file path=ppt/slides/slide8.xml><?xml version="1.0" encoding="utf-8"?>
 <p:sld xmlns:a="http://schemas.openxmlformats.org/drawingml/2006/main" xmlns:p="http://schemas.openxmlformats.org/presentationml/2006/main" xmlns:r="http://schemas.openxmlformats.org/officeDocument/2006/relationships">
   <p:cSld>
     <p:spTree>
@@ -6127,7 +7567,7 @@
 </p:sld>
 </file>
 
-<file path=ppt/slides/slide7.xml><?xml version="1.0" encoding="utf-8"?>
+<file path=ppt/slides/slide9.xml><?xml version="1.0" encoding="utf-8"?>
 <p:sld xmlns:a="http://schemas.openxmlformats.org/drawingml/2006/main" xmlns:p="http://schemas.openxmlformats.org/presentationml/2006/main" xmlns:r="http://schemas.openxmlformats.org/officeDocument/2006/relationships">
   <p:cSld>
     <p:spTree>
@@ -7240,1020 +8680,6 @@
           </a:graphicData>
         </a:graphic>
       </p:graphicFrame>
-    </p:spTree>
-  </p:cSld>
-  <p:clrMapOvr>
-    <a:masterClrMapping/>
-  </p:clrMapOvr>
-</p:sld>
-</file>
-
-<file path=ppt/slides/slide8.xml><?xml version="1.0" encoding="utf-8"?>
-<p:sld xmlns:a="http://schemas.openxmlformats.org/drawingml/2006/main" xmlns:p="http://schemas.openxmlformats.org/presentationml/2006/main" xmlns:r="http://schemas.openxmlformats.org/officeDocument/2006/relationships">
-  <p:cSld>
-    <p:spTree>
-      <p:nvGrpSpPr>
-        <p:cNvPr id="1" name=""/>
-        <p:cNvGrpSpPr/>
-        <p:nvPr/>
-      </p:nvGrpSpPr>
-      <p:grpSpPr/>
-      <p:sp>
-        <p:nvSpPr>
-          <p:cNvPr id="2" name="TextBox 1"/>
-          <p:cNvSpPr txBox="1"/>
-          <p:nvPr/>
-        </p:nvSpPr>
-        <p:spPr>
-          <a:xfrm>
-            <a:off x="457200" y="274320"/>
-            <a:ext cx="11247120" cy="822960"/>
-          </a:xfrm>
-          <a:prstGeom prst="rect">
-            <a:avLst/>
-          </a:prstGeom>
-          <a:noFill/>
-        </p:spPr>
-        <p:txBody>
-          <a:bodyPr wrap="none">
-            <a:spAutoFit/>
-          </a:bodyPr>
-          <a:lstStyle/>
-          <a:p>
-            <a:pPr>
-              <a:defRPr sz="2600" b="1">
-                <a:solidFill>
-                  <a:srgbClr val="0B0B0B"/>
-                </a:solidFill>
-              </a:defRPr>
-            </a:pPr>
-            <a:r>
-              <a:t>5 · Sensitivity appendix</a:t>
-            </a:r>
-          </a:p>
-        </p:txBody>
-      </p:sp>
-      <p:sp>
-        <p:nvSpPr>
-          <p:cNvPr id="3" name="TextBox 2"/>
-          <p:cNvSpPr txBox="1"/>
-          <p:nvPr/>
-        </p:nvSpPr>
-        <p:spPr>
-          <a:xfrm>
-            <a:off x="548640" y="1188720"/>
-            <a:ext cx="5486400" cy="5029200"/>
-          </a:xfrm>
-          <a:prstGeom prst="rect">
-            <a:avLst/>
-          </a:prstGeom>
-          <a:noFill/>
-        </p:spPr>
-        <p:txBody>
-          <a:bodyPr wrap="square">
-            <a:spAutoFit/>
-          </a:bodyPr>
-          <a:lstStyle/>
-          <a:p>
-            <a:pPr>
-              <a:spcAft>
-                <a:spcPts val="600"/>
-              </a:spcAft>
-              <a:defRPr sz="1400">
-                <a:solidFill>
-                  <a:srgbClr val="0B0B0B"/>
-                </a:solidFill>
-              </a:defRPr>
-            </a:pPr>
-            <a:r>
-              <a:t>• GPUDirect off (−38 %, same bytes on the wire, 1.6× the time), buffer sizes (noise), NVLS vs Ring on NVLink (474 vs 388 GB/s algbw), Tree invalid for the all-gather, socket threads (7× on TCP)</a:t>
-            </a:r>
-          </a:p>
-          <a:p>
-            <a:pPr>
-              <a:spcAft>
-                <a:spcPts val="600"/>
-              </a:spcAft>
-              <a:defRPr sz="1400">
-                <a:solidFill>
-                  <a:srgbClr val="0B0B0B"/>
-                </a:solidFill>
-              </a:defRPr>
-            </a:pPr>
-            <a:r>
-              <a:t>• DDP bucket 25 → 200 MiB over the rails: 2090 → 2769 samples/s (+32 %), comm fraction 91 % → 32 % — change how often you talk before how you talk</a:t>
-            </a:r>
-          </a:p>
-        </p:txBody>
-      </p:sp>
-      <p:graphicFrame>
-        <p:nvGraphicFramePr>
-          <p:cNvPr id="4" name="Table 3"/>
-          <p:cNvGraphicFramePr>
-            <a:graphicFrameLocks noGrp="1"/>
-          </p:cNvGraphicFramePr>
-          <p:nvPr/>
-        </p:nvGraphicFramePr>
-        <p:xfrm>
-          <a:off x="6217920" y="1188720"/>
-          <a:ext cx="5486400" cy="3291839"/>
-        </p:xfrm>
-        <a:graphic>
-          <a:graphicData uri="http://schemas.openxmlformats.org/drawingml/2006/table">
-            <a:tbl>
-              <a:tblPr firstRow="1" bandRow="1">
-                <a:tableStyleId>{5C22544A-7EE6-4342-B048-85BDC9FD1C3A}</a:tableStyleId>
-              </a:tblPr>
-              <a:tblGrid>
-                <a:gridCol w="1371600"/>
-                <a:gridCol w="1371600"/>
-                <a:gridCol w="1371600"/>
-                <a:gridCol w="1371600"/>
-              </a:tblGrid>
-              <a:tr h="274319">
-                <a:tc>
-                  <a:txBody>
-                    <a:bodyPr/>
-                    <a:lstStyle/>
-                    <a:p>
-                      <a:pPr>
-                        <a:defRPr sz="900" b="1"/>
-                      </a:pPr>
-                      <a:r>
-                        <a:t>run_id</a:t>
-                      </a:r>
-                    </a:p>
-                  </a:txBody>
-                  <a:tcPr/>
-                </a:tc>
-                <a:tc>
-                  <a:txBody>
-                    <a:bodyPr/>
-                    <a:lstStyle/>
-                    <a:p>
-                      <a:pPr>
-                        <a:defRPr sz="900" b="1"/>
-                      </a:pPr>
-                      <a:r>
-                        <a:t>16MiB</a:t>
-                      </a:r>
-                    </a:p>
-                  </a:txBody>
-                  <a:tcPr/>
-                </a:tc>
-                <a:tc>
-                  <a:txBody>
-                    <a:bodyPr/>
-                    <a:lstStyle/>
-                    <a:p>
-                      <a:pPr>
-                        <a:defRPr sz="900" b="1"/>
-                      </a:pPr>
-                      <a:r>
-                        <a:t>512MiB</a:t>
-                      </a:r>
-                    </a:p>
-                  </a:txBody>
-                  <a:tcPr/>
-                </a:tc>
-                <a:tc>
-                  <a:txBody>
-                    <a:bodyPr/>
-                    <a:lstStyle/>
-                    <a:p>
-                      <a:pPr>
-                        <a:defRPr sz="900" b="1"/>
-                      </a:pPr>
-                      <a:r>
-                        <a:t>4GiB</a:t>
-                      </a:r>
-                    </a:p>
-                  </a:txBody>
-                  <a:tcPr/>
-                </a:tc>
-              </a:tr>
-              <a:tr h="274319">
-                <a:tc>
-                  <a:txBody>
-                    <a:bodyPr/>
-                    <a:lstStyle/>
-                    <a:p>
-                      <a:pPr>
-                        <a:defRPr sz="900"/>
-                      </a:pPr>
-                      <a:r>
-                        <a:t>e5-algo-nvls</a:t>
-                      </a:r>
-                    </a:p>
-                  </a:txBody>
-                  <a:tcPr/>
-                </a:tc>
-                <a:tc>
-                  <a:txBody>
-                    <a:bodyPr/>
-                    <a:lstStyle/>
-                    <a:p>
-                      <a:pPr>
-                        <a:defRPr sz="900"/>
-                      </a:pPr>
-                      <a:r>
-                        <a:t>297</a:t>
-                      </a:r>
-                    </a:p>
-                  </a:txBody>
-                  <a:tcPr/>
-                </a:tc>
-                <a:tc>
-                  <a:txBody>
-                    <a:bodyPr/>
-                    <a:lstStyle/>
-                    <a:p>
-                      <a:pPr>
-                        <a:defRPr sz="900"/>
-                      </a:pPr>
-                      <a:r>
-                        <a:t>695</a:t>
-                      </a:r>
-                    </a:p>
-                  </a:txBody>
-                  <a:tcPr/>
-                </a:tc>
-                <a:tc>
-                  <a:txBody>
-                    <a:bodyPr/>
-                    <a:lstStyle/>
-                    <a:p>
-                      <a:pPr>
-                        <a:defRPr sz="900"/>
-                      </a:pPr>
-                      <a:r>
-                        <a:t>830</a:t>
-                      </a:r>
-                    </a:p>
-                  </a:txBody>
-                  <a:tcPr/>
-                </a:tc>
-              </a:tr>
-              <a:tr h="274319">
-                <a:tc>
-                  <a:txBody>
-                    <a:bodyPr/>
-                    <a:lstStyle/>
-                    <a:p>
-                      <a:pPr>
-                        <a:defRPr sz="900"/>
-                      </a:pPr>
-                      <a:r>
-                        <a:t>e5-algo-ring</a:t>
-                      </a:r>
-                    </a:p>
-                  </a:txBody>
-                  <a:tcPr/>
-                </a:tc>
-                <a:tc>
-                  <a:txBody>
-                    <a:bodyPr/>
-                    <a:lstStyle/>
-                    <a:p>
-                      <a:pPr>
-                        <a:defRPr sz="900"/>
-                      </a:pPr>
-                      <a:r>
-                        <a:t>327</a:t>
-                      </a:r>
-                    </a:p>
-                  </a:txBody>
-                  <a:tcPr/>
-                </a:tc>
-                <a:tc>
-                  <a:txBody>
-                    <a:bodyPr/>
-                    <a:lstStyle/>
-                    <a:p>
-                      <a:pPr>
-                        <a:defRPr sz="900"/>
-                      </a:pPr>
-                      <a:r>
-                        <a:t>635</a:t>
-                      </a:r>
-                    </a:p>
-                  </a:txBody>
-                  <a:tcPr/>
-                </a:tc>
-                <a:tc>
-                  <a:txBody>
-                    <a:bodyPr/>
-                    <a:lstStyle/>
-                    <a:p>
-                      <a:pPr>
-                        <a:defRPr sz="900"/>
-                      </a:pPr>
-                      <a:r>
-                        <a:t>679</a:t>
-                      </a:r>
-                    </a:p>
-                  </a:txBody>
-                  <a:tcPr/>
-                </a:tc>
-              </a:tr>
-              <a:tr h="274319">
-                <a:tc>
-                  <a:txBody>
-                    <a:bodyPr/>
-                    <a:lstStyle/>
-                    <a:p>
-                      <a:pPr>
-                        <a:defRPr sz="900"/>
-                      </a:pPr>
-                      <a:r>
-                        <a:t>e5-buffsize16m</a:t>
-                      </a:r>
-                    </a:p>
-                  </a:txBody>
-                  <a:tcPr/>
-                </a:tc>
-                <a:tc>
-                  <a:txBody>
-                    <a:bodyPr/>
-                    <a:lstStyle/>
-                    <a:p>
-                      <a:pPr>
-                        <a:defRPr sz="900"/>
-                      </a:pPr>
-                      <a:r>
-                        <a:t>101</a:t>
-                      </a:r>
-                    </a:p>
-                  </a:txBody>
-                  <a:tcPr/>
-                </a:tc>
-                <a:tc>
-                  <a:txBody>
-                    <a:bodyPr/>
-                    <a:lstStyle/>
-                    <a:p>
-                      <a:pPr>
-                        <a:defRPr sz="900"/>
-                      </a:pPr>
-                      <a:r>
-                        <a:t>420</a:t>
-                      </a:r>
-                    </a:p>
-                  </a:txBody>
-                  <a:tcPr/>
-                </a:tc>
-                <a:tc>
-                  <a:txBody>
-                    <a:bodyPr/>
-                    <a:lstStyle/>
-                    <a:p>
-                      <a:pPr>
-                        <a:defRPr sz="900"/>
-                      </a:pPr>
-                      <a:r>
-                        <a:t>393</a:t>
-                      </a:r>
-                    </a:p>
-                  </a:txBody>
-                  <a:tcPr/>
-                </a:tc>
-              </a:tr>
-              <a:tr h="274319">
-                <a:tc>
-                  <a:txBody>
-                    <a:bodyPr/>
-                    <a:lstStyle/>
-                    <a:p>
-                      <a:pPr>
-                        <a:defRPr sz="900"/>
-                      </a:pPr>
-                      <a:r>
-                        <a:t>e5-buffsize4m</a:t>
-                      </a:r>
-                    </a:p>
-                  </a:txBody>
-                  <a:tcPr/>
-                </a:tc>
-                <a:tc>
-                  <a:txBody>
-                    <a:bodyPr/>
-                    <a:lstStyle/>
-                    <a:p>
-                      <a:pPr>
-                        <a:defRPr sz="900"/>
-                      </a:pPr>
-                      <a:r>
-                        <a:t>102</a:t>
-                      </a:r>
-                    </a:p>
-                  </a:txBody>
-                  <a:tcPr/>
-                </a:tc>
-                <a:tc>
-                  <a:txBody>
-                    <a:bodyPr/>
-                    <a:lstStyle/>
-                    <a:p>
-                      <a:pPr>
-                        <a:defRPr sz="900"/>
-                      </a:pPr>
-                      <a:r>
-                        <a:t>402</a:t>
-                      </a:r>
-                    </a:p>
-                  </a:txBody>
-                  <a:tcPr/>
-                </a:tc>
-                <a:tc>
-                  <a:txBody>
-                    <a:bodyPr/>
-                    <a:lstStyle/>
-                    <a:p>
-                      <a:pPr>
-                        <a:defRPr sz="900"/>
-                      </a:pPr>
-                      <a:r>
-                        <a:t>419</a:t>
-                      </a:r>
-                    </a:p>
-                  </a:txBody>
-                  <a:tcPr/>
-                </a:tc>
-              </a:tr>
-              <a:tr h="274319">
-                <a:tc>
-                  <a:txBody>
-                    <a:bodyPr/>
-                    <a:lstStyle/>
-                    <a:p>
-                      <a:pPr>
-                        <a:defRPr sz="900"/>
-                      </a:pPr>
-                      <a:r>
-                        <a:t>e5-counters-gdr-off</a:t>
-                      </a:r>
-                    </a:p>
-                  </a:txBody>
-                  <a:tcPr/>
-                </a:tc>
-                <a:tc>
-                  <a:txBody>
-                    <a:bodyPr/>
-                    <a:lstStyle/>
-                    <a:p>
-                      <a:pPr>
-                        <a:defRPr sz="900"/>
-                      </a:pPr>
-                      <a:r>
-                        <a:t>nan</a:t>
-                      </a:r>
-                    </a:p>
-                  </a:txBody>
-                  <a:tcPr/>
-                </a:tc>
-                <a:tc>
-                  <a:txBody>
-                    <a:bodyPr/>
-                    <a:lstStyle/>
-                    <a:p>
-                      <a:pPr>
-                        <a:defRPr sz="900"/>
-                      </a:pPr>
-                      <a:r>
-                        <a:t>nan</a:t>
-                      </a:r>
-                    </a:p>
-                  </a:txBody>
-                  <a:tcPr/>
-                </a:tc>
-                <a:tc>
-                  <a:txBody>
-                    <a:bodyPr/>
-                    <a:lstStyle/>
-                    <a:p>
-                      <a:pPr>
-                        <a:defRPr sz="900"/>
-                      </a:pPr>
-                      <a:r>
-                        <a:t>253</a:t>
-                      </a:r>
-                    </a:p>
-                  </a:txBody>
-                  <a:tcPr/>
-                </a:tc>
-              </a:tr>
-              <a:tr h="274319">
-                <a:tc>
-                  <a:txBody>
-                    <a:bodyPr/>
-                    <a:lstStyle/>
-                    <a:p>
-                      <a:pPr>
-                        <a:defRPr sz="900"/>
-                      </a:pPr>
-                      <a:r>
-                        <a:t>e5-counters-nvlink</a:t>
-                      </a:r>
-                    </a:p>
-                  </a:txBody>
-                  <a:tcPr/>
-                </a:tc>
-                <a:tc>
-                  <a:txBody>
-                    <a:bodyPr/>
-                    <a:lstStyle/>
-                    <a:p>
-                      <a:pPr>
-                        <a:defRPr sz="900"/>
-                      </a:pPr>
-                      <a:r>
-                        <a:t>nan</a:t>
-                      </a:r>
-                    </a:p>
-                  </a:txBody>
-                  <a:tcPr/>
-                </a:tc>
-                <a:tc>
-                  <a:txBody>
-                    <a:bodyPr/>
-                    <a:lstStyle/>
-                    <a:p>
-                      <a:pPr>
-                        <a:defRPr sz="900"/>
-                      </a:pPr>
-                      <a:r>
-                        <a:t>nan</a:t>
-                      </a:r>
-                    </a:p>
-                  </a:txBody>
-                  <a:tcPr/>
-                </a:tc>
-                <a:tc>
-                  <a:txBody>
-                    <a:bodyPr/>
-                    <a:lstStyle/>
-                    <a:p>
-                      <a:pPr>
-                        <a:defRPr sz="900"/>
-                      </a:pPr>
-                      <a:r>
-                        <a:t>833</a:t>
-                      </a:r>
-                    </a:p>
-                  </a:txBody>
-                  <a:tcPr/>
-                </a:tc>
-              </a:tr>
-              <a:tr h="274319">
-                <a:tc>
-                  <a:txBody>
-                    <a:bodyPr/>
-                    <a:lstStyle/>
-                    <a:p>
-                      <a:pPr>
-                        <a:defRPr sz="900"/>
-                      </a:pPr>
-                      <a:r>
-                        <a:t>e5-counters-rails1</a:t>
-                      </a:r>
-                    </a:p>
-                  </a:txBody>
-                  <a:tcPr/>
-                </a:tc>
-                <a:tc>
-                  <a:txBody>
-                    <a:bodyPr/>
-                    <a:lstStyle/>
-                    <a:p>
-                      <a:pPr>
-                        <a:defRPr sz="900"/>
-                      </a:pPr>
-                      <a:r>
-                        <a:t>nan</a:t>
-                      </a:r>
-                    </a:p>
-                  </a:txBody>
-                  <a:tcPr/>
-                </a:tc>
-                <a:tc>
-                  <a:txBody>
-                    <a:bodyPr/>
-                    <a:lstStyle/>
-                    <a:p>
-                      <a:pPr>
-                        <a:defRPr sz="900"/>
-                      </a:pPr>
-                      <a:r>
-                        <a:t>nan</a:t>
-                      </a:r>
-                    </a:p>
-                  </a:txBody>
-                  <a:tcPr/>
-                </a:tc>
-                <a:tc>
-                  <a:txBody>
-                    <a:bodyPr/>
-                    <a:lstStyle/>
-                    <a:p>
-                      <a:pPr>
-                        <a:defRPr sz="900"/>
-                      </a:pPr>
-                      <a:r>
-                        <a:t>87.8</a:t>
-                      </a:r>
-                    </a:p>
-                  </a:txBody>
-                  <a:tcPr/>
-                </a:tc>
-              </a:tr>
-              <a:tr h="274319">
-                <a:tc>
-                  <a:txBody>
-                    <a:bodyPr/>
-                    <a:lstStyle/>
-                    <a:p>
-                      <a:pPr>
-                        <a:defRPr sz="900"/>
-                      </a:pPr>
-                      <a:r>
-                        <a:t>e5-counters-rdma</a:t>
-                      </a:r>
-                    </a:p>
-                  </a:txBody>
-                  <a:tcPr/>
-                </a:tc>
-                <a:tc>
-                  <a:txBody>
-                    <a:bodyPr/>
-                    <a:lstStyle/>
-                    <a:p>
-                      <a:pPr>
-                        <a:defRPr sz="900"/>
-                      </a:pPr>
-                      <a:r>
-                        <a:t>nan</a:t>
-                      </a:r>
-                    </a:p>
-                  </a:txBody>
-                  <a:tcPr/>
-                </a:tc>
-                <a:tc>
-                  <a:txBody>
-                    <a:bodyPr/>
-                    <a:lstStyle/>
-                    <a:p>
-                      <a:pPr>
-                        <a:defRPr sz="900"/>
-                      </a:pPr>
-                      <a:r>
-                        <a:t>nan</a:t>
-                      </a:r>
-                    </a:p>
-                  </a:txBody>
-                  <a:tcPr/>
-                </a:tc>
-                <a:tc>
-                  <a:txBody>
-                    <a:bodyPr/>
-                    <a:lstStyle/>
-                    <a:p>
-                      <a:pPr>
-                        <a:defRPr sz="900"/>
-                      </a:pPr>
-                      <a:r>
-                        <a:t>410</a:t>
-                      </a:r>
-                    </a:p>
-                  </a:txBody>
-                  <a:tcPr/>
-                </a:tc>
-              </a:tr>
-              <a:tr h="274319">
-                <a:tc>
-                  <a:txBody>
-                    <a:bodyPr/>
-                    <a:lstStyle/>
-                    <a:p>
-                      <a:pPr>
-                        <a:defRPr sz="900"/>
-                      </a:pPr>
-                      <a:r>
-                        <a:t>e5-counters-rdma-qps4</a:t>
-                      </a:r>
-                    </a:p>
-                  </a:txBody>
-                  <a:tcPr/>
-                </a:tc>
-                <a:tc>
-                  <a:txBody>
-                    <a:bodyPr/>
-                    <a:lstStyle/>
-                    <a:p>
-                      <a:pPr>
-                        <a:defRPr sz="900"/>
-                      </a:pPr>
-                      <a:r>
-                        <a:t>nan</a:t>
-                      </a:r>
-                    </a:p>
-                  </a:txBody>
-                  <a:tcPr/>
-                </a:tc>
-                <a:tc>
-                  <a:txBody>
-                    <a:bodyPr/>
-                    <a:lstStyle/>
-                    <a:p>
-                      <a:pPr>
-                        <a:defRPr sz="900"/>
-                      </a:pPr>
-                      <a:r>
-                        <a:t>nan</a:t>
-                      </a:r>
-                    </a:p>
-                  </a:txBody>
-                  <a:tcPr/>
-                </a:tc>
-                <a:tc>
-                  <a:txBody>
-                    <a:bodyPr/>
-                    <a:lstStyle/>
-                    <a:p>
-                      <a:pPr>
-                        <a:defRPr sz="900"/>
-                      </a:pPr>
-                      <a:r>
-                        <a:t>301</a:t>
-                      </a:r>
-                    </a:p>
-                  </a:txBody>
-                  <a:tcPr/>
-                </a:tc>
-              </a:tr>
-              <a:tr h="274319">
-                <a:tc>
-                  <a:txBody>
-                    <a:bodyPr/>
-                    <a:lstStyle/>
-                    <a:p>
-                      <a:pPr>
-                        <a:defRPr sz="900"/>
-                      </a:pPr>
-                      <a:r>
-                        <a:t>e5-gdr-off</a:t>
-                      </a:r>
-                    </a:p>
-                  </a:txBody>
-                  <a:tcPr/>
-                </a:tc>
-                <a:tc>
-                  <a:txBody>
-                    <a:bodyPr/>
-                    <a:lstStyle/>
-                    <a:p>
-                      <a:pPr>
-                        <a:defRPr sz="900"/>
-                      </a:pPr>
-                      <a:r>
-                        <a:t>107</a:t>
-                      </a:r>
-                    </a:p>
-                  </a:txBody>
-                  <a:tcPr/>
-                </a:tc>
-                <a:tc>
-                  <a:txBody>
-                    <a:bodyPr/>
-                    <a:lstStyle/>
-                    <a:p>
-                      <a:pPr>
-                        <a:defRPr sz="900"/>
-                      </a:pPr>
-                      <a:r>
-                        <a:t>222</a:t>
-                      </a:r>
-                    </a:p>
-                  </a:txBody>
-                  <a:tcPr/>
-                </a:tc>
-                <a:tc>
-                  <a:txBody>
-                    <a:bodyPr/>
-                    <a:lstStyle/>
-                    <a:p>
-                      <a:pPr>
-                        <a:defRPr sz="900"/>
-                      </a:pPr>
-                      <a:r>
-                        <a:t>247</a:t>
-                      </a:r>
-                    </a:p>
-                  </a:txBody>
-                  <a:tcPr/>
-                </a:tc>
-              </a:tr>
-              <a:tr h="274330">
-                <a:tc>
-                  <a:txBody>
-                    <a:bodyPr/>
-                    <a:lstStyle/>
-                    <a:p>
-                      <a:pPr>
-                        <a:defRPr sz="900"/>
-                      </a:pPr>
-                      <a:r>
-                        <a:t>e5-sock-nthreads4</a:t>
-                      </a:r>
-                    </a:p>
-                  </a:txBody>
-                  <a:tcPr/>
-                </a:tc>
-                <a:tc>
-                  <a:txBody>
-                    <a:bodyPr/>
-                    <a:lstStyle/>
-                    <a:p>
-                      <a:pPr>
-                        <a:defRPr sz="900"/>
-                      </a:pPr>
-                      <a:r>
-                        <a:t>10.3</a:t>
-                      </a:r>
-                    </a:p>
-                  </a:txBody>
-                  <a:tcPr/>
-                </a:tc>
-                <a:tc>
-                  <a:txBody>
-                    <a:bodyPr/>
-                    <a:lstStyle/>
-                    <a:p>
-                      <a:pPr>
-                        <a:defRPr sz="900"/>
-                      </a:pPr>
-                      <a:r>
-                        <a:t>21.6</a:t>
-                      </a:r>
-                    </a:p>
-                  </a:txBody>
-                  <a:tcPr/>
-                </a:tc>
-                <a:tc>
-                  <a:txBody>
-                    <a:bodyPr/>
-                    <a:lstStyle/>
-                    <a:p>
-                      <a:pPr>
-                        <a:defRPr sz="900"/>
-                      </a:pPr>
-                      <a:r>
-                        <a:t>29.4</a:t>
-                      </a:r>
-                    </a:p>
-                  </a:txBody>
-                  <a:tcPr/>
-                </a:tc>
-              </a:tr>
-            </a:tbl>
-          </a:graphicData>
-        </a:graphic>
-      </p:graphicFrame>
-    </p:spTree>
-  </p:cSld>
-  <p:clrMapOvr>
-    <a:masterClrMapping/>
-  </p:clrMapOvr>
-</p:sld>
-</file>
-
-<file path=ppt/slides/slide9.xml><?xml version="1.0" encoding="utf-8"?>
-<p:sld xmlns:a="http://schemas.openxmlformats.org/drawingml/2006/main" xmlns:p="http://schemas.openxmlformats.org/presentationml/2006/main" xmlns:r="http://schemas.openxmlformats.org/officeDocument/2006/relationships">
-  <p:cSld>
-    <p:spTree>
-      <p:nvGrpSpPr>
-        <p:cNvPr id="1" name=""/>
-        <p:cNvGrpSpPr/>
-        <p:nvPr/>
-      </p:nvGrpSpPr>
-      <p:grpSpPr/>
-      <p:sp>
-        <p:nvSpPr>
-          <p:cNvPr id="2" name="TextBox 1"/>
-          <p:cNvSpPr txBox="1"/>
-          <p:nvPr/>
-        </p:nvSpPr>
-        <p:spPr>
-          <a:xfrm>
-            <a:off x="457200" y="274320"/>
-            <a:ext cx="11247120" cy="822960"/>
-          </a:xfrm>
-          <a:prstGeom prst="rect">
-            <a:avLst/>
-          </a:prstGeom>
-          <a:noFill/>
-        </p:spPr>
-        <p:txBody>
-          <a:bodyPr wrap="none">
-            <a:spAutoFit/>
-          </a:bodyPr>
-          <a:lstStyle/>
-          <a:p>
-            <a:pPr>
-              <a:defRPr sz="2600" b="1">
-                <a:solidFill>
-                  <a:srgbClr val="0B0B0B"/>
-                </a:solidFill>
-              </a:defRPr>
-            </a:pPr>
-            <a:r>
-              <a:t>5 · Extending to production multi-node GPU systems</a:t>
-            </a:r>
-          </a:p>
-        </p:txBody>
-      </p:sp>
-      <p:sp>
-        <p:nvSpPr>
-          <p:cNvPr id="3" name="TextBox 2"/>
-          <p:cNvSpPr txBox="1"/>
-          <p:nvPr/>
-        </p:nvSpPr>
-        <p:spPr>
-          <a:xfrm>
-            <a:off x="548640" y="1188720"/>
-            <a:ext cx="10972800" cy="5029200"/>
-          </a:xfrm>
-          <a:prstGeom prst="rect">
-            <a:avLst/>
-          </a:prstGeom>
-          <a:noFill/>
-        </p:spPr>
-        <p:txBody>
-          <a:bodyPr wrap="square">
-            <a:spAutoFit/>
-          </a:bodyPr>
-          <a:lstStyle/>
-          <a:p>
-            <a:pPr>
-              <a:spcAft>
-                <a:spcPts val="600"/>
-              </a:spcAft>
-              <a:defRPr sz="1400">
-                <a:solidFill>
-                  <a:srgbClr val="0B0B0B"/>
-                </a:solidFill>
-              </a:defRPr>
-            </a:pPr>
-            <a:r>
-              <a:t>• Same manifests scale by nnodes: one pod per tray, one claim per pod; rails per pod and GID discovery stay per-node decisions</a:t>
-            </a:r>
-          </a:p>
-          <a:p>
-            <a:pPr>
-              <a:spcAft>
-                <a:spcPts val="600"/>
-              </a:spcAft>
-              <a:defRPr sz="1400">
-                <a:solidFill>
-                  <a:srgbClr val="0B0B0B"/>
-                </a:solidFill>
-              </a:defRPr>
-            </a:pPr>
-            <a:r>
-              <a:t>• Fleet health: the counters watched here (rail bytes, CNPs, pause, NVLink errors, transport fallbacks) become alert rules; a silent NET/Socket fallback is a FAIL, not a slow run</a:t>
-            </a:r>
-          </a:p>
-          <a:p>
-            <a:pPr>
-              <a:spcAft>
-                <a:spcPts val="600"/>
-              </a:spcAft>
-              <a:defRPr sz="1400">
-                <a:solidFill>
-                  <a:srgbClr val="0B0B0B"/>
-                </a:solidFill>
-              </a:defRPr>
-            </a:pPr>
-            <a:r>
-              <a:t>• Gang scheduling (Kueue) and topology labels (NVLink clique, fabric block) place jobs where the fast path exists</a:t>
-            </a:r>
-          </a:p>
-          <a:p>
-            <a:pPr>
-              <a:spcAft>
-                <a:spcPts val="600"/>
-              </a:spcAft>
-              <a:defRPr sz="1400">
-                <a:solidFill>
-                  <a:srgbClr val="0B0B0B"/>
-                </a:solidFill>
-              </a:defRPr>
-            </a:pPr>
-            <a:r>
-              <a:t>• Rack-scale: multi-node NVLink inside the clique, the rails between racks; floors are calibrated per width and message size</a:t>
-            </a:r>
-          </a:p>
-        </p:txBody>
-      </p:sp>
     </p:spTree>
   </p:cSld>
   <p:clrMapOvr>

</xml_diff>

<commit_message>
Deck rebuilt on feedback: architecture diagram (drawn in slides/diagram.py), DRA-vs-device-plugin and dranet slide, plain-language results slides with speaker notes, GID and demo-plan slides removed; demo runbook rewritten for a general audience along the brief's five items
Co-Authored-By: Claude Fable 5.1 <noreply@anthropic.com>
</commit_message>
<xml_diff>
--- a/slides/compass.pptx
+++ b/slides/compass.pptx
@@ -7,16 +7,14 @@
   <p:sldIdLst>
     <p:sldId id="256" r:id="rId7"/>
     <p:sldId id="257" r:id="rId8"/>
-    <p:sldId id="258" r:id="rId9"/>
-    <p:sldId id="259" r:id="rId10"/>
-    <p:sldId id="260" r:id="rId11"/>
-    <p:sldId id="261" r:id="rId12"/>
-    <p:sldId id="262" r:id="rId13"/>
-    <p:sldId id="263" r:id="rId14"/>
-    <p:sldId id="264" r:id="rId15"/>
-    <p:sldId id="265" r:id="rId16"/>
-    <p:sldId id="266" r:id="rId17"/>
-    <p:sldId id="267" r:id="rId18"/>
+    <p:sldId id="258" r:id="rId10"/>
+    <p:sldId id="259" r:id="rId11"/>
+    <p:sldId id="260" r:id="rId12"/>
+    <p:sldId id="261" r:id="rId13"/>
+    <p:sldId id="262" r:id="rId14"/>
+    <p:sldId id="263" r:id="rId15"/>
+    <p:sldId id="264" r:id="rId16"/>
+    <p:sldId id="265" r:id="rId17"/>
   </p:sldIdLst>
   <p:sldSz cx="12191695" cy="6858000" type="screen4x3"/>
   <p:notesSz cx="6858000" cy="9144000"/>
@@ -116,6 +114,1102 @@
     </a:lvl9pPr>
   </p:defaultTextStyle>
 </p:presentation>
+</file>
+
+<file path=ppt/notesMasters/notesMaster1.xml><?xml version="1.0" encoding="utf-8"?>
+<p:notesMaster xmlns:a="http://schemas.openxmlformats.org/drawingml/2006/main" xmlns:p="http://schemas.openxmlformats.org/presentationml/2006/main" xmlns:r="http://schemas.openxmlformats.org/officeDocument/2006/relationships">
+  <p:cSld>
+    <p:bg>
+      <p:bgRef idx="1001">
+        <a:schemeClr val="bg1"/>
+      </p:bgRef>
+    </p:bg>
+    <p:spTree>
+      <p:nvGrpSpPr>
+        <p:cNvPr id="1" name=""/>
+        <p:cNvGrpSpPr/>
+        <p:nvPr/>
+      </p:nvGrpSpPr>
+      <p:grpSpPr>
+        <a:xfrm>
+          <a:off x="0" y="0"/>
+          <a:ext cx="0" cy="0"/>
+          <a:chOff x="0" y="0"/>
+          <a:chExt cx="0" cy="0"/>
+        </a:xfrm>
+      </p:grpSpPr>
+      <p:sp>
+        <p:nvSpPr>
+          <p:cNvPr id="2" name="Header Placeholder 1"/>
+          <p:cNvSpPr>
+            <a:spLocks noGrp="1"/>
+          </p:cNvSpPr>
+          <p:nvPr>
+            <p:ph type="hdr" sz="quarter"/>
+          </p:nvPr>
+        </p:nvSpPr>
+        <p:spPr>
+          <a:xfrm>
+            <a:off x="0" y="0"/>
+            <a:ext cx="2971800" cy="457200"/>
+          </a:xfrm>
+          <a:prstGeom prst="rect">
+            <a:avLst/>
+          </a:prstGeom>
+        </p:spPr>
+        <p:txBody>
+          <a:bodyPr vert="horz" lIns="91440" tIns="45720" rIns="91440" bIns="45720" rtlCol="0"/>
+          <a:lstStyle>
+            <a:lvl1pPr algn="l">
+              <a:defRPr sz="1200"/>
+            </a:lvl1pPr>
+          </a:lstStyle>
+          <a:p>
+            <a:endParaRPr lang="en-US"/>
+          </a:p>
+        </p:txBody>
+      </p:sp>
+      <p:sp>
+        <p:nvSpPr>
+          <p:cNvPr id="3" name="Date Placeholder 2"/>
+          <p:cNvSpPr>
+            <a:spLocks noGrp="1"/>
+          </p:cNvSpPr>
+          <p:nvPr>
+            <p:ph type="dt" idx="1"/>
+          </p:nvPr>
+        </p:nvSpPr>
+        <p:spPr>
+          <a:xfrm>
+            <a:off x="3884613" y="0"/>
+            <a:ext cx="2971800" cy="457200"/>
+          </a:xfrm>
+          <a:prstGeom prst="rect">
+            <a:avLst/>
+          </a:prstGeom>
+        </p:spPr>
+        <p:txBody>
+          <a:bodyPr vert="horz" lIns="91440" tIns="45720" rIns="91440" bIns="45720" rtlCol="0"/>
+          <a:lstStyle>
+            <a:lvl1pPr algn="r">
+              <a:defRPr sz="1200"/>
+            </a:lvl1pPr>
+          </a:lstStyle>
+          <a:p>
+            <a:fld id="{0F89C1C7-3DCD-1040-A9CF-14679D8B5DDD}" type="datetimeFigureOut">
+              <a:rPr lang="en-US" smtClean="0"/>
+              <a:t>10/17/16</a:t>
+            </a:fld>
+            <a:endParaRPr lang="en-US"/>
+          </a:p>
+        </p:txBody>
+      </p:sp>
+      <p:sp>
+        <p:nvSpPr>
+          <p:cNvPr id="4" name="Slide Image Placeholder 3"/>
+          <p:cNvSpPr>
+            <a:spLocks noGrp="1" noRot="1" noChangeAspect="1"/>
+          </p:cNvSpPr>
+          <p:nvPr>
+            <p:ph type="sldImg" idx="2"/>
+          </p:nvPr>
+        </p:nvSpPr>
+        <p:spPr>
+          <a:xfrm>
+            <a:off x="1143000" y="685800"/>
+            <a:ext cx="4572000" cy="3429000"/>
+          </a:xfrm>
+          <a:prstGeom prst="rect">
+            <a:avLst/>
+          </a:prstGeom>
+          <a:noFill/>
+          <a:ln w="12700">
+            <a:solidFill>
+              <a:prstClr val="black"/>
+            </a:solidFill>
+          </a:ln>
+        </p:spPr>
+        <p:txBody>
+          <a:bodyPr vert="horz" lIns="91440" tIns="45720" rIns="91440" bIns="45720" rtlCol="0" anchor="ctr"/>
+          <a:lstStyle/>
+          <a:p>
+            <a:endParaRPr lang="en-US"/>
+          </a:p>
+        </p:txBody>
+      </p:sp>
+      <p:sp>
+        <p:nvSpPr>
+          <p:cNvPr id="5" name="Notes Placeholder 4"/>
+          <p:cNvSpPr>
+            <a:spLocks noGrp="1"/>
+          </p:cNvSpPr>
+          <p:nvPr>
+            <p:ph type="body" sz="quarter" idx="3"/>
+          </p:nvPr>
+        </p:nvSpPr>
+        <p:spPr>
+          <a:xfrm>
+            <a:off x="685800" y="4343400"/>
+            <a:ext cx="5486400" cy="4114800"/>
+          </a:xfrm>
+          <a:prstGeom prst="rect">
+            <a:avLst/>
+          </a:prstGeom>
+        </p:spPr>
+        <p:txBody>
+          <a:bodyPr vert="horz" lIns="91440" tIns="45720" rIns="91440" bIns="45720" rtlCol="0"/>
+          <a:lstStyle/>
+          <a:p>
+            <a:pPr lvl="0"/>
+            <a:r>
+              <a:rPr lang="en-US" smtClean="0"/>
+              <a:t>Click to edit Master text styles</a:t>
+            </a:r>
+          </a:p>
+          <a:p>
+            <a:pPr lvl="1"/>
+            <a:r>
+              <a:rPr lang="en-US" smtClean="0"/>
+              <a:t>Second level</a:t>
+            </a:r>
+          </a:p>
+          <a:p>
+            <a:pPr lvl="2"/>
+            <a:r>
+              <a:rPr lang="en-US" smtClean="0"/>
+              <a:t>Third level</a:t>
+            </a:r>
+          </a:p>
+          <a:p>
+            <a:pPr lvl="3"/>
+            <a:r>
+              <a:rPr lang="en-US" smtClean="0"/>
+              <a:t>Fourth level</a:t>
+            </a:r>
+          </a:p>
+          <a:p>
+            <a:pPr lvl="4"/>
+            <a:r>
+              <a:rPr lang="en-US" smtClean="0"/>
+              <a:t>Fifth level</a:t>
+            </a:r>
+            <a:endParaRPr lang="en-US"/>
+          </a:p>
+        </p:txBody>
+      </p:sp>
+      <p:sp>
+        <p:nvSpPr>
+          <p:cNvPr id="6" name="Footer Placeholder 5"/>
+          <p:cNvSpPr>
+            <a:spLocks noGrp="1"/>
+          </p:cNvSpPr>
+          <p:nvPr>
+            <p:ph type="ftr" sz="quarter" idx="4"/>
+          </p:nvPr>
+        </p:nvSpPr>
+        <p:spPr>
+          <a:xfrm>
+            <a:off x="0" y="8685213"/>
+            <a:ext cx="2971800" cy="457200"/>
+          </a:xfrm>
+          <a:prstGeom prst="rect">
+            <a:avLst/>
+          </a:prstGeom>
+        </p:spPr>
+        <p:txBody>
+          <a:bodyPr vert="horz" lIns="91440" tIns="45720" rIns="91440" bIns="45720" rtlCol="0" anchor="b"/>
+          <a:lstStyle>
+            <a:lvl1pPr algn="l">
+              <a:defRPr sz="1200"/>
+            </a:lvl1pPr>
+          </a:lstStyle>
+          <a:p>
+            <a:endParaRPr lang="en-US"/>
+          </a:p>
+        </p:txBody>
+      </p:sp>
+      <p:sp>
+        <p:nvSpPr>
+          <p:cNvPr id="7" name="Slide Number Placeholder 6"/>
+          <p:cNvSpPr>
+            <a:spLocks noGrp="1"/>
+          </p:cNvSpPr>
+          <p:nvPr>
+            <p:ph type="sldNum" sz="quarter" idx="5"/>
+          </p:nvPr>
+        </p:nvSpPr>
+        <p:spPr>
+          <a:xfrm>
+            <a:off x="3884613" y="8685213"/>
+            <a:ext cx="2971800" cy="457200"/>
+          </a:xfrm>
+          <a:prstGeom prst="rect">
+            <a:avLst/>
+          </a:prstGeom>
+        </p:spPr>
+        <p:txBody>
+          <a:bodyPr vert="horz" lIns="91440" tIns="45720" rIns="91440" bIns="45720" rtlCol="0" anchor="b"/>
+          <a:lstStyle>
+            <a:lvl1pPr algn="r">
+              <a:defRPr sz="1200"/>
+            </a:lvl1pPr>
+          </a:lstStyle>
+          <a:p>
+            <a:fld id="{BB5E49A5-4136-284D-997B-48E1D791AD67}" type="slidenum">
+              <a:rPr lang="en-US" smtClean="0"/>
+              <a:t>‹#›</a:t>
+            </a:fld>
+            <a:endParaRPr lang="en-US"/>
+          </a:p>
+        </p:txBody>
+      </p:sp>
+    </p:spTree>
+    <p:extLst>
+      <p:ext uri="{BB962C8B-B14F-4D97-AF65-F5344CB8AC3E}">
+        <p14:creationId xmlns:p14="http://schemas.microsoft.com/office/powerpoint/2010/main" val="2623252185"/>
+      </p:ext>
+    </p:extLst>
+  </p:cSld>
+  <p:clrMap bg1="lt1" tx1="dk1" bg2="lt2" tx2="dk2" accent1="accent1" accent2="accent2" accent3="accent3" accent4="accent4" accent5="accent5" accent6="accent6" hlink="hlink" folHlink="folHlink"/>
+  <p:notesStyle>
+    <a:lvl1pPr marL="0" algn="l" defTabSz="457200" rtl="0" eaLnBrk="1" latinLnBrk="0" hangingPunct="1">
+      <a:defRPr sz="1200" kern="1200">
+        <a:solidFill>
+          <a:schemeClr val="tx1"/>
+        </a:solidFill>
+        <a:latin typeface="+mn-lt"/>
+        <a:ea typeface="+mn-ea"/>
+        <a:cs typeface="+mn-cs"/>
+      </a:defRPr>
+    </a:lvl1pPr>
+    <a:lvl2pPr marL="457200" algn="l" defTabSz="457200" rtl="0" eaLnBrk="1" latinLnBrk="0" hangingPunct="1">
+      <a:defRPr sz="1200" kern="1200">
+        <a:solidFill>
+          <a:schemeClr val="tx1"/>
+        </a:solidFill>
+        <a:latin typeface="+mn-lt"/>
+        <a:ea typeface="+mn-ea"/>
+        <a:cs typeface="+mn-cs"/>
+      </a:defRPr>
+    </a:lvl2pPr>
+    <a:lvl3pPr marL="914400" algn="l" defTabSz="457200" rtl="0" eaLnBrk="1" latinLnBrk="0" hangingPunct="1">
+      <a:defRPr sz="1200" kern="1200">
+        <a:solidFill>
+          <a:schemeClr val="tx1"/>
+        </a:solidFill>
+        <a:latin typeface="+mn-lt"/>
+        <a:ea typeface="+mn-ea"/>
+        <a:cs typeface="+mn-cs"/>
+      </a:defRPr>
+    </a:lvl3pPr>
+    <a:lvl4pPr marL="1371600" algn="l" defTabSz="457200" rtl="0" eaLnBrk="1" latinLnBrk="0" hangingPunct="1">
+      <a:defRPr sz="1200" kern="1200">
+        <a:solidFill>
+          <a:schemeClr val="tx1"/>
+        </a:solidFill>
+        <a:latin typeface="+mn-lt"/>
+        <a:ea typeface="+mn-ea"/>
+        <a:cs typeface="+mn-cs"/>
+      </a:defRPr>
+    </a:lvl4pPr>
+    <a:lvl5pPr marL="1828800" algn="l" defTabSz="457200" rtl="0" eaLnBrk="1" latinLnBrk="0" hangingPunct="1">
+      <a:defRPr sz="1200" kern="1200">
+        <a:solidFill>
+          <a:schemeClr val="tx1"/>
+        </a:solidFill>
+        <a:latin typeface="+mn-lt"/>
+        <a:ea typeface="+mn-ea"/>
+        <a:cs typeface="+mn-cs"/>
+      </a:defRPr>
+    </a:lvl5pPr>
+    <a:lvl6pPr marL="2286000" algn="l" defTabSz="457200" rtl="0" eaLnBrk="1" latinLnBrk="0" hangingPunct="1">
+      <a:defRPr sz="1200" kern="1200">
+        <a:solidFill>
+          <a:schemeClr val="tx1"/>
+        </a:solidFill>
+        <a:latin typeface="+mn-lt"/>
+        <a:ea typeface="+mn-ea"/>
+        <a:cs typeface="+mn-cs"/>
+      </a:defRPr>
+    </a:lvl6pPr>
+    <a:lvl7pPr marL="2743200" algn="l" defTabSz="457200" rtl="0" eaLnBrk="1" latinLnBrk="0" hangingPunct="1">
+      <a:defRPr sz="1200" kern="1200">
+        <a:solidFill>
+          <a:schemeClr val="tx1"/>
+        </a:solidFill>
+        <a:latin typeface="+mn-lt"/>
+        <a:ea typeface="+mn-ea"/>
+        <a:cs typeface="+mn-cs"/>
+      </a:defRPr>
+    </a:lvl7pPr>
+    <a:lvl8pPr marL="3200400" algn="l" defTabSz="457200" rtl="0" eaLnBrk="1" latinLnBrk="0" hangingPunct="1">
+      <a:defRPr sz="1200" kern="1200">
+        <a:solidFill>
+          <a:schemeClr val="tx1"/>
+        </a:solidFill>
+        <a:latin typeface="+mn-lt"/>
+        <a:ea typeface="+mn-ea"/>
+        <a:cs typeface="+mn-cs"/>
+      </a:defRPr>
+    </a:lvl8pPr>
+    <a:lvl9pPr marL="3657600" algn="l" defTabSz="457200" rtl="0" eaLnBrk="1" latinLnBrk="0" hangingPunct="1">
+      <a:defRPr sz="1200" kern="1200">
+        <a:solidFill>
+          <a:schemeClr val="tx1"/>
+        </a:solidFill>
+        <a:latin typeface="+mn-lt"/>
+        <a:ea typeface="+mn-ea"/>
+        <a:cs typeface="+mn-cs"/>
+      </a:defRPr>
+    </a:lvl9pPr>
+  </p:notesStyle>
+</p:notesMaster>
+</file>
+
+<file path=ppt/notesSlides/notesSlide1.xml><?xml version="1.0" encoding="utf-8"?>
+<p:notes xmlns:a="http://schemas.openxmlformats.org/drawingml/2006/main" xmlns:p="http://schemas.openxmlformats.org/presentationml/2006/main" xmlns:r="http://schemas.openxmlformats.org/officeDocument/2006/relationships">
+  <p:cSld>
+    <p:spTree>
+      <p:nvGrpSpPr>
+        <p:cNvPr id="1" name=""/>
+        <p:cNvGrpSpPr/>
+        <p:nvPr/>
+      </p:nvGrpSpPr>
+      <p:grpSpPr>
+        <a:xfrm>
+          <a:off x="0" y="0"/>
+          <a:ext cx="0" cy="0"/>
+          <a:chOff x="0" y="0"/>
+          <a:chExt cx="0" cy="0"/>
+        </a:xfrm>
+      </p:grpSpPr>
+      <p:sp>
+        <p:nvSpPr>
+          <p:cNvPr id="2" name="Slide Image Placeholder 1"/>
+          <p:cNvSpPr>
+            <a:spLocks noGrp="1"/>
+          </p:cNvSpPr>
+          <p:nvPr>
+            <p:ph type="sldImg" idx="2"/>
+          </p:nvPr>
+        </p:nvSpPr>
+        <p:spPr/>
+      </p:sp>
+      <p:sp>
+        <p:nvSpPr>
+          <p:cNvPr id="3" name="Notes Placeholder 2"/>
+          <p:cNvSpPr>
+            <a:spLocks noGrp="1"/>
+          </p:cNvSpPr>
+          <p:nvPr>
+            <p:ph type="body" idx="3" sz="quarter"/>
+          </p:nvPr>
+        </p:nvSpPr>
+        <p:spPr/>
+        <p:txBody>
+          <a:bodyPr/>
+          <a:lstStyle/>
+          <a:p>
+            <a:r>
+              <a:t>ON THE SLIDE (say these):</a:t>
+            </a:r>
+          </a:p>
+          <a:p/>
+          <a:p>
+            <a:r>
+              <a:t>Two GB300 compute trays (4 GPUs + 4 network rails each) and a small control-plane node, leased from a shared Slurm pool and turned into a Kubernetes (k3s) cluster</a:t>
+            </a:r>
+          </a:p>
+          <a:p/>
+          <a:p>
+            <a:r>
+              <a:t>Three ways for the trays to talk: NVLink between trays (the fast path), the RDMA rails (RoCE v2), and plain TCP over the pod network — the benchmark runs the same collective over each</a:t>
+            </a:r>
+          </a:p>
+          <a:p/>
+          <a:p>
+            <a:r>
+              <a:t>Each experiment is one Kubernetes Job with one pod per tray; every pod claims its GPUs and its rails through the same allocation mechanism (DRA); the pods never run with host networking</a:t>
+            </a:r>
+          </a:p>
+          <a:p/>
+          <a:p>
+            <a:r>
+              <a:t>Every run writes a machine-checked result file plus per-rank timings; a small watcher pod on each tray records the NIC, NVLink and GPU counters once a second; the same counters go to a Grafana dashboard</a:t>
+            </a:r>
+          </a:p>
+          <a:p/>
+          <a:p/>
+          <a:p/>
+          <a:p>
+            <a:r>
+              <a:t>What the audience needs to know: a GB300 tray is one node with four GPUs joined by NVLink, four RDMA-capable NICs (one per GPU, called rails), and two Grace CPUs. Two such trays sit in the same NVLink domain, so their GPUs can talk directly over NVLink (multi-node NVLink, MNNVL) as well as over the rails.</a:t>
+            </a:r>
+          </a:p>
+          <a:p/>
+          <a:p>
+            <a:r>
+              <a:t>Why Kubernetes here: the exercise wants a reproducible environment, not a particular scheduler. Kubernetes gives declarative manifests (committed to the repo), a scheduler that allocates GPUs and NICs as first-class devices, and one image that CI builds and publishes. The trays are borrowed, so the bootstrap snapshots every node and proves it goes back unchanged.</a:t>
+            </a:r>
+          </a:p>
+          <a:p/>
+          <a:p>
+            <a:r>
+              <a:t>Why three networks: the exercise asks us to separate evidence from diagnosis about networking. Running the identical collective over NVLink, over the rails, and over TCP shows what each path can do before we speculate about bottlenecks.</a:t>
+            </a:r>
+          </a:p>
+        </p:txBody>
+      </p:sp>
+      <p:sp>
+        <p:nvSpPr>
+          <p:cNvPr id="4" name="Slide Number Placeholder 3"/>
+          <p:cNvSpPr>
+            <a:spLocks noGrp="1"/>
+          </p:cNvSpPr>
+          <p:nvPr>
+            <p:ph type="sldNum" idx="5" sz="quarter"/>
+          </p:nvPr>
+        </p:nvSpPr>
+        <p:spPr/>
+      </p:sp>
+    </p:spTree>
+  </p:cSld>
+  <p:clrMapOvr>
+    <a:masterClrMapping/>
+  </p:clrMapOvr>
+</p:notes>
+</file>
+
+<file path=ppt/notesSlides/notesSlide2.xml><?xml version="1.0" encoding="utf-8"?>
+<p:notes xmlns:a="http://schemas.openxmlformats.org/drawingml/2006/main" xmlns:p="http://schemas.openxmlformats.org/presentationml/2006/main" xmlns:r="http://schemas.openxmlformats.org/officeDocument/2006/relationships">
+  <p:cSld>
+    <p:spTree>
+      <p:nvGrpSpPr>
+        <p:cNvPr id="1" name=""/>
+        <p:cNvGrpSpPr/>
+        <p:nvPr/>
+      </p:nvGrpSpPr>
+      <p:grpSpPr>
+        <a:xfrm>
+          <a:off x="0" y="0"/>
+          <a:ext cx="0" cy="0"/>
+          <a:chOff x="0" y="0"/>
+          <a:chExt cx="0" cy="0"/>
+        </a:xfrm>
+      </p:grpSpPr>
+      <p:sp>
+        <p:nvSpPr>
+          <p:cNvPr id="2" name="Slide Image Placeholder 1"/>
+          <p:cNvSpPr>
+            <a:spLocks noGrp="1"/>
+          </p:cNvSpPr>
+          <p:nvPr>
+            <p:ph type="sldImg" idx="2"/>
+          </p:nvPr>
+        </p:nvSpPr>
+        <p:spPr/>
+      </p:sp>
+      <p:sp>
+        <p:nvSpPr>
+          <p:cNvPr id="3" name="Notes Placeholder 2"/>
+          <p:cNvSpPr>
+            <a:spLocks noGrp="1"/>
+          </p:cNvSpPr>
+          <p:nvPr>
+            <p:ph type="body" idx="3" sz="quarter"/>
+          </p:nvPr>
+        </p:nvSpPr>
+        <p:spPr/>
+        <p:txBody>
+          <a:bodyPr/>
+          <a:lstStyle/>
+          <a:p>
+            <a:r>
+              <a:t>Plain version: with the device plugin you order 'four GPUs' and get four unnamed GPUs; there is no way to also order the network card that sits next to each GPU. With DRA the cluster lists every device with its properties and the pod asks for a set of them; because dranet publishes the NICs through the same interface, the GPU claim and the NIC claim live side by side in one pod spec.</a:t>
+            </a:r>
+          </a:p>
+          <a:p/>
+          <a:p>
+            <a:r>
+              <a:t>This is what made the rail-count experiment (1 vs 2 vs 4 rails) possible with a one-line change per experiment, and what let us keep the pods unprivileged and off the host network.</a:t>
+            </a:r>
+          </a:p>
+          <a:p/>
+          <a:p>
+            <a:r>
+              <a:t>The shared RDMA namespace mode is a Linux kernel setting. It can only be changed when no container network namespace exists, which is why the bootstrap sets it on the freshly leased node before installing k3s, and restores the original at teardown.</a:t>
+            </a:r>
+          </a:p>
+        </p:txBody>
+      </p:sp>
+      <p:sp>
+        <p:nvSpPr>
+          <p:cNvPr id="4" name="Slide Number Placeholder 3"/>
+          <p:cNvSpPr>
+            <a:spLocks noGrp="1"/>
+          </p:cNvSpPr>
+          <p:nvPr>
+            <p:ph type="sldNum" idx="5" sz="quarter"/>
+          </p:nvPr>
+        </p:nvSpPr>
+        <p:spPr/>
+      </p:sp>
+    </p:spTree>
+  </p:cSld>
+  <p:clrMapOvr>
+    <a:masterClrMapping/>
+  </p:clrMapOvr>
+</p:notes>
+</file>
+
+<file path=ppt/notesSlides/notesSlide3.xml><?xml version="1.0" encoding="utf-8"?>
+<p:notes xmlns:a="http://schemas.openxmlformats.org/drawingml/2006/main" xmlns:p="http://schemas.openxmlformats.org/presentationml/2006/main" xmlns:r="http://schemas.openxmlformats.org/officeDocument/2006/relationships">
+  <p:cSld>
+    <p:spTree>
+      <p:nvGrpSpPr>
+        <p:cNvPr id="1" name=""/>
+        <p:cNvGrpSpPr/>
+        <p:nvPr/>
+      </p:nvGrpSpPr>
+      <p:grpSpPr>
+        <a:xfrm>
+          <a:off x="0" y="0"/>
+          <a:ext cx="0" cy="0"/>
+          <a:chOff x="0" y="0"/>
+          <a:chExt cx="0" cy="0"/>
+        </a:xfrm>
+      </p:grpSpPr>
+      <p:sp>
+        <p:nvSpPr>
+          <p:cNvPr id="2" name="Slide Image Placeholder 1"/>
+          <p:cNvSpPr>
+            <a:spLocks noGrp="1"/>
+          </p:cNvSpPr>
+          <p:nvPr>
+            <p:ph type="sldImg" idx="2"/>
+          </p:nvPr>
+        </p:nvSpPr>
+        <p:spPr/>
+      </p:sp>
+      <p:sp>
+        <p:nvSpPr>
+          <p:cNvPr id="3" name="Notes Placeholder 2"/>
+          <p:cNvSpPr>
+            <a:spLocks noGrp="1"/>
+          </p:cNvSpPr>
+          <p:nvPr>
+            <p:ph type="body" idx="3" sz="quarter"/>
+          </p:nvPr>
+        </p:nvSpPr>
+        <p:spPr/>
+        <p:txBody>
+          <a:bodyPr/>
+          <a:lstStyle/>
+          <a:p>
+            <a:r>
+              <a:t>Bus bandwidth is the standard way collective benchmarks report speed: bytes moved per second, adjusted so different numbers of GPUs are comparable. Higher is better.</a:t>
+            </a:r>
+          </a:p>
+          <a:p/>
+          <a:p>
+            <a:r>
+              <a:t>The shape of the curve: for a 1 MiB message the operation takes about 80 microseconds on either NVLink or RDMA — that time is handshakes and kernel launches, not data. As the message grows, the fixed cost is amortised and the curve flattens at the speed of the wire.</a:t>
+            </a:r>
+          </a:p>
+          <a:p/>
+          <a:p>
+            <a:r>
+              <a:t>The two TCP lines show why the CNI overlay must never carry training traffic, and what a plain Ethernet path costs compared with RDMA on the very same cable (118 vs 425 GB/s).</a:t>
+            </a:r>
+          </a:p>
+        </p:txBody>
+      </p:sp>
+      <p:sp>
+        <p:nvSpPr>
+          <p:cNvPr id="4" name="Slide Number Placeholder 3"/>
+          <p:cNvSpPr>
+            <a:spLocks noGrp="1"/>
+          </p:cNvSpPr>
+          <p:nvPr>
+            <p:ph type="sldNum" idx="5" sz="quarter"/>
+          </p:nvPr>
+        </p:nvSpPr>
+        <p:spPr/>
+      </p:sp>
+    </p:spTree>
+  </p:cSld>
+  <p:clrMapOvr>
+    <a:masterClrMapping/>
+  </p:clrMapOvr>
+</p:notes>
+</file>
+
+<file path=ppt/notesSlides/notesSlide4.xml><?xml version="1.0" encoding="utf-8"?>
+<p:notes xmlns:a="http://schemas.openxmlformats.org/drawingml/2006/main" xmlns:p="http://schemas.openxmlformats.org/presentationml/2006/main" xmlns:r="http://schemas.openxmlformats.org/officeDocument/2006/relationships">
+  <p:cSld>
+    <p:spTree>
+      <p:nvGrpSpPr>
+        <p:cNvPr id="1" name=""/>
+        <p:cNvGrpSpPr/>
+        <p:nvPr/>
+      </p:nvGrpSpPr>
+      <p:grpSpPr>
+        <a:xfrm>
+          <a:off x="0" y="0"/>
+          <a:ext cx="0" cy="0"/>
+          <a:chOff x="0" y="0"/>
+          <a:chExt cx="0" cy="0"/>
+        </a:xfrm>
+      </p:grpSpPr>
+      <p:sp>
+        <p:nvSpPr>
+          <p:cNvPr id="2" name="Slide Image Placeholder 1"/>
+          <p:cNvSpPr>
+            <a:spLocks noGrp="1"/>
+          </p:cNvSpPr>
+          <p:nvPr>
+            <p:ph type="sldImg" idx="2"/>
+          </p:nvPr>
+        </p:nvSpPr>
+        <p:spPr/>
+      </p:sp>
+      <p:sp>
+        <p:nvSpPr>
+          <p:cNvPr id="3" name="Notes Placeholder 2"/>
+          <p:cNvSpPr>
+            <a:spLocks noGrp="1"/>
+          </p:cNvSpPr>
+          <p:nvPr>
+            <p:ph type="body" idx="3" sz="quarter"/>
+          </p:nvPr>
+        </p:nvSpPr>
+        <p:spPr/>
+        <p:txBody>
+          <a:bodyPr/>
+          <a:lstStyle/>
+          <a:p>
+            <a:r>
+              <a:t>This slide exists to make the diagnosis honest: below a few MiB the network bandwidth is irrelevant; what matters is how many operations you issue. It sets up the bucket-size finding.</a:t>
+            </a:r>
+          </a:p>
+        </p:txBody>
+      </p:sp>
+      <p:sp>
+        <p:nvSpPr>
+          <p:cNvPr id="4" name="Slide Number Placeholder 3"/>
+          <p:cNvSpPr>
+            <a:spLocks noGrp="1"/>
+          </p:cNvSpPr>
+          <p:nvPr>
+            <p:ph type="sldNum" idx="5" sz="quarter"/>
+          </p:nvPr>
+        </p:nvSpPr>
+        <p:spPr/>
+      </p:sp>
+    </p:spTree>
+  </p:cSld>
+  <p:clrMapOvr>
+    <a:masterClrMapping/>
+  </p:clrMapOvr>
+</p:notes>
+</file>
+
+<file path=ppt/notesSlides/notesSlide5.xml><?xml version="1.0" encoding="utf-8"?>
+<p:notes xmlns:a="http://schemas.openxmlformats.org/drawingml/2006/main" xmlns:p="http://schemas.openxmlformats.org/presentationml/2006/main" xmlns:r="http://schemas.openxmlformats.org/officeDocument/2006/relationships">
+  <p:cSld>
+    <p:spTree>
+      <p:nvGrpSpPr>
+        <p:cNvPr id="1" name=""/>
+        <p:cNvGrpSpPr/>
+        <p:nvPr/>
+      </p:nvGrpSpPr>
+      <p:grpSpPr>
+        <a:xfrm>
+          <a:off x="0" y="0"/>
+          <a:ext cx="0" cy="0"/>
+          <a:chOff x="0" y="0"/>
+          <a:chExt cx="0" cy="0"/>
+        </a:xfrm>
+      </p:grpSpPr>
+      <p:sp>
+        <p:nvSpPr>
+          <p:cNvPr id="2" name="Slide Image Placeholder 1"/>
+          <p:cNvSpPr>
+            <a:spLocks noGrp="1"/>
+          </p:cNvSpPr>
+          <p:nvPr>
+            <p:ph type="sldImg" idx="2"/>
+          </p:nvPr>
+        </p:nvSpPr>
+        <p:spPr/>
+      </p:sp>
+      <p:sp>
+        <p:nvSpPr>
+          <p:cNvPr id="3" name="Notes Placeholder 2"/>
+          <p:cNvSpPr>
+            <a:spLocks noGrp="1"/>
+          </p:cNvSpPr>
+          <p:nvPr>
+            <p:ph type="body" idx="3" sz="quarter"/>
+          </p:nvPr>
+        </p:nvSpPr>
+        <p:spPr/>
+        <p:txBody>
+          <a:bodyPr/>
+          <a:lstStyle/>
+          <a:p>
+            <a:r>
+              <a:t>Why efficiency drops on one tray from 2 to 4 GPUs: no NIC is involved, so it is not the network — the model is small (a 21 ms step), so launch overhead and the intra-tray all-reduce are a bigger fraction. Saying this out loud is the exercise's 'do not assume networking is the problem'.</a:t>
+            </a:r>
+          </a:p>
+          <a:p/>
+          <a:p>
+            <a:r>
+              <a:t>Why 8 GPUs over NVLink beats 4 on one tray: NCCL uses the NVSwitch-based reduction (NVLS) across both trays; the exchange gets faster per byte at 8 ranks than the 4-rank pattern.</a:t>
+            </a:r>
+          </a:p>
+          <a:p/>
+          <a:p>
+            <a:r>
+              <a:t>Why 8 GPUs over the rails is 69 %: the same exchange now runs at 425 instead of 835 GB/s and the communication share rises to 91 % of the step. This is the case the optimization slides attack from two directions.</a:t>
+            </a:r>
+          </a:p>
+        </p:txBody>
+      </p:sp>
+      <p:sp>
+        <p:nvSpPr>
+          <p:cNvPr id="4" name="Slide Number Placeholder 3"/>
+          <p:cNvSpPr>
+            <a:spLocks noGrp="1"/>
+          </p:cNvSpPr>
+          <p:nvPr>
+            <p:ph type="sldNum" idx="5" sz="quarter"/>
+          </p:nvPr>
+        </p:nvSpPr>
+        <p:spPr/>
+      </p:sp>
+    </p:spTree>
+  </p:cSld>
+  <p:clrMapOvr>
+    <a:masterClrMapping/>
+  </p:clrMapOvr>
+</p:notes>
+</file>
+
+<file path=ppt/notesSlides/notesSlide6.xml><?xml version="1.0" encoding="utf-8"?>
+<p:notes xmlns:a="http://schemas.openxmlformats.org/drawingml/2006/main" xmlns:p="http://schemas.openxmlformats.org/presentationml/2006/main" xmlns:r="http://schemas.openxmlformats.org/officeDocument/2006/relationships">
+  <p:cSld>
+    <p:spTree>
+      <p:nvGrpSpPr>
+        <p:cNvPr id="1" name=""/>
+        <p:cNvGrpSpPr/>
+        <p:nvPr/>
+      </p:nvGrpSpPr>
+      <p:grpSpPr>
+        <a:xfrm>
+          <a:off x="0" y="0"/>
+          <a:ext cx="0" cy="0"/>
+          <a:chOff x="0" y="0"/>
+          <a:chExt cx="0" cy="0"/>
+        </a:xfrm>
+      </p:grpSpPr>
+      <p:sp>
+        <p:nvSpPr>
+          <p:cNvPr id="2" name="Slide Image Placeholder 1"/>
+          <p:cNvSpPr>
+            <a:spLocks noGrp="1"/>
+          </p:cNvSpPr>
+          <p:nvPr>
+            <p:ph type="sldImg" idx="2"/>
+          </p:nvPr>
+        </p:nvSpPr>
+        <p:spPr/>
+      </p:sp>
+      <p:sp>
+        <p:nvSpPr>
+          <p:cNvPr id="3" name="Notes Placeholder 2"/>
+          <p:cNvSpPr>
+            <a:spLocks noGrp="1"/>
+          </p:cNvSpPr>
+          <p:nvPr>
+            <p:ph type="body" idx="3" sz="quarter"/>
+          </p:nvPr>
+        </p:nvSpPr>
+        <p:spPr/>
+        <p:txBody>
+          <a:bodyPr/>
+          <a:lstStyle/>
+          <a:p>
+            <a:r>
+              <a:t>How we know the rails are 800 Gb/s: we watched the NIC's transmitted-bytes counter during a sustained all-reduce and cross-checked it against ethtool's byte counter (they agree to the byte). One rail moved 411 Gb/s. The physical NIC exposes four 200 Gb/s ports per rail, and the virtual function aggregates them.</a:t>
+            </a:r>
+          </a:p>
+          <a:p/>
+          <a:p>
+            <a:r>
+              <a:t>How we know it is not congestion: the same watcher reads the RoCE congestion-control counters (CNPs sent and handled, ECN-marked packets) and the reliability counters (out-of-sequence, sequence errors, ACK timeouts). All flat at zero per second during every run.</a:t>
+            </a:r>
+          </a:p>
+          <a:p/>
+          <a:p>
+            <a:r>
+              <a:t>How we know it is not PCIe: lspci shows 64 GT/s x16 on the ConnectX-8 and on the GPU, about 120 GB/s per direction, against about 60 GB/s used per rail.</a:t>
+            </a:r>
+          </a:p>
+          <a:p/>
+          <a:p>
+            <a:r>
+              <a:t>The GPUDirect-off run (next slide) shows the same bytes on the wire taking 1.6x longer — that is the cost of bouncing through host memory, not a network effect.</a:t>
+            </a:r>
+          </a:p>
+        </p:txBody>
+      </p:sp>
+      <p:sp>
+        <p:nvSpPr>
+          <p:cNvPr id="4" name="Slide Number Placeholder 3"/>
+          <p:cNvSpPr>
+            <a:spLocks noGrp="1"/>
+          </p:cNvSpPr>
+          <p:nvPr>
+            <p:ph type="sldNum" idx="5" sz="quarter"/>
+          </p:nvPr>
+        </p:nvSpPr>
+        <p:spPr/>
+      </p:sp>
+    </p:spTree>
+  </p:cSld>
+  <p:clrMapOvr>
+    <a:masterClrMapping/>
+  </p:clrMapOvr>
+</p:notes>
+</file>
+
+<file path=ppt/notesSlides/notesSlide7.xml><?xml version="1.0" encoding="utf-8"?>
+<p:notes xmlns:a="http://schemas.openxmlformats.org/drawingml/2006/main" xmlns:p="http://schemas.openxmlformats.org/presentationml/2006/main" xmlns:r="http://schemas.openxmlformats.org/officeDocument/2006/relationships">
+  <p:cSld>
+    <p:spTree>
+      <p:nvGrpSpPr>
+        <p:cNvPr id="1" name=""/>
+        <p:cNvGrpSpPr/>
+        <p:nvPr/>
+      </p:nvGrpSpPr>
+      <p:grpSpPr>
+        <a:xfrm>
+          <a:off x="0" y="0"/>
+          <a:ext cx="0" cy="0"/>
+          <a:chOff x="0" y="0"/>
+          <a:chExt cx="0" cy="0"/>
+        </a:xfrm>
+      </p:grpSpPr>
+      <p:sp>
+        <p:nvSpPr>
+          <p:cNvPr id="2" name="Slide Image Placeholder 1"/>
+          <p:cNvSpPr>
+            <a:spLocks noGrp="1"/>
+          </p:cNvSpPr>
+          <p:nvPr>
+            <p:ph type="sldImg" idx="2"/>
+          </p:nvPr>
+        </p:nvSpPr>
+        <p:spPr/>
+      </p:sp>
+      <p:sp>
+        <p:nvSpPr>
+          <p:cNvPr id="3" name="Notes Placeholder 2"/>
+          <p:cNvSpPr>
+            <a:spLocks noGrp="1"/>
+          </p:cNvSpPr>
+          <p:nvPr>
+            <p:ph type="body" idx="3" sz="quarter"/>
+          </p:nvPr>
+        </p:nvSpPr>
+        <p:spPr/>
+        <p:txBody>
+          <a:bodyPr/>
+          <a:lstStyle/>
+          <a:p>
+            <a:r>
+              <a:t>A queue pair is the RDMA equivalent of a connection between two NICs. NCCL opens one per pair of communicating GPUs by default. The knob lets it open several and stripe a message across them; it is a common tuning recommendation on large fabrics where a single flow cannot fill a link because of how switches spread traffic.</a:t>
+            </a:r>
+          </a:p>
+          <a:p/>
+          <a:p>
+            <a:r>
+              <a:t>Here there is one switch hop between matching rails, so striping buys nothing and costs overhead. The counters make the explanation concrete: fewer bytes per second on each rail, no errors, no congestion — the sender is simply doing less useful work per unit time.</a:t>
+            </a:r>
+          </a:p>
+          <a:p/>
+          <a:p>
+            <a:r>
+              <a:t>The p-values are from Welch's t-test across the five repeats of baseline versus change; run-to-run spread within a cell is under 2 % except one 4 GiB outlier, so the differences are real.</a:t>
+            </a:r>
+          </a:p>
+        </p:txBody>
+      </p:sp>
+      <p:sp>
+        <p:nvSpPr>
+          <p:cNvPr id="4" name="Slide Number Placeholder 3"/>
+          <p:cNvSpPr>
+            <a:spLocks noGrp="1"/>
+          </p:cNvSpPr>
+          <p:nvPr>
+            <p:ph type="sldNum" idx="5" sz="quarter"/>
+          </p:nvPr>
+        </p:nvSpPr>
+        <p:spPr/>
+      </p:sp>
+    </p:spTree>
+  </p:cSld>
+  <p:clrMapOvr>
+    <a:masterClrMapping/>
+  </p:clrMapOvr>
+</p:notes>
+</file>
+
+<file path=ppt/notesSlides/notesSlide8.xml><?xml version="1.0" encoding="utf-8"?>
+<p:notes xmlns:a="http://schemas.openxmlformats.org/drawingml/2006/main" xmlns:p="http://schemas.openxmlformats.org/presentationml/2006/main" xmlns:r="http://schemas.openxmlformats.org/officeDocument/2006/relationships">
+  <p:cSld>
+    <p:spTree>
+      <p:nvGrpSpPr>
+        <p:cNvPr id="1" name=""/>
+        <p:cNvGrpSpPr/>
+        <p:nvPr/>
+      </p:nvGrpSpPr>
+      <p:grpSpPr>
+        <a:xfrm>
+          <a:off x="0" y="0"/>
+          <a:ext cx="0" cy="0"/>
+          <a:chOff x="0" y="0"/>
+          <a:chExt cx="0" cy="0"/>
+        </a:xfrm>
+      </p:grpSpPr>
+      <p:sp>
+        <p:nvSpPr>
+          <p:cNvPr id="2" name="Slide Image Placeholder 1"/>
+          <p:cNvSpPr>
+            <a:spLocks noGrp="1"/>
+          </p:cNvSpPr>
+          <p:nvPr>
+            <p:ph type="sldImg" idx="2"/>
+          </p:nvPr>
+        </p:nvSpPr>
+        <p:spPr/>
+      </p:sp>
+      <p:sp>
+        <p:nvSpPr>
+          <p:cNvPr id="3" name="Notes Placeholder 2"/>
+          <p:cNvSpPr>
+            <a:spLocks noGrp="1"/>
+          </p:cNvSpPr>
+          <p:nvPr>
+            <p:ph type="body" idx="3" sz="quarter"/>
+          </p:nvPr>
+        </p:nvSpPr>
+        <p:spPr/>
+        <p:txBody>
+          <a:bodyPr/>
+          <a:lstStyle/>
+          <a:p>
+            <a:r>
+              <a:t>The bucket-size result is the practical takeaway for a training team: fewer, larger all-reduces amortise the fixed cost we saw on the small-message slide. It recovers most of the gap between the RDMA and NVLink runs without touching the network.</a:t>
+            </a:r>
+          </a:p>
+          <a:p/>
+          <a:p>
+            <a:r>
+              <a:t>The Tree entry is kept on purpose: the exercise asks for honest reporting, and 'that configuration is invalid' is a finding too.</a:t>
+            </a:r>
+          </a:p>
+        </p:txBody>
+      </p:sp>
+      <p:sp>
+        <p:nvSpPr>
+          <p:cNvPr id="4" name="Slide Number Placeholder 3"/>
+          <p:cNvSpPr>
+            <a:spLocks noGrp="1"/>
+          </p:cNvSpPr>
+          <p:nvPr>
+            <p:ph type="sldNum" idx="5" sz="quarter"/>
+          </p:nvPr>
+        </p:nvSpPr>
+        <p:spPr/>
+      </p:sp>
+    </p:spTree>
+  </p:cSld>
+  <p:clrMapOvr>
+    <a:masterClrMapping/>
+  </p:clrMapOvr>
+</p:notes>
+</file>
+
+<file path=ppt/notesSlides/notesSlide9.xml><?xml version="1.0" encoding="utf-8"?>
+<p:notes xmlns:a="http://schemas.openxmlformats.org/drawingml/2006/main" xmlns:p="http://schemas.openxmlformats.org/presentationml/2006/main" xmlns:r="http://schemas.openxmlformats.org/officeDocument/2006/relationships">
+  <p:cSld>
+    <p:spTree>
+      <p:nvGrpSpPr>
+        <p:cNvPr id="1" name=""/>
+        <p:cNvGrpSpPr/>
+        <p:nvPr/>
+      </p:nvGrpSpPr>
+      <p:grpSpPr>
+        <a:xfrm>
+          <a:off x="0" y="0"/>
+          <a:ext cx="0" cy="0"/>
+          <a:chOff x="0" y="0"/>
+          <a:chExt cx="0" cy="0"/>
+        </a:xfrm>
+      </p:grpSpPr>
+      <p:sp>
+        <p:nvSpPr>
+          <p:cNvPr id="2" name="Slide Image Placeholder 1"/>
+          <p:cNvSpPr>
+            <a:spLocks noGrp="1"/>
+          </p:cNvSpPr>
+          <p:nvPr>
+            <p:ph type="sldImg" idx="2"/>
+          </p:nvPr>
+        </p:nvSpPr>
+        <p:spPr/>
+      </p:sp>
+      <p:sp>
+        <p:nvSpPr>
+          <p:cNvPr id="3" name="Notes Placeholder 2"/>
+          <p:cNvSpPr>
+            <a:spLocks noGrp="1"/>
+          </p:cNvSpPr>
+          <p:nvPr>
+            <p:ph type="body" idx="3" sz="quarter"/>
+          </p:nvPr>
+        </p:nvSpPr>
+        <p:spPr/>
+        <p:txBody>
+          <a:bodyPr/>
+          <a:lstStyle/>
+          <a:p>
+            <a:r>
+              <a:t>If asked about scheduling at scale: add a gang scheduler (Kueue) so multi-pod Jobs start together, and label nodes with their NVLink domain and fabric block so claims land where the fast path exists. Both are outside the two-tray scope but the manifests already assume one pod per tray and per-pod claims.</a:t>
+            </a:r>
+          </a:p>
+        </p:txBody>
+      </p:sp>
+      <p:sp>
+        <p:nvSpPr>
+          <p:cNvPr id="4" name="Slide Number Placeholder 3"/>
+          <p:cNvSpPr>
+            <a:spLocks noGrp="1"/>
+          </p:cNvSpPr>
+          <p:nvPr>
+            <p:ph type="sldNum" idx="5" sz="quarter"/>
+          </p:nvPr>
+        </p:nvSpPr>
+        <p:spPr/>
+      </p:sp>
+    </p:spTree>
+  </p:cSld>
+  <p:clrMapOvr>
+    <a:masterClrMapping/>
+  </p:clrMapOvr>
+</p:notes>
 </file>
 
 <file path=ppt/slideLayouts/slideLayout1.xml><?xml version="1.0" encoding="utf-8"?>
@@ -3141,7 +4235,7 @@
               </a:defRPr>
             </a:pPr>
             <a:r>
-              <a:t>NCCL all-reduce · NVLink vs RDMA vs TCP · DDP scaling · NCCL_IB_QPS_PER_CONNECTION</a:t>
+              <a:t>NCCL all-reduce · NVLink vs RDMA vs TCP · DDP scaling · one controlled optimization, and the counters behind every number</a:t>
             </a:r>
           </a:p>
         </p:txBody>
@@ -3194,885 +4288,7 @@
               </a:defRPr>
             </a:pPr>
             <a:r>
-              <a:t>5 · Sensitivity appendix</a:t>
-            </a:r>
-          </a:p>
-        </p:txBody>
-      </p:sp>
-      <p:sp>
-        <p:nvSpPr>
-          <p:cNvPr id="3" name="TextBox 2"/>
-          <p:cNvSpPr txBox="1"/>
-          <p:nvPr/>
-        </p:nvSpPr>
-        <p:spPr>
-          <a:xfrm>
-            <a:off x="548640" y="1188720"/>
-            <a:ext cx="5486400" cy="5029200"/>
-          </a:xfrm>
-          <a:prstGeom prst="rect">
-            <a:avLst/>
-          </a:prstGeom>
-          <a:noFill/>
-        </p:spPr>
-        <p:txBody>
-          <a:bodyPr wrap="square">
-            <a:spAutoFit/>
-          </a:bodyPr>
-          <a:lstStyle/>
-          <a:p>
-            <a:pPr>
-              <a:spcAft>
-                <a:spcPts val="600"/>
-              </a:spcAft>
-              <a:defRPr sz="1400">
-                <a:solidFill>
-                  <a:srgbClr val="0B0B0B"/>
-                </a:solidFill>
-              </a:defRPr>
-            </a:pPr>
-            <a:r>
-              <a:t>• GPUDirect off (−38 %, same bytes on the wire, 1.6× the time), buffer sizes (noise), NVLS vs Ring on NVLink (474 vs 388 GB/s algbw), Tree invalid for the all-gather, socket threads (7× on TCP)</a:t>
-            </a:r>
-          </a:p>
-          <a:p>
-            <a:pPr>
-              <a:spcAft>
-                <a:spcPts val="600"/>
-              </a:spcAft>
-              <a:defRPr sz="1400">
-                <a:solidFill>
-                  <a:srgbClr val="0B0B0B"/>
-                </a:solidFill>
-              </a:defRPr>
-            </a:pPr>
-            <a:r>
-              <a:t>• DDP bucket 25 → 200 MiB over the rails: 2090 → 2769 samples/s (+32 %), comm fraction 91 % → 32 % — change how often you talk before how you talk</a:t>
-            </a:r>
-          </a:p>
-        </p:txBody>
-      </p:sp>
-      <p:graphicFrame>
-        <p:nvGraphicFramePr>
-          <p:cNvPr id="4" name="Table 3"/>
-          <p:cNvGraphicFramePr>
-            <a:graphicFrameLocks noGrp="1"/>
-          </p:cNvGraphicFramePr>
-          <p:nvPr/>
-        </p:nvGraphicFramePr>
-        <p:xfrm>
-          <a:off x="6217920" y="1188720"/>
-          <a:ext cx="5486400" cy="3291839"/>
-        </p:xfrm>
-        <a:graphic>
-          <a:graphicData uri="http://schemas.openxmlformats.org/drawingml/2006/table">
-            <a:tbl>
-              <a:tblPr firstRow="1" bandRow="1">
-                <a:tableStyleId>{5C22544A-7EE6-4342-B048-85BDC9FD1C3A}</a:tableStyleId>
-              </a:tblPr>
-              <a:tblGrid>
-                <a:gridCol w="1371600"/>
-                <a:gridCol w="1371600"/>
-                <a:gridCol w="1371600"/>
-                <a:gridCol w="1371600"/>
-              </a:tblGrid>
-              <a:tr h="274319">
-                <a:tc>
-                  <a:txBody>
-                    <a:bodyPr/>
-                    <a:lstStyle/>
-                    <a:p>
-                      <a:pPr>
-                        <a:defRPr sz="900" b="1"/>
-                      </a:pPr>
-                      <a:r>
-                        <a:t>run_id</a:t>
-                      </a:r>
-                    </a:p>
-                  </a:txBody>
-                  <a:tcPr/>
-                </a:tc>
-                <a:tc>
-                  <a:txBody>
-                    <a:bodyPr/>
-                    <a:lstStyle/>
-                    <a:p>
-                      <a:pPr>
-                        <a:defRPr sz="900" b="1"/>
-                      </a:pPr>
-                      <a:r>
-                        <a:t>16MiB</a:t>
-                      </a:r>
-                    </a:p>
-                  </a:txBody>
-                  <a:tcPr/>
-                </a:tc>
-                <a:tc>
-                  <a:txBody>
-                    <a:bodyPr/>
-                    <a:lstStyle/>
-                    <a:p>
-                      <a:pPr>
-                        <a:defRPr sz="900" b="1"/>
-                      </a:pPr>
-                      <a:r>
-                        <a:t>512MiB</a:t>
-                      </a:r>
-                    </a:p>
-                  </a:txBody>
-                  <a:tcPr/>
-                </a:tc>
-                <a:tc>
-                  <a:txBody>
-                    <a:bodyPr/>
-                    <a:lstStyle/>
-                    <a:p>
-                      <a:pPr>
-                        <a:defRPr sz="900" b="1"/>
-                      </a:pPr>
-                      <a:r>
-                        <a:t>4GiB</a:t>
-                      </a:r>
-                    </a:p>
-                  </a:txBody>
-                  <a:tcPr/>
-                </a:tc>
-              </a:tr>
-              <a:tr h="274319">
-                <a:tc>
-                  <a:txBody>
-                    <a:bodyPr/>
-                    <a:lstStyle/>
-                    <a:p>
-                      <a:pPr>
-                        <a:defRPr sz="900"/>
-                      </a:pPr>
-                      <a:r>
-                        <a:t>e5-algo-nvls</a:t>
-                      </a:r>
-                    </a:p>
-                  </a:txBody>
-                  <a:tcPr/>
-                </a:tc>
-                <a:tc>
-                  <a:txBody>
-                    <a:bodyPr/>
-                    <a:lstStyle/>
-                    <a:p>
-                      <a:pPr>
-                        <a:defRPr sz="900"/>
-                      </a:pPr>
-                      <a:r>
-                        <a:t>297</a:t>
-                      </a:r>
-                    </a:p>
-                  </a:txBody>
-                  <a:tcPr/>
-                </a:tc>
-                <a:tc>
-                  <a:txBody>
-                    <a:bodyPr/>
-                    <a:lstStyle/>
-                    <a:p>
-                      <a:pPr>
-                        <a:defRPr sz="900"/>
-                      </a:pPr>
-                      <a:r>
-                        <a:t>695</a:t>
-                      </a:r>
-                    </a:p>
-                  </a:txBody>
-                  <a:tcPr/>
-                </a:tc>
-                <a:tc>
-                  <a:txBody>
-                    <a:bodyPr/>
-                    <a:lstStyle/>
-                    <a:p>
-                      <a:pPr>
-                        <a:defRPr sz="900"/>
-                      </a:pPr>
-                      <a:r>
-                        <a:t>830</a:t>
-                      </a:r>
-                    </a:p>
-                  </a:txBody>
-                  <a:tcPr/>
-                </a:tc>
-              </a:tr>
-              <a:tr h="274319">
-                <a:tc>
-                  <a:txBody>
-                    <a:bodyPr/>
-                    <a:lstStyle/>
-                    <a:p>
-                      <a:pPr>
-                        <a:defRPr sz="900"/>
-                      </a:pPr>
-                      <a:r>
-                        <a:t>e5-algo-ring</a:t>
-                      </a:r>
-                    </a:p>
-                  </a:txBody>
-                  <a:tcPr/>
-                </a:tc>
-                <a:tc>
-                  <a:txBody>
-                    <a:bodyPr/>
-                    <a:lstStyle/>
-                    <a:p>
-                      <a:pPr>
-                        <a:defRPr sz="900"/>
-                      </a:pPr>
-                      <a:r>
-                        <a:t>327</a:t>
-                      </a:r>
-                    </a:p>
-                  </a:txBody>
-                  <a:tcPr/>
-                </a:tc>
-                <a:tc>
-                  <a:txBody>
-                    <a:bodyPr/>
-                    <a:lstStyle/>
-                    <a:p>
-                      <a:pPr>
-                        <a:defRPr sz="900"/>
-                      </a:pPr>
-                      <a:r>
-                        <a:t>635</a:t>
-                      </a:r>
-                    </a:p>
-                  </a:txBody>
-                  <a:tcPr/>
-                </a:tc>
-                <a:tc>
-                  <a:txBody>
-                    <a:bodyPr/>
-                    <a:lstStyle/>
-                    <a:p>
-                      <a:pPr>
-                        <a:defRPr sz="900"/>
-                      </a:pPr>
-                      <a:r>
-                        <a:t>679</a:t>
-                      </a:r>
-                    </a:p>
-                  </a:txBody>
-                  <a:tcPr/>
-                </a:tc>
-              </a:tr>
-              <a:tr h="274319">
-                <a:tc>
-                  <a:txBody>
-                    <a:bodyPr/>
-                    <a:lstStyle/>
-                    <a:p>
-                      <a:pPr>
-                        <a:defRPr sz="900"/>
-                      </a:pPr>
-                      <a:r>
-                        <a:t>e5-buffsize16m</a:t>
-                      </a:r>
-                    </a:p>
-                  </a:txBody>
-                  <a:tcPr/>
-                </a:tc>
-                <a:tc>
-                  <a:txBody>
-                    <a:bodyPr/>
-                    <a:lstStyle/>
-                    <a:p>
-                      <a:pPr>
-                        <a:defRPr sz="900"/>
-                      </a:pPr>
-                      <a:r>
-                        <a:t>101</a:t>
-                      </a:r>
-                    </a:p>
-                  </a:txBody>
-                  <a:tcPr/>
-                </a:tc>
-                <a:tc>
-                  <a:txBody>
-                    <a:bodyPr/>
-                    <a:lstStyle/>
-                    <a:p>
-                      <a:pPr>
-                        <a:defRPr sz="900"/>
-                      </a:pPr>
-                      <a:r>
-                        <a:t>420</a:t>
-                      </a:r>
-                    </a:p>
-                  </a:txBody>
-                  <a:tcPr/>
-                </a:tc>
-                <a:tc>
-                  <a:txBody>
-                    <a:bodyPr/>
-                    <a:lstStyle/>
-                    <a:p>
-                      <a:pPr>
-                        <a:defRPr sz="900"/>
-                      </a:pPr>
-                      <a:r>
-                        <a:t>393</a:t>
-                      </a:r>
-                    </a:p>
-                  </a:txBody>
-                  <a:tcPr/>
-                </a:tc>
-              </a:tr>
-              <a:tr h="274319">
-                <a:tc>
-                  <a:txBody>
-                    <a:bodyPr/>
-                    <a:lstStyle/>
-                    <a:p>
-                      <a:pPr>
-                        <a:defRPr sz="900"/>
-                      </a:pPr>
-                      <a:r>
-                        <a:t>e5-buffsize4m</a:t>
-                      </a:r>
-                    </a:p>
-                  </a:txBody>
-                  <a:tcPr/>
-                </a:tc>
-                <a:tc>
-                  <a:txBody>
-                    <a:bodyPr/>
-                    <a:lstStyle/>
-                    <a:p>
-                      <a:pPr>
-                        <a:defRPr sz="900"/>
-                      </a:pPr>
-                      <a:r>
-                        <a:t>102</a:t>
-                      </a:r>
-                    </a:p>
-                  </a:txBody>
-                  <a:tcPr/>
-                </a:tc>
-                <a:tc>
-                  <a:txBody>
-                    <a:bodyPr/>
-                    <a:lstStyle/>
-                    <a:p>
-                      <a:pPr>
-                        <a:defRPr sz="900"/>
-                      </a:pPr>
-                      <a:r>
-                        <a:t>402</a:t>
-                      </a:r>
-                    </a:p>
-                  </a:txBody>
-                  <a:tcPr/>
-                </a:tc>
-                <a:tc>
-                  <a:txBody>
-                    <a:bodyPr/>
-                    <a:lstStyle/>
-                    <a:p>
-                      <a:pPr>
-                        <a:defRPr sz="900"/>
-                      </a:pPr>
-                      <a:r>
-                        <a:t>419</a:t>
-                      </a:r>
-                    </a:p>
-                  </a:txBody>
-                  <a:tcPr/>
-                </a:tc>
-              </a:tr>
-              <a:tr h="274319">
-                <a:tc>
-                  <a:txBody>
-                    <a:bodyPr/>
-                    <a:lstStyle/>
-                    <a:p>
-                      <a:pPr>
-                        <a:defRPr sz="900"/>
-                      </a:pPr>
-                      <a:r>
-                        <a:t>e5-counters-gdr-off</a:t>
-                      </a:r>
-                    </a:p>
-                  </a:txBody>
-                  <a:tcPr/>
-                </a:tc>
-                <a:tc>
-                  <a:txBody>
-                    <a:bodyPr/>
-                    <a:lstStyle/>
-                    <a:p>
-                      <a:pPr>
-                        <a:defRPr sz="900"/>
-                      </a:pPr>
-                      <a:r>
-                        <a:t>nan</a:t>
-                      </a:r>
-                    </a:p>
-                  </a:txBody>
-                  <a:tcPr/>
-                </a:tc>
-                <a:tc>
-                  <a:txBody>
-                    <a:bodyPr/>
-                    <a:lstStyle/>
-                    <a:p>
-                      <a:pPr>
-                        <a:defRPr sz="900"/>
-                      </a:pPr>
-                      <a:r>
-                        <a:t>nan</a:t>
-                      </a:r>
-                    </a:p>
-                  </a:txBody>
-                  <a:tcPr/>
-                </a:tc>
-                <a:tc>
-                  <a:txBody>
-                    <a:bodyPr/>
-                    <a:lstStyle/>
-                    <a:p>
-                      <a:pPr>
-                        <a:defRPr sz="900"/>
-                      </a:pPr>
-                      <a:r>
-                        <a:t>253</a:t>
-                      </a:r>
-                    </a:p>
-                  </a:txBody>
-                  <a:tcPr/>
-                </a:tc>
-              </a:tr>
-              <a:tr h="274319">
-                <a:tc>
-                  <a:txBody>
-                    <a:bodyPr/>
-                    <a:lstStyle/>
-                    <a:p>
-                      <a:pPr>
-                        <a:defRPr sz="900"/>
-                      </a:pPr>
-                      <a:r>
-                        <a:t>e5-counters-nvlink</a:t>
-                      </a:r>
-                    </a:p>
-                  </a:txBody>
-                  <a:tcPr/>
-                </a:tc>
-                <a:tc>
-                  <a:txBody>
-                    <a:bodyPr/>
-                    <a:lstStyle/>
-                    <a:p>
-                      <a:pPr>
-                        <a:defRPr sz="900"/>
-                      </a:pPr>
-                      <a:r>
-                        <a:t>nan</a:t>
-                      </a:r>
-                    </a:p>
-                  </a:txBody>
-                  <a:tcPr/>
-                </a:tc>
-                <a:tc>
-                  <a:txBody>
-                    <a:bodyPr/>
-                    <a:lstStyle/>
-                    <a:p>
-                      <a:pPr>
-                        <a:defRPr sz="900"/>
-                      </a:pPr>
-                      <a:r>
-                        <a:t>nan</a:t>
-                      </a:r>
-                    </a:p>
-                  </a:txBody>
-                  <a:tcPr/>
-                </a:tc>
-                <a:tc>
-                  <a:txBody>
-                    <a:bodyPr/>
-                    <a:lstStyle/>
-                    <a:p>
-                      <a:pPr>
-                        <a:defRPr sz="900"/>
-                      </a:pPr>
-                      <a:r>
-                        <a:t>833</a:t>
-                      </a:r>
-                    </a:p>
-                  </a:txBody>
-                  <a:tcPr/>
-                </a:tc>
-              </a:tr>
-              <a:tr h="274319">
-                <a:tc>
-                  <a:txBody>
-                    <a:bodyPr/>
-                    <a:lstStyle/>
-                    <a:p>
-                      <a:pPr>
-                        <a:defRPr sz="900"/>
-                      </a:pPr>
-                      <a:r>
-                        <a:t>e5-counters-rails1</a:t>
-                      </a:r>
-                    </a:p>
-                  </a:txBody>
-                  <a:tcPr/>
-                </a:tc>
-                <a:tc>
-                  <a:txBody>
-                    <a:bodyPr/>
-                    <a:lstStyle/>
-                    <a:p>
-                      <a:pPr>
-                        <a:defRPr sz="900"/>
-                      </a:pPr>
-                      <a:r>
-                        <a:t>nan</a:t>
-                      </a:r>
-                    </a:p>
-                  </a:txBody>
-                  <a:tcPr/>
-                </a:tc>
-                <a:tc>
-                  <a:txBody>
-                    <a:bodyPr/>
-                    <a:lstStyle/>
-                    <a:p>
-                      <a:pPr>
-                        <a:defRPr sz="900"/>
-                      </a:pPr>
-                      <a:r>
-                        <a:t>nan</a:t>
-                      </a:r>
-                    </a:p>
-                  </a:txBody>
-                  <a:tcPr/>
-                </a:tc>
-                <a:tc>
-                  <a:txBody>
-                    <a:bodyPr/>
-                    <a:lstStyle/>
-                    <a:p>
-                      <a:pPr>
-                        <a:defRPr sz="900"/>
-                      </a:pPr>
-                      <a:r>
-                        <a:t>87.8</a:t>
-                      </a:r>
-                    </a:p>
-                  </a:txBody>
-                  <a:tcPr/>
-                </a:tc>
-              </a:tr>
-              <a:tr h="274319">
-                <a:tc>
-                  <a:txBody>
-                    <a:bodyPr/>
-                    <a:lstStyle/>
-                    <a:p>
-                      <a:pPr>
-                        <a:defRPr sz="900"/>
-                      </a:pPr>
-                      <a:r>
-                        <a:t>e5-counters-rdma</a:t>
-                      </a:r>
-                    </a:p>
-                  </a:txBody>
-                  <a:tcPr/>
-                </a:tc>
-                <a:tc>
-                  <a:txBody>
-                    <a:bodyPr/>
-                    <a:lstStyle/>
-                    <a:p>
-                      <a:pPr>
-                        <a:defRPr sz="900"/>
-                      </a:pPr>
-                      <a:r>
-                        <a:t>nan</a:t>
-                      </a:r>
-                    </a:p>
-                  </a:txBody>
-                  <a:tcPr/>
-                </a:tc>
-                <a:tc>
-                  <a:txBody>
-                    <a:bodyPr/>
-                    <a:lstStyle/>
-                    <a:p>
-                      <a:pPr>
-                        <a:defRPr sz="900"/>
-                      </a:pPr>
-                      <a:r>
-                        <a:t>nan</a:t>
-                      </a:r>
-                    </a:p>
-                  </a:txBody>
-                  <a:tcPr/>
-                </a:tc>
-                <a:tc>
-                  <a:txBody>
-                    <a:bodyPr/>
-                    <a:lstStyle/>
-                    <a:p>
-                      <a:pPr>
-                        <a:defRPr sz="900"/>
-                      </a:pPr>
-                      <a:r>
-                        <a:t>410</a:t>
-                      </a:r>
-                    </a:p>
-                  </a:txBody>
-                  <a:tcPr/>
-                </a:tc>
-              </a:tr>
-              <a:tr h="274319">
-                <a:tc>
-                  <a:txBody>
-                    <a:bodyPr/>
-                    <a:lstStyle/>
-                    <a:p>
-                      <a:pPr>
-                        <a:defRPr sz="900"/>
-                      </a:pPr>
-                      <a:r>
-                        <a:t>e5-counters-rdma-qps4</a:t>
-                      </a:r>
-                    </a:p>
-                  </a:txBody>
-                  <a:tcPr/>
-                </a:tc>
-                <a:tc>
-                  <a:txBody>
-                    <a:bodyPr/>
-                    <a:lstStyle/>
-                    <a:p>
-                      <a:pPr>
-                        <a:defRPr sz="900"/>
-                      </a:pPr>
-                      <a:r>
-                        <a:t>nan</a:t>
-                      </a:r>
-                    </a:p>
-                  </a:txBody>
-                  <a:tcPr/>
-                </a:tc>
-                <a:tc>
-                  <a:txBody>
-                    <a:bodyPr/>
-                    <a:lstStyle/>
-                    <a:p>
-                      <a:pPr>
-                        <a:defRPr sz="900"/>
-                      </a:pPr>
-                      <a:r>
-                        <a:t>nan</a:t>
-                      </a:r>
-                    </a:p>
-                  </a:txBody>
-                  <a:tcPr/>
-                </a:tc>
-                <a:tc>
-                  <a:txBody>
-                    <a:bodyPr/>
-                    <a:lstStyle/>
-                    <a:p>
-                      <a:pPr>
-                        <a:defRPr sz="900"/>
-                      </a:pPr>
-                      <a:r>
-                        <a:t>301</a:t>
-                      </a:r>
-                    </a:p>
-                  </a:txBody>
-                  <a:tcPr/>
-                </a:tc>
-              </a:tr>
-              <a:tr h="274319">
-                <a:tc>
-                  <a:txBody>
-                    <a:bodyPr/>
-                    <a:lstStyle/>
-                    <a:p>
-                      <a:pPr>
-                        <a:defRPr sz="900"/>
-                      </a:pPr>
-                      <a:r>
-                        <a:t>e5-gdr-off</a:t>
-                      </a:r>
-                    </a:p>
-                  </a:txBody>
-                  <a:tcPr/>
-                </a:tc>
-                <a:tc>
-                  <a:txBody>
-                    <a:bodyPr/>
-                    <a:lstStyle/>
-                    <a:p>
-                      <a:pPr>
-                        <a:defRPr sz="900"/>
-                      </a:pPr>
-                      <a:r>
-                        <a:t>107</a:t>
-                      </a:r>
-                    </a:p>
-                  </a:txBody>
-                  <a:tcPr/>
-                </a:tc>
-                <a:tc>
-                  <a:txBody>
-                    <a:bodyPr/>
-                    <a:lstStyle/>
-                    <a:p>
-                      <a:pPr>
-                        <a:defRPr sz="900"/>
-                      </a:pPr>
-                      <a:r>
-                        <a:t>222</a:t>
-                      </a:r>
-                    </a:p>
-                  </a:txBody>
-                  <a:tcPr/>
-                </a:tc>
-                <a:tc>
-                  <a:txBody>
-                    <a:bodyPr/>
-                    <a:lstStyle/>
-                    <a:p>
-                      <a:pPr>
-                        <a:defRPr sz="900"/>
-                      </a:pPr>
-                      <a:r>
-                        <a:t>247</a:t>
-                      </a:r>
-                    </a:p>
-                  </a:txBody>
-                  <a:tcPr/>
-                </a:tc>
-              </a:tr>
-              <a:tr h="274330">
-                <a:tc>
-                  <a:txBody>
-                    <a:bodyPr/>
-                    <a:lstStyle/>
-                    <a:p>
-                      <a:pPr>
-                        <a:defRPr sz="900"/>
-                      </a:pPr>
-                      <a:r>
-                        <a:t>e5-sock-nthreads4</a:t>
-                      </a:r>
-                    </a:p>
-                  </a:txBody>
-                  <a:tcPr/>
-                </a:tc>
-                <a:tc>
-                  <a:txBody>
-                    <a:bodyPr/>
-                    <a:lstStyle/>
-                    <a:p>
-                      <a:pPr>
-                        <a:defRPr sz="900"/>
-                      </a:pPr>
-                      <a:r>
-                        <a:t>10.3</a:t>
-                      </a:r>
-                    </a:p>
-                  </a:txBody>
-                  <a:tcPr/>
-                </a:tc>
-                <a:tc>
-                  <a:txBody>
-                    <a:bodyPr/>
-                    <a:lstStyle/>
-                    <a:p>
-                      <a:pPr>
-                        <a:defRPr sz="900"/>
-                      </a:pPr>
-                      <a:r>
-                        <a:t>21.6</a:t>
-                      </a:r>
-                    </a:p>
-                  </a:txBody>
-                  <a:tcPr/>
-                </a:tc>
-                <a:tc>
-                  <a:txBody>
-                    <a:bodyPr/>
-                    <a:lstStyle/>
-                    <a:p>
-                      <a:pPr>
-                        <a:defRPr sz="900"/>
-                      </a:pPr>
-                      <a:r>
-                        <a:t>29.4</a:t>
-                      </a:r>
-                    </a:p>
-                  </a:txBody>
-                  <a:tcPr/>
-                </a:tc>
-              </a:tr>
-            </a:tbl>
-          </a:graphicData>
-        </a:graphic>
-      </p:graphicFrame>
-    </p:spTree>
-  </p:cSld>
-  <p:clrMapOvr>
-    <a:masterClrMapping/>
-  </p:clrMapOvr>
-</p:sld>
-</file>
-
-<file path=ppt/slides/slide11.xml><?xml version="1.0" encoding="utf-8"?>
-<p:sld xmlns:a="http://schemas.openxmlformats.org/drawingml/2006/main" xmlns:p="http://schemas.openxmlformats.org/presentationml/2006/main" xmlns:r="http://schemas.openxmlformats.org/officeDocument/2006/relationships">
-  <p:cSld>
-    <p:spTree>
-      <p:nvGrpSpPr>
-        <p:cNvPr id="1" name=""/>
-        <p:cNvGrpSpPr/>
-        <p:nvPr/>
-      </p:nvGrpSpPr>
-      <p:grpSpPr/>
-      <p:sp>
-        <p:nvSpPr>
-          <p:cNvPr id="2" name="TextBox 1"/>
-          <p:cNvSpPr txBox="1"/>
-          <p:nvPr/>
-        </p:nvSpPr>
-        <p:spPr>
-          <a:xfrm>
-            <a:off x="457200" y="274320"/>
-            <a:ext cx="11247120" cy="822960"/>
-          </a:xfrm>
-          <a:prstGeom prst="rect">
-            <a:avLst/>
-          </a:prstGeom>
-          <a:noFill/>
-        </p:spPr>
-        <p:txBody>
-          <a:bodyPr wrap="none">
-            <a:spAutoFit/>
-          </a:bodyPr>
-          <a:lstStyle/>
-          <a:p>
-            <a:pPr>
-              <a:defRPr sz="2600" b="1">
-                <a:solidFill>
-                  <a:srgbClr val="0B0B0B"/>
-                </a:solidFill>
-              </a:defRPr>
-            </a:pPr>
-            <a:r>
-              <a:t>5 · Extending to production multi-node GPU systems</a:t>
+              <a:t>5 · Extending this to production multi-node GPU systems</a:t>
             </a:r>
           </a:p>
         </p:txBody>
@@ -4110,7 +4326,7 @@
               </a:defRPr>
             </a:pPr>
             <a:r>
-              <a:t>• Same manifests scale by nnodes: one pod per tray, one claim per pod; rails per pod and GID discovery stay per-node decisions</a:t>
+              <a:t>• The manifests scale by node count: one pod per tray, one GPU claim and one rail claim per pod; the same image, the same result schema</a:t>
             </a:r>
           </a:p>
           <a:p>
@@ -4125,7 +4341,7 @@
               </a:defRPr>
             </a:pPr>
             <a:r>
-              <a:t>• Fleet health: the counters watched here (rail bytes, CNPs, pause, NVLink errors, transport fallbacks) become alert rules; a silent NET/Socket fallback is a FAIL, not a slow run</a:t>
+              <a:t>• Placement follows topology: inside an NVLink domain use NVLink; between domains budget for the rails and size gradient buckets or accumulation accordingly</a:t>
             </a:r>
           </a:p>
           <a:p>
@@ -4140,7 +4356,7 @@
               </a:defRPr>
             </a:pPr>
             <a:r>
-              <a:t>• Gang scheduling (Kueue) and topology labels (NVLink clique, fabric block) place jobs where the fast path exists</a:t>
+              <a:t>• The counters watched here become alerts: a fabric run whose NCCL log shows TCP fallback is a failure, not a slow run; congestion or sequence errors per rail are the network's signal; a rail below its share of line rate during a known-good collective is a rail fault</a:t>
             </a:r>
           </a:p>
           <a:p>
@@ -4155,85 +4371,9 @@
               </a:defRPr>
             </a:pPr>
             <a:r>
-              <a:t>• Rack-scale: multi-node NVLink inside the clique, the rails between racks; floors are calibrated per width and message size</a:t>
-            </a:r>
-          </a:p>
-        </p:txBody>
-      </p:sp>
-    </p:spTree>
-  </p:cSld>
-  <p:clrMapOvr>
-    <a:masterClrMapping/>
-  </p:clrMapOvr>
-</p:sld>
-</file>
-
-<file path=ppt/slides/slide12.xml><?xml version="1.0" encoding="utf-8"?>
-<p:sld xmlns:a="http://schemas.openxmlformats.org/drawingml/2006/main" xmlns:p="http://schemas.openxmlformats.org/presentationml/2006/main" xmlns:r="http://schemas.openxmlformats.org/officeDocument/2006/relationships">
-  <p:cSld>
-    <p:spTree>
-      <p:nvGrpSpPr>
-        <p:cNvPr id="1" name=""/>
-        <p:cNvGrpSpPr/>
-        <p:nvPr/>
-      </p:nvGrpSpPr>
-      <p:grpSpPr/>
-      <p:sp>
-        <p:nvSpPr>
-          <p:cNvPr id="2" name="TextBox 1"/>
-          <p:cNvSpPr txBox="1"/>
-          <p:nvPr/>
-        </p:nvSpPr>
-        <p:spPr>
-          <a:xfrm>
-            <a:off x="457200" y="274320"/>
-            <a:ext cx="11247120" cy="822960"/>
-          </a:xfrm>
-          <a:prstGeom prst="rect">
-            <a:avLst/>
-          </a:prstGeom>
-          <a:noFill/>
-        </p:spPr>
-        <p:txBody>
-          <a:bodyPr wrap="none">
-            <a:spAutoFit/>
-          </a:bodyPr>
-          <a:lstStyle/>
-          <a:p>
-            <a:pPr>
-              <a:defRPr sz="2600" b="1">
-                <a:solidFill>
-                  <a:srgbClr val="0B0B0B"/>
-                </a:solidFill>
-              </a:defRPr>
-            </a:pPr>
-            <a:r>
-              <a:t>Live demo plan (docs/demo.md)</a:t>
-            </a:r>
-          </a:p>
-        </p:txBody>
-      </p:sp>
-      <p:sp>
-        <p:nvSpPr>
-          <p:cNvPr id="3" name="TextBox 2"/>
-          <p:cNvSpPr txBox="1"/>
-          <p:nvPr/>
-        </p:nvSpPr>
-        <p:spPr>
-          <a:xfrm>
-            <a:off x="548640" y="1188720"/>
-            <a:ext cx="10972800" cy="5029200"/>
-          </a:xfrm>
-          <a:prstGeom prst="rect">
-            <a:avLst/>
-          </a:prstGeom>
-          <a:noFill/>
-        </p:spPr>
-        <p:txBody>
-          <a:bodyPr wrap="square">
-            <a:spAutoFit/>
-          </a:bodyPr>
-          <a:lstStyle/>
+              <a:t>• Floors are calibrated per rank count and message size, because bus bandwidth is not constant across either — the sweep here is the reference shape</a:t>
+            </a:r>
+          </a:p>
           <a:p>
             <a:pPr>
               <a:spcAft>
@@ -4246,67 +4386,7 @@
               </a:defRPr>
             </a:pPr>
             <a:r>
-              <a:t>• Bring-up (~7 min, talk over it): preflight 45 s → k8s-up ~4 min → GPU Operator in DRA mode ~1.5 min → dranet fork + DeviceClass ~1 min</a:t>
-            </a:r>
-          </a:p>
-          <a:p>
-            <a:pPr>
-              <a:spcAft>
-                <a:spcPts val="600"/>
-              </a:spcAft>
-              <a:defRPr sz="1400">
-                <a:solidFill>
-                  <a:srgbClr val="0B0B0B"/>
-                </a:solidFill>
-              </a:defRPr>
-            </a:pPr>
-            <a:r>
-              <a:t>• Probe (~1 min warm): host GID table vs pod GID table, host still owns the VF, pingpong on the discovered GID</a:t>
-            </a:r>
-          </a:p>
-          <a:p>
-            <a:pPr>
-              <a:spcAft>
-                <a:spcPts val="600"/>
-              </a:spcAft>
-              <a:defRPr sz="1400">
-                <a:solidFill>
-                  <a:srgbClr val="0B0B0B"/>
-                </a:solidFill>
-              </a:defRPr>
-            </a:pPr>
-            <a:r>
-              <a:t>• Three counter-window cells (~1 min each): NVLink, 4 rails, 1 rail — watched live on the fabric dashboard</a:t>
-            </a:r>
-          </a:p>
-          <a:p>
-            <a:pPr>
-              <a:spcAft>
-                <a:spcPts val="600"/>
-              </a:spcAft>
-              <a:defRPr sz="1400">
-                <a:solidFill>
-                  <a:srgbClr val="0B0B0B"/>
-                </a:solidFill>
-              </a:defRPr>
-            </a:pPr>
-            <a:r>
-              <a:t>• Dashboard tour: NVLink bytes per GPU → rails at ~480 Gb/s each → flat CNP/ECN/out-of-sequence → TCP cells show up only on the management NIC and host CPU</a:t>
-            </a:r>
-          </a:p>
-          <a:p>
-            <a:pPr>
-              <a:spcAft>
-                <a:spcPts val="600"/>
-              </a:spcAft>
-              <a:defRPr sz="1400">
-                <a:solidFill>
-                  <a:srgbClr val="0B0B0B"/>
-                </a:solidFill>
-              </a:defRPr>
-            </a:pPr>
-            <a:r>
-              <a:t>• Fallback: everything in results/ is committed and regenerable (make analyze); teardown k8s-down ~3 min, trays verified clean</a:t>
+              <a:t>• The whole environment is reproducible from the repository: bootstrap, manifests, image build, results, analysis and this deck</a:t>
             </a:r>
           </a:p>
         </p:txBody>
@@ -4359,124 +4439,35 @@
               </a:defRPr>
             </a:pPr>
             <a:r>
-              <a:t>1 · Architecture and design choices</a:t>
+              <a:t>1 · Architecture: two trays, three networks, one Job per experiment</a:t>
             </a:r>
           </a:p>
         </p:txBody>
       </p:sp>
-      <p:sp>
-        <p:nvSpPr>
-          <p:cNvPr id="3" name="TextBox 2"/>
-          <p:cNvSpPr txBox="1"/>
+      <p:pic>
+        <p:nvPicPr>
+          <p:cNvPr id="3" name="Picture 2" descr="architecture.png"/>
+          <p:cNvPicPr>
+            <a:picLocks noChangeAspect="1"/>
+          </p:cNvPicPr>
           <p:nvPr/>
-        </p:nvSpPr>
+        </p:nvPicPr>
+        <p:blipFill>
+          <a:blip r:embed="rId3"/>
+          <a:stretch>
+            <a:fillRect/>
+          </a:stretch>
+        </p:blipFill>
         <p:spPr>
           <a:xfrm>
-            <a:off x="548640" y="1188720"/>
-            <a:ext cx="10972800" cy="5029200"/>
+            <a:off x="1166914" y="1051560"/>
+            <a:ext cx="9857866" cy="5577840"/>
           </a:xfrm>
           <a:prstGeom prst="rect">
             <a:avLst/>
           </a:prstGeom>
-          <a:noFill/>
         </p:spPr>
-        <p:txBody>
-          <a:bodyPr wrap="square">
-            <a:spAutoFit/>
-          </a:bodyPr>
-          <a:lstStyle/>
-          <a:p>
-            <a:pPr>
-              <a:spcAft>
-                <a:spcPts val="600"/>
-              </a:spcAft>
-              <a:defRPr sz="1400">
-                <a:solidFill>
-                  <a:srgbClr val="0B0B0B"/>
-                </a:solidFill>
-              </a:defRPr>
-            </a:pPr>
-            <a:r>
-              <a:t>• Two GB300 trays (4 GPUs + 4 RDMA rail VFs each) leased from a shared Slurm pool; k3s + Cilium via the vendored bootstrap</a:t>
-            </a:r>
-          </a:p>
-          <a:p>
-            <a:pPr>
-              <a:spcAft>
-                <a:spcPts val="600"/>
-              </a:spcAft>
-              <a:defRPr sz="1400">
-                <a:solidFill>
-                  <a:srgbClr val="0B0B0B"/>
-                </a:solidFill>
-              </a:defRPr>
-            </a:pPr>
-            <a:r>
-              <a:t>• GPUs through the NVIDIA DRA driver (ResourceClaim, DeviceClass gpu.nvidia.com); NICs through a dranet fork: IPVLAN children of the rail VFs, RDMA reached in shared netns mode — nothing leaves the host, no hostNetwork anywhere</a:t>
-            </a:r>
-          </a:p>
-          <a:p>
-            <a:pPr>
-              <a:spcAft>
-                <a:spcPts val="600"/>
-              </a:spcAft>
-              <a:defRPr sz="1400">
-                <a:solidFill>
-                  <a:srgbClr val="0B0B0B"/>
-                </a:solidFill>
-              </a:defRPr>
-            </a:pPr>
-            <a:r>
-              <a:t>• One image (thin layer on NGC PyTorch), one Indexed Job per cell, torchrun 2×4 ranks, rendezvous via a headless Service</a:t>
-            </a:r>
-          </a:p>
-          <a:p>
-            <a:pPr>
-              <a:spcAft>
-                <a:spcPts val="600"/>
-              </a:spcAft>
-              <a:defRPr sz="1400">
-                <a:solidFill>
-                  <a:srgbClr val="0B0B0B"/>
-                </a:solidFill>
-              </a:defRPr>
-            </a:pPr>
-            <a:r>
-              <a:t>• Every run writes a schema-validated result.json + per-rank CSV; a 1 Hz watcher samples the RDMA, NIC and DCGM counters behind the numbers</a:t>
-            </a:r>
-          </a:p>
-          <a:p>
-            <a:pPr>
-              <a:spcAft>
-                <a:spcPts val="600"/>
-              </a:spcAft>
-              <a:defRPr sz="1400">
-                <a:solidFill>
-                  <a:srgbClr val="0B0B0B"/>
-                </a:solidFill>
-              </a:defRPr>
-            </a:pPr>
-            <a:r>
-              <a:t>• CI: ruff, pytest (no GPU), manifest drift check, Terraform validate, analysis smoke; arm64 image to ghcr.io (mirrored to Quay)</a:t>
-            </a:r>
-          </a:p>
-          <a:p>
-            <a:pPr>
-              <a:spcAft>
-                <a:spcPts val="600"/>
-              </a:spcAft>
-              <a:defRPr sz="1400">
-                <a:solidFill>
-                  <a:srgbClr val="0B0B0B"/>
-                </a:solidFill>
-              </a:defRPr>
-            </a:pPr>
-            <a:r>
-              <a:t>• Observability: host exporters (DCGM :9400, RDMA :9500, NVLink :9600, node :9100) shipped to Grafana Cloud by Terraform-managed Alloy; one fabric dashboard</a:t>
-            </a:r>
-          </a:p>
-        </p:txBody>
-      </p:sp>
+      </p:pic>
     </p:spTree>
   </p:cSld>
   <p:clrMapOvr>
@@ -4525,7 +4516,7 @@
               </a:defRPr>
             </a:pPr>
             <a:r>
-              <a:t>1 · Why DRA, why dranet (the fork), why Cilium</a:t>
+              <a:t>1 · Why DRA instead of the device plugin, and why dranet for the NICs</a:t>
             </a:r>
           </a:p>
         </p:txBody>
@@ -4563,7 +4554,7 @@
               </a:defRPr>
             </a:pPr>
             <a:r>
-              <a:t>• DRA (GA in Kubernetes 1.34): GPUs and NICs are structured devices with attributes; a ResourceClaim per pod against a DeviceClass — one mechanism for both device kinds, visible to the scheduler</a:t>
+              <a:t>• Device plugin (the old way): a node advertises an opaque count such as nvidia.com/gpu: 4; the scheduler only counts; a pod cannot say which GPU, cannot ask for a NIC that matches its GPU, and cannot see device attributes</a:t>
             </a:r>
           </a:p>
           <a:p>
@@ -4578,7 +4569,7 @@
               </a:defRPr>
             </a:pPr>
             <a:r>
-              <a:t>• dranet upstream moves the NIC into the pod; on this site that drains the tray (host health check inventories the rails). The fork adds IPVLAN children: the VF stays on the host, the pod gets a child with its own SLAAC address, RDMA reached in shared netns mode — no hostNetwork, no privilege, host inventory unchanged</a:t>
+              <a:t>• DRA (Dynamic Resource Allocation, GA in Kubernetes 1.34): devices are published as structured objects with attributes; a pod writes a ResourceClaim against a DeviceClass; the scheduler allocates the concrete devices and the pod's manifest says exactly what it got</a:t>
             </a:r>
           </a:p>
           <a:p>
@@ -4593,7 +4584,7 @@
               </a:defRPr>
             </a:pPr>
             <a:r>
-              <a:t>• Shared RDMA netns mode can only be set with no pod namespace alive → the bootstrap sets it on the fresh tray before k3s and restores it at teardown (do-no-harm on borrowed hardware)</a:t>
+              <a:t>• One mechanism for GPUs and NICs: the GPU Operator publishes gpu.nvidia.com; the dranet driver publishes the rail NICs as dra.net devices with their name, RDMA capability and PCI address — so a pod claims 4 GPUs and the rails it needs in the same manifest, and we can vary the rail count (1, 2, 4) per experiment without touching the host</a:t>
             </a:r>
           </a:p>
           <a:p>
@@ -4608,7 +4599,7 @@
               </a:defRPr>
             </a:pPr>
             <a:r>
-              <a:t>• Cilium 1.20: eBPF kube-proxy replacement (no iptables churn on a host whose health check watches routes), geneve tunnel on the management NIC (site never learns pod CIDRs, no BGP, no LB IPs), Hubble for flow evidence — and the data plane never touches it</a:t>
+              <a:t>• Why the dranet fork: upstream moves the NIC into the pod, which on this site trips the node health check and gets the tray drained. The fork gives the pod an IPVLAN child of the rail instead — the NIC and its RDMA device stay on the host, the pod still gets RDMA (shared RDMA namespace mode, set at node bring-up before Kubernetes starts)</a:t>
             </a:r>
           </a:p>
         </p:txBody>
@@ -4661,143 +4652,7 @@
               </a:defRPr>
             </a:pPr>
             <a:r>
-              <a:t>1 · The RoCE GID index: discovered, not assumed</a:t>
-            </a:r>
-          </a:p>
-        </p:txBody>
-      </p:sp>
-      <p:sp>
-        <p:nvSpPr>
-          <p:cNvPr id="3" name="TextBox 2"/>
-          <p:cNvSpPr txBox="1"/>
-          <p:nvPr/>
-        </p:nvSpPr>
-        <p:spPr>
-          <a:xfrm>
-            <a:off x="548640" y="1188720"/>
-            <a:ext cx="10972800" cy="5029200"/>
-          </a:xfrm>
-          <a:prstGeom prst="rect">
-            <a:avLst/>
-          </a:prstGeom>
-          <a:noFill/>
-        </p:spPr>
-        <p:txBody>
-          <a:bodyPr wrap="square">
-            <a:spAutoFit/>
-          </a:bodyPr>
-          <a:lstStyle/>
-          <a:p>
-            <a:pPr>
-              <a:spcAft>
-                <a:spcPts val="600"/>
-              </a:spcAft>
-              <a:defRPr sz="1400">
-                <a:solidFill>
-                  <a:srgbClr val="0B0B0B"/>
-                </a:solidFill>
-              </a:defRPr>
-            </a:pPr>
-            <a:r>
-              <a:t>• GID table = two entries per IP address (RoCE v1, RoCE v2): link-local at 0/1, the VF's global at 2/3 → index 3 on the host</a:t>
-            </a:r>
-          </a:p>
-          <a:p>
-            <a:pPr>
-              <a:spcAft>
-                <a:spcPts val="600"/>
-              </a:spcAft>
-              <a:defRPr sz="1400">
-                <a:solidFill>
-                  <a:srgbClr val="0B0B0B"/>
-                </a:solidFill>
-              </a:defRPr>
-            </a:pPr>
-            <a:r>
-              <a:t>• In the pod the IPVLAN child's addresses land at 4–7 (namespace-scoped view) → index 7; a second pod on the same rail would be 11</a:t>
-            </a:r>
-          </a:p>
-          <a:p>
-            <a:pPr>
-              <a:spcAft>
-                <a:spcPts val="600"/>
-              </a:spcAft>
-              <a:defRPr sz="1400">
-                <a:solidFill>
-                  <a:srgbClr val="0B0B0B"/>
-                </a:solidFill>
-              </a:defRPr>
-            </a:pPr>
-            <a:r>
-              <a:t>• bench/gid.py: only HCAs whose uverbs char device is in the pod; RoCE v2 + global; every claimed rail must agree; exported as NCCL_IB_GID_INDEX by the pre-check after a router solicitation (a fresh child has link-local only)</a:t>
-            </a:r>
-          </a:p>
-          <a:p>
-            <a:pPr>
-              <a:spcAft>
-                <a:spcPts val="600"/>
-              </a:spcAft>
-              <a:defRPr sz="1400">
-                <a:solidFill>
-                  <a:srgbClr val="0B0B0B"/>
-                </a:solidFill>
-              </a:defRPr>
-            </a:pPr>
-            <a:r>
-              <a:t>• Wrong index = QP connect failures or a connected communicator moving zero bytes; ibv_rc_pingpong on index 7: 12–15 µs at 4 KiB, ~120 µs per 1 MiB round trip</a:t>
-            </a:r>
-          </a:p>
-        </p:txBody>
-      </p:sp>
-    </p:spTree>
-  </p:cSld>
-  <p:clrMapOvr>
-    <a:masterClrMapping/>
-  </p:clrMapOvr>
-</p:sld>
-</file>
-
-<file path=ppt/slides/slide5.xml><?xml version="1.0" encoding="utf-8"?>
-<p:sld xmlns:a="http://schemas.openxmlformats.org/drawingml/2006/main" xmlns:p="http://schemas.openxmlformats.org/presentationml/2006/main" xmlns:r="http://schemas.openxmlformats.org/officeDocument/2006/relationships">
-  <p:cSld>
-    <p:spTree>
-      <p:nvGrpSpPr>
-        <p:cNvPr id="1" name=""/>
-        <p:cNvGrpSpPr/>
-        <p:nvPr/>
-      </p:nvGrpSpPr>
-      <p:grpSpPr/>
-      <p:sp>
-        <p:nvSpPr>
-          <p:cNvPr id="2" name="TextBox 1"/>
-          <p:cNvSpPr txBox="1"/>
-          <p:nvPr/>
-        </p:nvSpPr>
-        <p:spPr>
-          <a:xfrm>
-            <a:off x="457200" y="274320"/>
-            <a:ext cx="11247120" cy="822960"/>
-          </a:xfrm>
-          <a:prstGeom prst="rect">
-            <a:avLst/>
-          </a:prstGeom>
-          <a:noFill/>
-        </p:spPr>
-        <p:txBody>
-          <a:bodyPr wrap="none">
-            <a:spAutoFit/>
-          </a:bodyPr>
-          <a:lstStyle/>
-          <a:p>
-            <a:pPr>
-              <a:defRPr sz="2600" b="1">
-                <a:solidFill>
-                  <a:srgbClr val="0B0B0B"/>
-                </a:solidFill>
-              </a:defRPr>
-            </a:pPr>
-            <a:r>
-              <a:t>2 · Baseline: all-reduce vs message size, three transports</a:t>
+              <a:t>2 · Baseline: all-reduce bandwidth grows with message size, and the network path sets the ceiling</a:t>
             </a:r>
           </a:p>
         </p:txBody>
@@ -4811,7 +4666,7 @@
           <p:nvPr/>
         </p:nvPicPr>
         <p:blipFill>
-          <a:blip r:embed="rId2"/>
+          <a:blip r:embed="rId3"/>
           <a:stretch>
             <a:fillRect/>
           </a:stretch>
@@ -4859,7 +4714,7 @@
               </a:defRPr>
             </a:pPr>
             <a:r>
-              <a:t>• Bus bandwidth rises with message size until the pipeline is full: fixed per-collective latency dominates small messages, the wire dominates large ones</a:t>
+              <a:t>• Same 8-GPU all-reduce, three paths. Over NVLink it reaches 835 GB/s; over the four RDMA rails about 425 GB/s; over TCP on one rail 118 GB/s; over TCP on the pod overlay 4 GB/s</a:t>
             </a:r>
           </a:p>
           <a:p>
@@ -4874,7 +4729,22 @@
               </a:defRPr>
             </a:pPr>
             <a:r>
-              <a:t>• Transport is proven from NCCL's own channel report (P2P/MNNVL · NET/IB/GDRDMA · NET/Socket), not inferred from speed</a:t>
+              <a:t>• Small messages are slow on every path because fixed per-operation costs dominate; from a few hundred MiB the wire dominates and the paths separate</a:t>
+            </a:r>
+          </a:p>
+          <a:p>
+            <a:pPr>
+              <a:spcAft>
+                <a:spcPts val="600"/>
+              </a:spcAft>
+              <a:defRPr sz="1200">
+                <a:solidFill>
+                  <a:srgbClr val="0B0B0B"/>
+                </a:solidFill>
+              </a:defRPr>
+            </a:pPr>
+            <a:r>
+              <a:t>• Which path was actually used is read from NCCL's own connection log for every run, not guessed from the speed</a:t>
             </a:r>
           </a:p>
         </p:txBody>
@@ -5378,7 +5248,7 @@
 </p:sld>
 </file>
 
-<file path=ppt/slides/slide6.xml><?xml version="1.0" encoding="utf-8"?>
+<file path=ppt/slides/slide5.xml><?xml version="1.0" encoding="utf-8"?>
 <p:sld xmlns:a="http://schemas.openxmlformats.org/drawingml/2006/main" xmlns:p="http://schemas.openxmlformats.org/presentationml/2006/main" xmlns:r="http://schemas.openxmlformats.org/officeDocument/2006/relationships">
   <p:cSld>
     <p:spTree>
@@ -5418,7 +5288,7 @@
               </a:defRPr>
             </a:pPr>
             <a:r>
-              <a:t>2 · Baseline: small messages are latency-bound</a:t>
+              <a:t>2 · Small messages: the latency floor</a:t>
             </a:r>
           </a:p>
         </p:txBody>
@@ -5432,7 +5302,7 @@
           <p:nvPr/>
         </p:nvPicPr>
         <p:blipFill>
-          <a:blip r:embed="rId2"/>
+          <a:blip r:embed="rId3"/>
           <a:stretch>
             <a:fillRect/>
           </a:stretch>
@@ -5447,9 +5317,62 @@
           </a:prstGeom>
         </p:spPr>
       </p:pic>
+      <p:sp>
+        <p:nvSpPr>
+          <p:cNvPr id="4" name="TextBox 3"/>
+          <p:cNvSpPr txBox="1"/>
+          <p:nvPr/>
+        </p:nvSpPr>
+        <p:spPr>
+          <a:xfrm>
+            <a:off x="7589520" y="1188720"/>
+            <a:ext cx="4206240" cy="5029200"/>
+          </a:xfrm>
+          <a:prstGeom prst="rect">
+            <a:avLst/>
+          </a:prstGeom>
+          <a:noFill/>
+        </p:spPr>
+        <p:txBody>
+          <a:bodyPr wrap="square">
+            <a:spAutoFit/>
+          </a:bodyPr>
+          <a:lstStyle/>
+          <a:p>
+            <a:pPr>
+              <a:spcAft>
+                <a:spcPts val="600"/>
+              </a:spcAft>
+              <a:defRPr sz="1200">
+                <a:solidFill>
+                  <a:srgbClr val="0B0B0B"/>
+                </a:solidFill>
+              </a:defRPr>
+            </a:pPr>
+            <a:r>
+              <a:t>• Between 4 KiB and 1 MiB an all-reduce costs roughly the same time whatever the size: around 20 to 80 microseconds</a:t>
+            </a:r>
+          </a:p>
+          <a:p>
+            <a:pPr>
+              <a:spcAft>
+                <a:spcPts val="600"/>
+              </a:spcAft>
+              <a:defRPr sz="1200">
+                <a:solidFill>
+                  <a:srgbClr val="0B0B0B"/>
+                </a:solidFill>
+              </a:defRPr>
+            </a:pPr>
+            <a:r>
+              <a:t>• That fixed cost is the reason a training step with many small gradient messages does not benefit from a faster wire — see the DDP bucket result later</a:t>
+            </a:r>
+          </a:p>
+        </p:txBody>
+      </p:sp>
       <p:graphicFrame>
         <p:nvGraphicFramePr>
-          <p:cNvPr id="4" name="Table 3"/>
+          <p:cNvPr id="5" name="Table 4"/>
           <p:cNvGraphicFramePr>
             <a:graphicFrameLocks noGrp="1"/>
           </p:cNvGraphicFramePr>
@@ -5764,7 +5687,7 @@
 </p:sld>
 </file>
 
-<file path=ppt/slides/slide7.xml><?xml version="1.0" encoding="utf-8"?>
+<file path=ppt/slides/slide6.xml><?xml version="1.0" encoding="utf-8"?>
 <p:sld xmlns:a="http://schemas.openxmlformats.org/drawingml/2006/main" xmlns:p="http://schemas.openxmlformats.org/presentationml/2006/main" xmlns:r="http://schemas.openxmlformats.org/officeDocument/2006/relationships">
   <p:cSld>
     <p:spTree>
@@ -5804,7 +5727,7 @@
               </a:defRPr>
             </a:pPr>
             <a:r>
-              <a:t>2 · Scaling: the DDP workload at 1 → 8 GPUs</a:t>
+              <a:t>2 · Scaling: the training workload from 1 to 8 GPUs</a:t>
             </a:r>
           </a:p>
         </p:txBody>
@@ -5818,7 +5741,7 @@
           <p:nvPr/>
         </p:nvPicPr>
         <p:blipFill>
-          <a:blip r:embed="rId2"/>
+          <a:blip r:embed="rId3"/>
           <a:stretch>
             <a:fillRect/>
           </a:stretch>
@@ -5866,7 +5789,37 @@
               </a:defRPr>
             </a:pPr>
             <a:r>
-              <a:t>• Efficiency = throughput / (N × single-GPU throughput); the comm fraction is NCCL kernel time over step time from torch.profiler</a:t>
+              <a:t>• Workload: a 124M-parameter GPT trained with PyTorch DDP on synthetic tokens; the same code runs at 1, 2, 4 GPUs on one tray and at 8 GPUs across two trays</a:t>
+            </a:r>
+          </a:p>
+          <a:p>
+            <a:pPr>
+              <a:spcAft>
+                <a:spcPts val="600"/>
+              </a:spcAft>
+              <a:defRPr sz="1200">
+                <a:solidFill>
+                  <a:srgbClr val="0B0B0B"/>
+                </a:solidFill>
+              </a:defRPr>
+            </a:pPr>
+            <a:r>
+              <a:t>• Efficiency = throughput divided by (N times the single-GPU throughput). 93 % at 2 GPUs, 78 % at 4, 92 % at 8 over NVLink, 69 % at 8 over the rails</a:t>
+            </a:r>
+          </a:p>
+          <a:p>
+            <a:pPr>
+              <a:spcAft>
+                <a:spcPts val="600"/>
+              </a:spcAft>
+              <a:defRPr sz="1200">
+                <a:solidFill>
+                  <a:srgbClr val="0B0B0B"/>
+                </a:solidFill>
+              </a:defRPr>
+            </a:pPr>
+            <a:r>
+              <a:t>• The 'comm' figure is how much of each step the GPU spends in communication kernels (from the PyTorch profiler); at this model size the gradient exchange is a large share of every step</a:t>
             </a:r>
           </a:p>
         </p:txBody>
@@ -7007,7 +6960,7 @@
 </p:sld>
 </file>
 
-<file path=ppt/slides/slide8.xml><?xml version="1.0" encoding="utf-8"?>
+<file path=ppt/slides/slide7.xml><?xml version="1.0" encoding="utf-8"?>
 <p:sld xmlns:a="http://schemas.openxmlformats.org/drawingml/2006/main" xmlns:p="http://schemas.openxmlformats.org/presentationml/2006/main" xmlns:r="http://schemas.openxmlformats.org/officeDocument/2006/relationships">
   <p:cSld>
     <p:spTree>
@@ -7047,7 +7000,7 @@
               </a:defRPr>
             </a:pPr>
             <a:r>
-              <a:t>3 · Diagnosis: where accelerator time goes</a:t>
+              <a:t>3 · Diagnosis: what limits the RDMA path, with the counters that prove it</a:t>
             </a:r>
           </a:p>
         </p:txBody>
@@ -7061,7 +7014,7 @@
           <p:nvPr/>
         </p:nvPicPr>
         <p:blipFill>
-          <a:blip r:embed="rId2"/>
+          <a:blip r:embed="rId3"/>
           <a:stretch>
             <a:fillRect/>
           </a:stretch>
@@ -7109,7 +7062,7 @@
               </a:defRPr>
             </a:pPr>
             <a:r>
-              <a:t>• Evidence: bytes on the wire (port_xmit_data, verified against ethtool) equal the two-node minimum S per direction; one rail carried 411 Gb/s — so a rail is a 4-plane 800 Gb/s port, not the 200 Gb/s sysfs reports</a:t>
+              <a:t>• Bandwidth scales with the number of rails a pod claims: 96 GB/s with one rail, 207 with two, 364 with four (4 GiB messages)</a:t>
             </a:r>
           </a:p>
           <a:p>
@@ -7124,7 +7077,7 @@
               </a:defRPr>
             </a:pPr>
             <a:r>
-              <a:t>• RDMA path scales with rails claimed (1 → 2 → 4) and each rail sits at ~55 % of 800 Gb/s; CNP/ECN/out-of-sequence counters flat; NIC and GPU at PCIe Gen6 x16 → not the wire, not congestion, not PCIe</a:t>
+              <a:t>• The bytes counted on each rail match the theoretical minimum for a two-node all-reduce exactly — and one rail carried 411 Gb/s, which a 200 Gb/s link cannot do. So a rail is really a 4-plane 800 Gb/s port; sysfs and ethtool report a single plane</a:t>
             </a:r>
           </a:p>
           <a:p>
@@ -7139,7 +7092,7 @@
               </a:defRPr>
             </a:pPr>
             <a:r>
-              <a:t>• What remains: the per-rail injection path (one NCCL connection per GPU–NIC pair, GDR across the Grace socket over C2C) — a narrowed hypothesis, with the next experiment named (channels per NIC, GPU–NIC placement)</a:t>
+              <a:t>• Each rail therefore ran at 51–60 % of its capacity. Congestion counters (CNP, ECN, out-of-sequence, ACK timeouts) stayed at zero; NIC and GPU both negotiate PCIe Gen6 x16 — so it is not the wire, not congestion, not PCIe</a:t>
             </a:r>
           </a:p>
           <a:p>
@@ -7154,7 +7107,7 @@
               </a:defRPr>
             </a:pPr>
             <a:r>
-              <a:t>• Cross-tray NVLink at 835 GB/s is ~2× the four rails together: the topology decides the transport, the transport decides the ceiling</a:t>
+              <a:t>• What remains is the per-rail injection path (one NCCL connection per GPU–NIC pair, GPUDirect across the Grace socket). That is a narrowed hypothesis, not a proof; the next experiment is more NCCL channels per NIC</a:t>
             </a:r>
           </a:p>
         </p:txBody>
@@ -7567,7 +7520,7 @@
 </p:sld>
 </file>
 
-<file path=ppt/slides/slide9.xml><?xml version="1.0" encoding="utf-8"?>
+<file path=ppt/slides/slide8.xml><?xml version="1.0" encoding="utf-8"?>
 <p:sld xmlns:a="http://schemas.openxmlformats.org/drawingml/2006/main" xmlns:p="http://schemas.openxmlformats.org/presentationml/2006/main" xmlns:r="http://schemas.openxmlformats.org/officeDocument/2006/relationships">
   <p:cSld>
     <p:spTree>
@@ -7607,7 +7560,7 @@
               </a:defRPr>
             </a:pPr>
             <a:r>
-              <a:t>4 · Optimization: NCCL_IB_QPS_PER_CONNECTION</a:t>
+              <a:t>4 · The optimization: more queue pairs per connection (NCCL_IB_QPS_PER_CONNECTION)</a:t>
             </a:r>
           </a:p>
         </p:txBody>
@@ -7621,7 +7574,7 @@
           <p:nvPr/>
         </p:nvPicPr>
         <p:blipFill>
-          <a:blip r:embed="rId2"/>
+          <a:blip r:embed="rId3"/>
           <a:stretch>
             <a:fillRect/>
           </a:stretch>
@@ -7669,7 +7622,7 @@
               </a:defRPr>
             </a:pPr>
             <a:r>
-              <a:t>• Baseline: 1 QP per connection on the RDMA path</a:t>
+              <a:t>• Baseline: RDMA path, four rails, GPUDirect on, one queue pair per NCCL connection (the default) — 98 / 413 / 408 GB/s at 16 MiB / 512 MiB / 4 GiB, five repeats each</a:t>
             </a:r>
           </a:p>
           <a:p>
@@ -7684,7 +7637,7 @@
               </a:defRPr>
             </a:pPr>
             <a:r>
-              <a:t>• Hypothesis (written before the run): a single QP per peer leaves rail bandwidth idle (rails at ~55 %); more QPs spread the flow and raise busbw; trade-off is per-QP state and out-of-order handling (out_of_sequence, packet_seq_err)</a:t>
+              <a:t>• Hypothesis, written before running: the rails have headroom (55 % used), one queue pair per peer serialises each flow, so 2 or 4 queue pairs should raise large-message bandwidth; expected cost is more out-of-order delivery</a:t>
             </a:r>
           </a:p>
           <a:p>
@@ -7699,7 +7652,7 @@
               </a:defRPr>
             </a:pPr>
             <a:r>
-              <a:t>• Change: QPS_PER_CONNECTION 1 → 2 → 4 with SPLIT_DATA_ON_QPS=1; 5 repeats each at 16 MiB / 512 MiB / 4 GiB; nothing else touched</a:t>
+              <a:t>• Change: only that variable (plus the companion setting that splits each message across the queue pairs), 1 → 2 → 4, five repeats per cell</a:t>
             </a:r>
           </a:p>
           <a:p>
@@ -7714,7 +7667,7 @@
               </a:defRPr>
             </a:pPr>
             <a:r>
-              <a:t>• Measurement: QPs=2 −4/−9/−8 %, QPs=4 −19/−32/−29 % (Welch p &lt; 0.001 at every size for QPs=4); counter window at QPs=4: 338 Gb/s per rail vs 482, reordering and congestion counters still zero</a:t>
+              <a:t>• Result: worse. 2 QPs: −4 % / −9 % / −8 %. 4 QPs: −19 % / −32 % / −29 %, statistically clear at every size. The counter window at 4 QPs shows each rail at 338 instead of 482 Gb/s, with reordering and congestion counters still at zero</a:t>
             </a:r>
           </a:p>
           <a:p>
@@ -7729,7 +7682,7 @@
               </a:defRPr>
             </a:pPr>
             <a:r>
-              <a:t>• Conclusion — negative: the headroom is real but this knob cannot reach it; splitting messages across QPs shrinks each work request. Keep the default; the ceiling is on the injection side</a:t>
+              <a:t>• Conclusion: the headroom is real but this knob cannot reach it — splitting every message across queue pairs shrinks each work request and multiplies completions. Keep the default; look at the injection side instead. A negative result, reported as one</a:t>
             </a:r>
           </a:p>
         </p:txBody>
@@ -8670,6 +8623,914 @@
                       </a:pPr>
                       <a:r>
                         <a:t>0</a:t>
+                      </a:r>
+                    </a:p>
+                  </a:txBody>
+                  <a:tcPr/>
+                </a:tc>
+              </a:tr>
+            </a:tbl>
+          </a:graphicData>
+        </a:graphic>
+      </p:graphicFrame>
+    </p:spTree>
+  </p:cSld>
+  <p:clrMapOvr>
+    <a:masterClrMapping/>
+  </p:clrMapOvr>
+</p:sld>
+</file>
+
+<file path=ppt/slides/slide9.xml><?xml version="1.0" encoding="utf-8"?>
+<p:sld xmlns:a="http://schemas.openxmlformats.org/drawingml/2006/main" xmlns:p="http://schemas.openxmlformats.org/presentationml/2006/main" xmlns:r="http://schemas.openxmlformats.org/officeDocument/2006/relationships">
+  <p:cSld>
+    <p:spTree>
+      <p:nvGrpSpPr>
+        <p:cNvPr id="1" name=""/>
+        <p:cNvGrpSpPr/>
+        <p:nvPr/>
+      </p:nvGrpSpPr>
+      <p:grpSpPr/>
+      <p:sp>
+        <p:nvSpPr>
+          <p:cNvPr id="2" name="TextBox 1"/>
+          <p:cNvSpPr txBox="1"/>
+          <p:nvPr/>
+        </p:nvSpPr>
+        <p:spPr>
+          <a:xfrm>
+            <a:off x="457200" y="274320"/>
+            <a:ext cx="11247120" cy="822960"/>
+          </a:xfrm>
+          <a:prstGeom prst="rect">
+            <a:avLst/>
+          </a:prstGeom>
+          <a:noFill/>
+        </p:spPr>
+        <p:txBody>
+          <a:bodyPr wrap="none">
+            <a:spAutoFit/>
+          </a:bodyPr>
+          <a:lstStyle/>
+          <a:p>
+            <a:pPr>
+              <a:defRPr sz="2600" b="1">
+                <a:solidFill>
+                  <a:srgbClr val="0B0B0B"/>
+                </a:solidFill>
+              </a:defRPr>
+            </a:pPr>
+            <a:r>
+              <a:t>5 · Other knobs we measured, and the one that actually helps the workload</a:t>
+            </a:r>
+          </a:p>
+        </p:txBody>
+      </p:sp>
+      <p:sp>
+        <p:nvSpPr>
+          <p:cNvPr id="3" name="TextBox 2"/>
+          <p:cNvSpPr txBox="1"/>
+          <p:nvPr/>
+        </p:nvSpPr>
+        <p:spPr>
+          <a:xfrm>
+            <a:off x="548640" y="1188720"/>
+            <a:ext cx="5486400" cy="5029200"/>
+          </a:xfrm>
+          <a:prstGeom prst="rect">
+            <a:avLst/>
+          </a:prstGeom>
+          <a:noFill/>
+        </p:spPr>
+        <p:txBody>
+          <a:bodyPr wrap="square">
+            <a:spAutoFit/>
+          </a:bodyPr>
+          <a:lstStyle/>
+          <a:p>
+            <a:pPr>
+              <a:spcAft>
+                <a:spcPts val="600"/>
+              </a:spcAft>
+              <a:defRPr sz="1400">
+                <a:solidFill>
+                  <a:srgbClr val="0B0B0B"/>
+                </a:solidFill>
+              </a:defRPr>
+            </a:pPr>
+            <a:r>
+              <a:t>• GPUDirect off: −38 % — same bytes on the wire, 1.6× the time; the cost of copying through host memory</a:t>
+            </a:r>
+          </a:p>
+          <a:p>
+            <a:pPr>
+              <a:spcAft>
+                <a:spcPts val="600"/>
+              </a:spcAft>
+              <a:defRPr sz="1400">
+                <a:solidFill>
+                  <a:srgbClr val="0B0B0B"/>
+                </a:solidFill>
+              </a:defRPr>
+            </a:pPr>
+            <a:r>
+              <a:t>• Bigger NCCL buffers: no change. NVLS vs Ring algorithm on NVLink: 474 vs 388 GB/s — the NVSwitch reduction is what keeps the NVLink curve climbing. 'Tree' is not valid for this collective set (NCCL has no tree all-gather)</a:t>
+            </a:r>
+          </a:p>
+          <a:p>
+            <a:pPr>
+              <a:spcAft>
+                <a:spcPts val="600"/>
+              </a:spcAft>
+              <a:defRPr sz="1400">
+                <a:solidFill>
+                  <a:srgbClr val="0B0B0B"/>
+                </a:solidFill>
+              </a:defRPr>
+            </a:pPr>
+            <a:r>
+              <a:t>• TCP with more socket threads: 7× faster than default TCP, still 14× slower than RDMA</a:t>
+            </a:r>
+          </a:p>
+          <a:p>
+            <a:pPr>
+              <a:spcAft>
+                <a:spcPts val="600"/>
+              </a:spcAft>
+              <a:defRPr sz="1400">
+                <a:solidFill>
+                  <a:srgbClr val="0B0B0B"/>
+                </a:solidFill>
+              </a:defRPr>
+            </a:pPr>
+            <a:r>
+              <a:t>• DDP gradient buckets 25 → 200 MiB over the rails: 2090 → 2769 samples/s (+32 %); communication share of the step falls from 91 % to 32 %. On a slower interconnect, change how often you communicate before changing how</a:t>
+            </a:r>
+          </a:p>
+        </p:txBody>
+      </p:sp>
+      <p:graphicFrame>
+        <p:nvGraphicFramePr>
+          <p:cNvPr id="4" name="Table 3"/>
+          <p:cNvGraphicFramePr>
+            <a:graphicFrameLocks noGrp="1"/>
+          </p:cNvGraphicFramePr>
+          <p:nvPr/>
+        </p:nvGraphicFramePr>
+        <p:xfrm>
+          <a:off x="6217920" y="1188720"/>
+          <a:ext cx="5486400" cy="3291839"/>
+        </p:xfrm>
+        <a:graphic>
+          <a:graphicData uri="http://schemas.openxmlformats.org/drawingml/2006/table">
+            <a:tbl>
+              <a:tblPr firstRow="1" bandRow="1">
+                <a:tableStyleId>{5C22544A-7EE6-4342-B048-85BDC9FD1C3A}</a:tableStyleId>
+              </a:tblPr>
+              <a:tblGrid>
+                <a:gridCol w="1371600"/>
+                <a:gridCol w="1371600"/>
+                <a:gridCol w="1371600"/>
+                <a:gridCol w="1371600"/>
+              </a:tblGrid>
+              <a:tr h="274319">
+                <a:tc>
+                  <a:txBody>
+                    <a:bodyPr/>
+                    <a:lstStyle/>
+                    <a:p>
+                      <a:pPr>
+                        <a:defRPr sz="900" b="1"/>
+                      </a:pPr>
+                      <a:r>
+                        <a:t>run_id</a:t>
+                      </a:r>
+                    </a:p>
+                  </a:txBody>
+                  <a:tcPr/>
+                </a:tc>
+                <a:tc>
+                  <a:txBody>
+                    <a:bodyPr/>
+                    <a:lstStyle/>
+                    <a:p>
+                      <a:pPr>
+                        <a:defRPr sz="900" b="1"/>
+                      </a:pPr>
+                      <a:r>
+                        <a:t>16MiB</a:t>
+                      </a:r>
+                    </a:p>
+                  </a:txBody>
+                  <a:tcPr/>
+                </a:tc>
+                <a:tc>
+                  <a:txBody>
+                    <a:bodyPr/>
+                    <a:lstStyle/>
+                    <a:p>
+                      <a:pPr>
+                        <a:defRPr sz="900" b="1"/>
+                      </a:pPr>
+                      <a:r>
+                        <a:t>512MiB</a:t>
+                      </a:r>
+                    </a:p>
+                  </a:txBody>
+                  <a:tcPr/>
+                </a:tc>
+                <a:tc>
+                  <a:txBody>
+                    <a:bodyPr/>
+                    <a:lstStyle/>
+                    <a:p>
+                      <a:pPr>
+                        <a:defRPr sz="900" b="1"/>
+                      </a:pPr>
+                      <a:r>
+                        <a:t>4GiB</a:t>
+                      </a:r>
+                    </a:p>
+                  </a:txBody>
+                  <a:tcPr/>
+                </a:tc>
+              </a:tr>
+              <a:tr h="274319">
+                <a:tc>
+                  <a:txBody>
+                    <a:bodyPr/>
+                    <a:lstStyle/>
+                    <a:p>
+                      <a:pPr>
+                        <a:defRPr sz="900"/>
+                      </a:pPr>
+                      <a:r>
+                        <a:t>e5-algo-nvls</a:t>
+                      </a:r>
+                    </a:p>
+                  </a:txBody>
+                  <a:tcPr/>
+                </a:tc>
+                <a:tc>
+                  <a:txBody>
+                    <a:bodyPr/>
+                    <a:lstStyle/>
+                    <a:p>
+                      <a:pPr>
+                        <a:defRPr sz="900"/>
+                      </a:pPr>
+                      <a:r>
+                        <a:t>297</a:t>
+                      </a:r>
+                    </a:p>
+                  </a:txBody>
+                  <a:tcPr/>
+                </a:tc>
+                <a:tc>
+                  <a:txBody>
+                    <a:bodyPr/>
+                    <a:lstStyle/>
+                    <a:p>
+                      <a:pPr>
+                        <a:defRPr sz="900"/>
+                      </a:pPr>
+                      <a:r>
+                        <a:t>695</a:t>
+                      </a:r>
+                    </a:p>
+                  </a:txBody>
+                  <a:tcPr/>
+                </a:tc>
+                <a:tc>
+                  <a:txBody>
+                    <a:bodyPr/>
+                    <a:lstStyle/>
+                    <a:p>
+                      <a:pPr>
+                        <a:defRPr sz="900"/>
+                      </a:pPr>
+                      <a:r>
+                        <a:t>830</a:t>
+                      </a:r>
+                    </a:p>
+                  </a:txBody>
+                  <a:tcPr/>
+                </a:tc>
+              </a:tr>
+              <a:tr h="274319">
+                <a:tc>
+                  <a:txBody>
+                    <a:bodyPr/>
+                    <a:lstStyle/>
+                    <a:p>
+                      <a:pPr>
+                        <a:defRPr sz="900"/>
+                      </a:pPr>
+                      <a:r>
+                        <a:t>e5-algo-ring</a:t>
+                      </a:r>
+                    </a:p>
+                  </a:txBody>
+                  <a:tcPr/>
+                </a:tc>
+                <a:tc>
+                  <a:txBody>
+                    <a:bodyPr/>
+                    <a:lstStyle/>
+                    <a:p>
+                      <a:pPr>
+                        <a:defRPr sz="900"/>
+                      </a:pPr>
+                      <a:r>
+                        <a:t>327</a:t>
+                      </a:r>
+                    </a:p>
+                  </a:txBody>
+                  <a:tcPr/>
+                </a:tc>
+                <a:tc>
+                  <a:txBody>
+                    <a:bodyPr/>
+                    <a:lstStyle/>
+                    <a:p>
+                      <a:pPr>
+                        <a:defRPr sz="900"/>
+                      </a:pPr>
+                      <a:r>
+                        <a:t>635</a:t>
+                      </a:r>
+                    </a:p>
+                  </a:txBody>
+                  <a:tcPr/>
+                </a:tc>
+                <a:tc>
+                  <a:txBody>
+                    <a:bodyPr/>
+                    <a:lstStyle/>
+                    <a:p>
+                      <a:pPr>
+                        <a:defRPr sz="900"/>
+                      </a:pPr>
+                      <a:r>
+                        <a:t>679</a:t>
+                      </a:r>
+                    </a:p>
+                  </a:txBody>
+                  <a:tcPr/>
+                </a:tc>
+              </a:tr>
+              <a:tr h="274319">
+                <a:tc>
+                  <a:txBody>
+                    <a:bodyPr/>
+                    <a:lstStyle/>
+                    <a:p>
+                      <a:pPr>
+                        <a:defRPr sz="900"/>
+                      </a:pPr>
+                      <a:r>
+                        <a:t>e5-buffsize16m</a:t>
+                      </a:r>
+                    </a:p>
+                  </a:txBody>
+                  <a:tcPr/>
+                </a:tc>
+                <a:tc>
+                  <a:txBody>
+                    <a:bodyPr/>
+                    <a:lstStyle/>
+                    <a:p>
+                      <a:pPr>
+                        <a:defRPr sz="900"/>
+                      </a:pPr>
+                      <a:r>
+                        <a:t>101</a:t>
+                      </a:r>
+                    </a:p>
+                  </a:txBody>
+                  <a:tcPr/>
+                </a:tc>
+                <a:tc>
+                  <a:txBody>
+                    <a:bodyPr/>
+                    <a:lstStyle/>
+                    <a:p>
+                      <a:pPr>
+                        <a:defRPr sz="900"/>
+                      </a:pPr>
+                      <a:r>
+                        <a:t>420</a:t>
+                      </a:r>
+                    </a:p>
+                  </a:txBody>
+                  <a:tcPr/>
+                </a:tc>
+                <a:tc>
+                  <a:txBody>
+                    <a:bodyPr/>
+                    <a:lstStyle/>
+                    <a:p>
+                      <a:pPr>
+                        <a:defRPr sz="900"/>
+                      </a:pPr>
+                      <a:r>
+                        <a:t>393</a:t>
+                      </a:r>
+                    </a:p>
+                  </a:txBody>
+                  <a:tcPr/>
+                </a:tc>
+              </a:tr>
+              <a:tr h="274319">
+                <a:tc>
+                  <a:txBody>
+                    <a:bodyPr/>
+                    <a:lstStyle/>
+                    <a:p>
+                      <a:pPr>
+                        <a:defRPr sz="900"/>
+                      </a:pPr>
+                      <a:r>
+                        <a:t>e5-buffsize4m</a:t>
+                      </a:r>
+                    </a:p>
+                  </a:txBody>
+                  <a:tcPr/>
+                </a:tc>
+                <a:tc>
+                  <a:txBody>
+                    <a:bodyPr/>
+                    <a:lstStyle/>
+                    <a:p>
+                      <a:pPr>
+                        <a:defRPr sz="900"/>
+                      </a:pPr>
+                      <a:r>
+                        <a:t>102</a:t>
+                      </a:r>
+                    </a:p>
+                  </a:txBody>
+                  <a:tcPr/>
+                </a:tc>
+                <a:tc>
+                  <a:txBody>
+                    <a:bodyPr/>
+                    <a:lstStyle/>
+                    <a:p>
+                      <a:pPr>
+                        <a:defRPr sz="900"/>
+                      </a:pPr>
+                      <a:r>
+                        <a:t>402</a:t>
+                      </a:r>
+                    </a:p>
+                  </a:txBody>
+                  <a:tcPr/>
+                </a:tc>
+                <a:tc>
+                  <a:txBody>
+                    <a:bodyPr/>
+                    <a:lstStyle/>
+                    <a:p>
+                      <a:pPr>
+                        <a:defRPr sz="900"/>
+                      </a:pPr>
+                      <a:r>
+                        <a:t>419</a:t>
+                      </a:r>
+                    </a:p>
+                  </a:txBody>
+                  <a:tcPr/>
+                </a:tc>
+              </a:tr>
+              <a:tr h="274319">
+                <a:tc>
+                  <a:txBody>
+                    <a:bodyPr/>
+                    <a:lstStyle/>
+                    <a:p>
+                      <a:pPr>
+                        <a:defRPr sz="900"/>
+                      </a:pPr>
+                      <a:r>
+                        <a:t>e5-counters-gdr-off</a:t>
+                      </a:r>
+                    </a:p>
+                  </a:txBody>
+                  <a:tcPr/>
+                </a:tc>
+                <a:tc>
+                  <a:txBody>
+                    <a:bodyPr/>
+                    <a:lstStyle/>
+                    <a:p>
+                      <a:pPr>
+                        <a:defRPr sz="900"/>
+                      </a:pPr>
+                      <a:r>
+                        <a:t>nan</a:t>
+                      </a:r>
+                    </a:p>
+                  </a:txBody>
+                  <a:tcPr/>
+                </a:tc>
+                <a:tc>
+                  <a:txBody>
+                    <a:bodyPr/>
+                    <a:lstStyle/>
+                    <a:p>
+                      <a:pPr>
+                        <a:defRPr sz="900"/>
+                      </a:pPr>
+                      <a:r>
+                        <a:t>nan</a:t>
+                      </a:r>
+                    </a:p>
+                  </a:txBody>
+                  <a:tcPr/>
+                </a:tc>
+                <a:tc>
+                  <a:txBody>
+                    <a:bodyPr/>
+                    <a:lstStyle/>
+                    <a:p>
+                      <a:pPr>
+                        <a:defRPr sz="900"/>
+                      </a:pPr>
+                      <a:r>
+                        <a:t>253</a:t>
+                      </a:r>
+                    </a:p>
+                  </a:txBody>
+                  <a:tcPr/>
+                </a:tc>
+              </a:tr>
+              <a:tr h="274319">
+                <a:tc>
+                  <a:txBody>
+                    <a:bodyPr/>
+                    <a:lstStyle/>
+                    <a:p>
+                      <a:pPr>
+                        <a:defRPr sz="900"/>
+                      </a:pPr>
+                      <a:r>
+                        <a:t>e5-counters-nvlink</a:t>
+                      </a:r>
+                    </a:p>
+                  </a:txBody>
+                  <a:tcPr/>
+                </a:tc>
+                <a:tc>
+                  <a:txBody>
+                    <a:bodyPr/>
+                    <a:lstStyle/>
+                    <a:p>
+                      <a:pPr>
+                        <a:defRPr sz="900"/>
+                      </a:pPr>
+                      <a:r>
+                        <a:t>nan</a:t>
+                      </a:r>
+                    </a:p>
+                  </a:txBody>
+                  <a:tcPr/>
+                </a:tc>
+                <a:tc>
+                  <a:txBody>
+                    <a:bodyPr/>
+                    <a:lstStyle/>
+                    <a:p>
+                      <a:pPr>
+                        <a:defRPr sz="900"/>
+                      </a:pPr>
+                      <a:r>
+                        <a:t>nan</a:t>
+                      </a:r>
+                    </a:p>
+                  </a:txBody>
+                  <a:tcPr/>
+                </a:tc>
+                <a:tc>
+                  <a:txBody>
+                    <a:bodyPr/>
+                    <a:lstStyle/>
+                    <a:p>
+                      <a:pPr>
+                        <a:defRPr sz="900"/>
+                      </a:pPr>
+                      <a:r>
+                        <a:t>833</a:t>
+                      </a:r>
+                    </a:p>
+                  </a:txBody>
+                  <a:tcPr/>
+                </a:tc>
+              </a:tr>
+              <a:tr h="274319">
+                <a:tc>
+                  <a:txBody>
+                    <a:bodyPr/>
+                    <a:lstStyle/>
+                    <a:p>
+                      <a:pPr>
+                        <a:defRPr sz="900"/>
+                      </a:pPr>
+                      <a:r>
+                        <a:t>e5-counters-rails1</a:t>
+                      </a:r>
+                    </a:p>
+                  </a:txBody>
+                  <a:tcPr/>
+                </a:tc>
+                <a:tc>
+                  <a:txBody>
+                    <a:bodyPr/>
+                    <a:lstStyle/>
+                    <a:p>
+                      <a:pPr>
+                        <a:defRPr sz="900"/>
+                      </a:pPr>
+                      <a:r>
+                        <a:t>nan</a:t>
+                      </a:r>
+                    </a:p>
+                  </a:txBody>
+                  <a:tcPr/>
+                </a:tc>
+                <a:tc>
+                  <a:txBody>
+                    <a:bodyPr/>
+                    <a:lstStyle/>
+                    <a:p>
+                      <a:pPr>
+                        <a:defRPr sz="900"/>
+                      </a:pPr>
+                      <a:r>
+                        <a:t>nan</a:t>
+                      </a:r>
+                    </a:p>
+                  </a:txBody>
+                  <a:tcPr/>
+                </a:tc>
+                <a:tc>
+                  <a:txBody>
+                    <a:bodyPr/>
+                    <a:lstStyle/>
+                    <a:p>
+                      <a:pPr>
+                        <a:defRPr sz="900"/>
+                      </a:pPr>
+                      <a:r>
+                        <a:t>87.8</a:t>
+                      </a:r>
+                    </a:p>
+                  </a:txBody>
+                  <a:tcPr/>
+                </a:tc>
+              </a:tr>
+              <a:tr h="274319">
+                <a:tc>
+                  <a:txBody>
+                    <a:bodyPr/>
+                    <a:lstStyle/>
+                    <a:p>
+                      <a:pPr>
+                        <a:defRPr sz="900"/>
+                      </a:pPr>
+                      <a:r>
+                        <a:t>e5-counters-rdma</a:t>
+                      </a:r>
+                    </a:p>
+                  </a:txBody>
+                  <a:tcPr/>
+                </a:tc>
+                <a:tc>
+                  <a:txBody>
+                    <a:bodyPr/>
+                    <a:lstStyle/>
+                    <a:p>
+                      <a:pPr>
+                        <a:defRPr sz="900"/>
+                      </a:pPr>
+                      <a:r>
+                        <a:t>nan</a:t>
+                      </a:r>
+                    </a:p>
+                  </a:txBody>
+                  <a:tcPr/>
+                </a:tc>
+                <a:tc>
+                  <a:txBody>
+                    <a:bodyPr/>
+                    <a:lstStyle/>
+                    <a:p>
+                      <a:pPr>
+                        <a:defRPr sz="900"/>
+                      </a:pPr>
+                      <a:r>
+                        <a:t>nan</a:t>
+                      </a:r>
+                    </a:p>
+                  </a:txBody>
+                  <a:tcPr/>
+                </a:tc>
+                <a:tc>
+                  <a:txBody>
+                    <a:bodyPr/>
+                    <a:lstStyle/>
+                    <a:p>
+                      <a:pPr>
+                        <a:defRPr sz="900"/>
+                      </a:pPr>
+                      <a:r>
+                        <a:t>410</a:t>
+                      </a:r>
+                    </a:p>
+                  </a:txBody>
+                  <a:tcPr/>
+                </a:tc>
+              </a:tr>
+              <a:tr h="274319">
+                <a:tc>
+                  <a:txBody>
+                    <a:bodyPr/>
+                    <a:lstStyle/>
+                    <a:p>
+                      <a:pPr>
+                        <a:defRPr sz="900"/>
+                      </a:pPr>
+                      <a:r>
+                        <a:t>e5-counters-rdma-qps4</a:t>
+                      </a:r>
+                    </a:p>
+                  </a:txBody>
+                  <a:tcPr/>
+                </a:tc>
+                <a:tc>
+                  <a:txBody>
+                    <a:bodyPr/>
+                    <a:lstStyle/>
+                    <a:p>
+                      <a:pPr>
+                        <a:defRPr sz="900"/>
+                      </a:pPr>
+                      <a:r>
+                        <a:t>nan</a:t>
+                      </a:r>
+                    </a:p>
+                  </a:txBody>
+                  <a:tcPr/>
+                </a:tc>
+                <a:tc>
+                  <a:txBody>
+                    <a:bodyPr/>
+                    <a:lstStyle/>
+                    <a:p>
+                      <a:pPr>
+                        <a:defRPr sz="900"/>
+                      </a:pPr>
+                      <a:r>
+                        <a:t>nan</a:t>
+                      </a:r>
+                    </a:p>
+                  </a:txBody>
+                  <a:tcPr/>
+                </a:tc>
+                <a:tc>
+                  <a:txBody>
+                    <a:bodyPr/>
+                    <a:lstStyle/>
+                    <a:p>
+                      <a:pPr>
+                        <a:defRPr sz="900"/>
+                      </a:pPr>
+                      <a:r>
+                        <a:t>301</a:t>
+                      </a:r>
+                    </a:p>
+                  </a:txBody>
+                  <a:tcPr/>
+                </a:tc>
+              </a:tr>
+              <a:tr h="274319">
+                <a:tc>
+                  <a:txBody>
+                    <a:bodyPr/>
+                    <a:lstStyle/>
+                    <a:p>
+                      <a:pPr>
+                        <a:defRPr sz="900"/>
+                      </a:pPr>
+                      <a:r>
+                        <a:t>e5-gdr-off</a:t>
+                      </a:r>
+                    </a:p>
+                  </a:txBody>
+                  <a:tcPr/>
+                </a:tc>
+                <a:tc>
+                  <a:txBody>
+                    <a:bodyPr/>
+                    <a:lstStyle/>
+                    <a:p>
+                      <a:pPr>
+                        <a:defRPr sz="900"/>
+                      </a:pPr>
+                      <a:r>
+                        <a:t>107</a:t>
+                      </a:r>
+                    </a:p>
+                  </a:txBody>
+                  <a:tcPr/>
+                </a:tc>
+                <a:tc>
+                  <a:txBody>
+                    <a:bodyPr/>
+                    <a:lstStyle/>
+                    <a:p>
+                      <a:pPr>
+                        <a:defRPr sz="900"/>
+                      </a:pPr>
+                      <a:r>
+                        <a:t>222</a:t>
+                      </a:r>
+                    </a:p>
+                  </a:txBody>
+                  <a:tcPr/>
+                </a:tc>
+                <a:tc>
+                  <a:txBody>
+                    <a:bodyPr/>
+                    <a:lstStyle/>
+                    <a:p>
+                      <a:pPr>
+                        <a:defRPr sz="900"/>
+                      </a:pPr>
+                      <a:r>
+                        <a:t>247</a:t>
+                      </a:r>
+                    </a:p>
+                  </a:txBody>
+                  <a:tcPr/>
+                </a:tc>
+              </a:tr>
+              <a:tr h="274330">
+                <a:tc>
+                  <a:txBody>
+                    <a:bodyPr/>
+                    <a:lstStyle/>
+                    <a:p>
+                      <a:pPr>
+                        <a:defRPr sz="900"/>
+                      </a:pPr>
+                      <a:r>
+                        <a:t>e5-sock-nthreads4</a:t>
+                      </a:r>
+                    </a:p>
+                  </a:txBody>
+                  <a:tcPr/>
+                </a:tc>
+                <a:tc>
+                  <a:txBody>
+                    <a:bodyPr/>
+                    <a:lstStyle/>
+                    <a:p>
+                      <a:pPr>
+                        <a:defRPr sz="900"/>
+                      </a:pPr>
+                      <a:r>
+                        <a:t>10.3</a:t>
+                      </a:r>
+                    </a:p>
+                  </a:txBody>
+                  <a:tcPr/>
+                </a:tc>
+                <a:tc>
+                  <a:txBody>
+                    <a:bodyPr/>
+                    <a:lstStyle/>
+                    <a:p>
+                      <a:pPr>
+                        <a:defRPr sz="900"/>
+                      </a:pPr>
+                      <a:r>
+                        <a:t>21.6</a:t>
+                      </a:r>
+                    </a:p>
+                  </a:txBody>
+                  <a:tcPr/>
+                </a:tc>
+                <a:tc>
+                  <a:txBody>
+                    <a:bodyPr/>
+                    <a:lstStyle/>
+                    <a:p>
+                      <a:pPr>
+                        <a:defRPr sz="900"/>
+                      </a:pPr>
+                      <a:r>
+                        <a:t>29.4</a:t>
                       </a:r>
                     </a:p>
                   </a:txBody>
@@ -9006,4 +9867,324 @@
   </a:objectDefaults>
   <a:extraClrSchemeLst/>
 </a:theme>
+</file>
+
+<file path=ppt/theme/theme2.xml><?xml version="1.0" encoding="utf-8"?>
+<a:theme xmlns:a="http://schemas.openxmlformats.org/drawingml/2006/main" name="Office Theme">
+  <a:themeElements>
+    <a:clrScheme name="Office">
+      <a:dk1>
+        <a:sysClr val="windowText" lastClr="000000"/>
+      </a:dk1>
+      <a:lt1>
+        <a:sysClr val="window" lastClr="FFFFFF"/>
+      </a:lt1>
+      <a:dk2>
+        <a:srgbClr val="1F497D"/>
+      </a:dk2>
+      <a:lt2>
+        <a:srgbClr val="EEECE1"/>
+      </a:lt2>
+      <a:accent1>
+        <a:srgbClr val="4F81BD"/>
+      </a:accent1>
+      <a:accent2>
+        <a:srgbClr val="C0504D"/>
+      </a:accent2>
+      <a:accent3>
+        <a:srgbClr val="9BBB59"/>
+      </a:accent3>
+      <a:accent4>
+        <a:srgbClr val="8064A2"/>
+      </a:accent4>
+      <a:accent5>
+        <a:srgbClr val="4BACC6"/>
+      </a:accent5>
+      <a:accent6>
+        <a:srgbClr val="F79646"/>
+      </a:accent6>
+      <a:hlink>
+        <a:srgbClr val="0000FF"/>
+      </a:hlink>
+      <a:folHlink>
+        <a:srgbClr val="800080"/>
+      </a:folHlink>
+    </a:clrScheme>
+    <a:fontScheme name="Office">
+      <a:majorFont>
+        <a:latin typeface="Calibri"/>
+        <a:ea typeface=""/>
+        <a:cs typeface=""/>
+        <a:font script="Jpan" typeface="ＭＳ Ｐゴシック"/>
+        <a:font script="Hang" typeface="맑은 고딕"/>
+        <a:font script="Hans" typeface="宋体"/>
+        <a:font script="Hant" typeface="新細明體"/>
+        <a:font script="Arab" typeface="Times New Roman"/>
+        <a:font script="Hebr" typeface="Times New Roman"/>
+        <a:font script="Thai" typeface="Angsana New"/>
+        <a:font script="Ethi" typeface="Nyala"/>
+        <a:font script="Beng" typeface="Vrinda"/>
+        <a:font script="Gujr" typeface="Shruti"/>
+        <a:font script="Khmr" typeface="MoolBoran"/>
+        <a:font script="Knda" typeface="Tunga"/>
+        <a:font script="Guru" typeface="Raavi"/>
+        <a:font script="Cans" typeface="Euphemia"/>
+        <a:font script="Cher" typeface="Plantagenet Cherokee"/>
+        <a:font script="Yiii" typeface="Microsoft Yi Baiti"/>
+        <a:font script="Tibt" typeface="Microsoft Himalaya"/>
+        <a:font script="Thaa" typeface="MV Boli"/>
+        <a:font script="Deva" typeface="Mangal"/>
+        <a:font script="Telu" typeface="Gautami"/>
+        <a:font script="Taml" typeface="Latha"/>
+        <a:font script="Syrc" typeface="Estrangelo Edessa"/>
+        <a:font script="Orya" typeface="Kalinga"/>
+        <a:font script="Mlym" typeface="Kartika"/>
+        <a:font script="Laoo" typeface="DokChampa"/>
+        <a:font script="Sinh" typeface="Iskoola Pota"/>
+        <a:font script="Mong" typeface="Mongolian Baiti"/>
+        <a:font script="Viet" typeface="Times New Roman"/>
+        <a:font script="Uigh" typeface="Microsoft Uighur"/>
+        <a:font script="Geor" typeface="Sylfaen"/>
+      </a:majorFont>
+      <a:minorFont>
+        <a:latin typeface="Calibri"/>
+        <a:ea typeface=""/>
+        <a:cs typeface=""/>
+        <a:font script="Jpan" typeface="ＭＳ Ｐゴシック"/>
+        <a:font script="Hang" typeface="맑은 고딕"/>
+        <a:font script="Hans" typeface="宋体"/>
+        <a:font script="Hant" typeface="新細明體"/>
+        <a:font script="Arab" typeface="Arial"/>
+        <a:font script="Hebr" typeface="Arial"/>
+        <a:font script="Thai" typeface="Cordia New"/>
+        <a:font script="Ethi" typeface="Nyala"/>
+        <a:font script="Beng" typeface="Vrinda"/>
+        <a:font script="Gujr" typeface="Shruti"/>
+        <a:font script="Khmr" typeface="DaunPenh"/>
+        <a:font script="Knda" typeface="Tunga"/>
+        <a:font script="Guru" typeface="Raavi"/>
+        <a:font script="Cans" typeface="Euphemia"/>
+        <a:font script="Cher" typeface="Plantagenet Cherokee"/>
+        <a:font script="Yiii" typeface="Microsoft Yi Baiti"/>
+        <a:font script="Tibt" typeface="Microsoft Himalaya"/>
+        <a:font script="Thaa" typeface="MV Boli"/>
+        <a:font script="Deva" typeface="Mangal"/>
+        <a:font script="Telu" typeface="Gautami"/>
+        <a:font script="Taml" typeface="Latha"/>
+        <a:font script="Syrc" typeface="Estrangelo Edessa"/>
+        <a:font script="Orya" typeface="Kalinga"/>
+        <a:font script="Mlym" typeface="Kartika"/>
+        <a:font script="Laoo" typeface="DokChampa"/>
+        <a:font script="Sinh" typeface="Iskoola Pota"/>
+        <a:font script="Mong" typeface="Mongolian Baiti"/>
+        <a:font script="Viet" typeface="Arial"/>
+        <a:font script="Uigh" typeface="Microsoft Uighur"/>
+        <a:font script="Geor" typeface="Sylfaen"/>
+      </a:minorFont>
+    </a:fontScheme>
+    <a:fmtScheme name="Office">
+      <a:fillStyleLst>
+        <a:solidFill>
+          <a:schemeClr val="phClr"/>
+        </a:solidFill>
+        <a:gradFill rotWithShape="1">
+          <a:gsLst>
+            <a:gs pos="0">
+              <a:schemeClr val="phClr">
+                <a:tint val="50000"/>
+                <a:satMod val="300000"/>
+              </a:schemeClr>
+            </a:gs>
+            <a:gs pos="35000">
+              <a:schemeClr val="phClr">
+                <a:tint val="37000"/>
+                <a:satMod val="300000"/>
+              </a:schemeClr>
+            </a:gs>
+            <a:gs pos="100000">
+              <a:schemeClr val="phClr">
+                <a:tint val="15000"/>
+                <a:satMod val="350000"/>
+              </a:schemeClr>
+            </a:gs>
+          </a:gsLst>
+          <a:lin ang="16200000" scaled="1"/>
+        </a:gradFill>
+        <a:gradFill rotWithShape="1">
+          <a:gsLst>
+            <a:gs pos="0">
+              <a:schemeClr val="phClr">
+                <a:tint val="100000"/>
+                <a:shade val="100000"/>
+                <a:satMod val="130000"/>
+              </a:schemeClr>
+            </a:gs>
+            <a:gs pos="100000">
+              <a:schemeClr val="phClr">
+                <a:tint val="50000"/>
+                <a:shade val="100000"/>
+                <a:satMod val="350000"/>
+              </a:schemeClr>
+            </a:gs>
+          </a:gsLst>
+          <a:lin ang="16200000" scaled="0"/>
+        </a:gradFill>
+      </a:fillStyleLst>
+      <a:lnStyleLst>
+        <a:ln w="9525" cap="flat" cmpd="sng" algn="ctr">
+          <a:solidFill>
+            <a:schemeClr val="phClr">
+              <a:shade val="95000"/>
+              <a:satMod val="105000"/>
+            </a:schemeClr>
+          </a:solidFill>
+          <a:prstDash val="solid"/>
+        </a:ln>
+        <a:ln w="25400" cap="flat" cmpd="sng" algn="ctr">
+          <a:solidFill>
+            <a:schemeClr val="phClr"/>
+          </a:solidFill>
+          <a:prstDash val="solid"/>
+        </a:ln>
+        <a:ln w="38100" cap="flat" cmpd="sng" algn="ctr">
+          <a:solidFill>
+            <a:schemeClr val="phClr"/>
+          </a:solidFill>
+          <a:prstDash val="solid"/>
+        </a:ln>
+      </a:lnStyleLst>
+      <a:effectStyleLst>
+        <a:effectStyle>
+          <a:effectLst>
+            <a:outerShdw blurRad="40000" dist="20000" dir="5400000" rotWithShape="0">
+              <a:srgbClr val="000000">
+                <a:alpha val="38000"/>
+              </a:srgbClr>
+            </a:outerShdw>
+          </a:effectLst>
+        </a:effectStyle>
+        <a:effectStyle>
+          <a:effectLst>
+            <a:outerShdw blurRad="40000" dist="23000" dir="5400000" rotWithShape="0">
+              <a:srgbClr val="000000">
+                <a:alpha val="35000"/>
+              </a:srgbClr>
+            </a:outerShdw>
+          </a:effectLst>
+        </a:effectStyle>
+        <a:effectStyle>
+          <a:effectLst>
+            <a:outerShdw blurRad="40000" dist="23000" dir="5400000" rotWithShape="0">
+              <a:srgbClr val="000000">
+                <a:alpha val="35000"/>
+              </a:srgbClr>
+            </a:outerShdw>
+          </a:effectLst>
+          <a:scene3d>
+            <a:camera prst="orthographicFront">
+              <a:rot lat="0" lon="0" rev="0"/>
+            </a:camera>
+            <a:lightRig rig="threePt" dir="t">
+              <a:rot lat="0" lon="0" rev="1200000"/>
+            </a:lightRig>
+          </a:scene3d>
+          <a:sp3d>
+            <a:bevelT w="63500" h="25400"/>
+          </a:sp3d>
+        </a:effectStyle>
+      </a:effectStyleLst>
+      <a:bgFillStyleLst>
+        <a:solidFill>
+          <a:schemeClr val="phClr"/>
+        </a:solidFill>
+        <a:gradFill rotWithShape="1">
+          <a:gsLst>
+            <a:gs pos="0">
+              <a:schemeClr val="phClr">
+                <a:tint val="40000"/>
+                <a:satMod val="350000"/>
+              </a:schemeClr>
+            </a:gs>
+            <a:gs pos="40000">
+              <a:schemeClr val="phClr">
+                <a:tint val="45000"/>
+                <a:shade val="99000"/>
+                <a:satMod val="350000"/>
+              </a:schemeClr>
+            </a:gs>
+            <a:gs pos="100000">
+              <a:schemeClr val="phClr">
+                <a:shade val="20000"/>
+                <a:satMod val="255000"/>
+              </a:schemeClr>
+            </a:gs>
+          </a:gsLst>
+          <a:path path="circle">
+            <a:fillToRect l="50000" t="-80000" r="50000" b="180000"/>
+          </a:path>
+        </a:gradFill>
+        <a:gradFill rotWithShape="1">
+          <a:gsLst>
+            <a:gs pos="0">
+              <a:schemeClr val="phClr">
+                <a:tint val="80000"/>
+                <a:satMod val="300000"/>
+              </a:schemeClr>
+            </a:gs>
+            <a:gs pos="100000">
+              <a:schemeClr val="phClr">
+                <a:shade val="30000"/>
+                <a:satMod val="200000"/>
+              </a:schemeClr>
+            </a:gs>
+          </a:gsLst>
+          <a:path path="circle">
+            <a:fillToRect l="50000" t="50000" r="50000" b="50000"/>
+          </a:path>
+        </a:gradFill>
+      </a:bgFillStyleLst>
+    </a:fmtScheme>
+  </a:themeElements>
+  <a:objectDefaults>
+    <a:spDef>
+      <a:spPr/>
+      <a:bodyPr/>
+      <a:lstStyle/>
+      <a:style>
+        <a:lnRef idx="1">
+          <a:schemeClr val="accent1"/>
+        </a:lnRef>
+        <a:fillRef idx="3">
+          <a:schemeClr val="accent1"/>
+        </a:fillRef>
+        <a:effectRef idx="2">
+          <a:schemeClr val="accent1"/>
+        </a:effectRef>
+        <a:fontRef idx="minor">
+          <a:schemeClr val="lt1"/>
+        </a:fontRef>
+      </a:style>
+    </a:spDef>
+    <a:lnDef>
+      <a:spPr/>
+      <a:bodyPr/>
+      <a:lstStyle/>
+      <a:style>
+        <a:lnRef idx="2">
+          <a:schemeClr val="accent1"/>
+        </a:lnRef>
+        <a:fillRef idx="0">
+          <a:schemeClr val="accent1"/>
+        </a:fillRef>
+        <a:effectRef idx="1">
+          <a:schemeClr val="accent1"/>
+        </a:effectRef>
+        <a:fontRef idx="minor">
+          <a:schemeClr val="tx1"/>
+        </a:fontRef>
+      </a:style>
+    </a:lnDef>
+  </a:objectDefaults>
+  <a:extraClrSchemeLst/>
+</a:theme>
 </file>
</xml_diff>

<commit_message>
Slide 6 notes lead with the DDP bucket size: why 25 MiB separates wire speed from per-collective fixed cost; findings updated
Co-Authored-By: Claude Fable 5.1 <noreply@anthropic.com>
</commit_message>
<xml_diff>
--- a/slides/compass.pptx
+++ b/slides/compass.pptx
@@ -859,19 +859,37 @@
           <a:lstStyle/>
           <a:p>
             <a:r>
-              <a:t>Why efficiency drops on one tray from 2 to 4 GPUs: no NIC is involved, so it is not the network — the model is small (a 21 ms step), so launch overhead and the intra-tray all-reduce are a bigger fraction. Saying this out loud is the exercise's 'do not assume networking is the problem'.</a:t>
+              <a:t>Lead with the bucket size. DDP does not all-reduce each gradient separately: it packs gradients into buckets and launches one all-reduce per bucket as the backward pass fills them. The bucket cap here is PyTorch's default, 25 MiB. The model has 124M parameters kept in fp32 under autocast, so about 474 MiB of gradients per step, which is roughly 19 all-reduces of 25 MiB each.</a:t>
             </a:r>
           </a:p>
           <a:p/>
           <a:p>
             <a:r>
-              <a:t>Why 8 GPUs over NVLink beats 4 on one tray: NCCL uses the NVSwitch-based reduction (NVLS) across both trays; the exchange gets faster per byte at 8 ranks than the 4-rank pattern.</a:t>
+              <a:t>Why that size makes the measurement useful: 25 MiB sits at the knee of the message-size curve from the baseline slide. At that size an all-reduce is already bandwidth-sensitive (NVLink and RDMA are clearly apart: ~300 vs ~150 GB/s), but the fixed cost per collective is still a large share of its time (on either path, 16 MiB runs at about a third of the large-message speed). So with the default bucket the step is sensitive to both things at once: the wire speed, and the number of collectives issued per step.</a:t>
             </a:r>
           </a:p>
           <a:p/>
           <a:p>
             <a:r>
-              <a:t>Why 8 GPUs over the rails is 69 %: the same exchange now runs at 425 instead of 835 GB/s and the communication share rises to 91 % of the step. This is the case the optimization slides attack from two directions.</a:t>
+              <a:t>That lets two comparisons separate the two causes. Same bucket size, different transport (8 GPUs over NVLink vs over the rails: 92 % vs 69 %) isolates the wire. Same transport, different bucket size (25 vs 200 MiB over the rails, next-but-one slide: +32 %, communication share 91 % -&gt; 32 %) isolates the per-collective fixed cost. A correction to the intuition 'kernel launch overhead': the fixed cost is more than the CUDA launch - it includes NCCL's per-collective setup and handshake, the DDP reducer waiting for a bucket to be ready, and on RDMA the posting of work requests on every connection. Launch is one part of it.</a:t>
+            </a:r>
+          </a:p>
+          <a:p/>
+          <a:p>
+            <a:r>
+              <a:t>Why efficiency drops on one tray from 2 to 4 GPUs (93 % -&gt; 78 %): no NIC is involved, so it is not the network. The step is only ~21 ms of compute, so the ~19 all-reduces and their fixed costs are a bigger fraction, and the 4-rank intra-tray pattern is less efficient than the 8-rank NVSwitch reduction used across trays. Saying this out loud is the brief's 'do not assume networking is the problem'.</a:t>
+            </a:r>
+          </a:p>
+          <a:p/>
+          <a:p>
+            <a:r>
+              <a:t>Why 8 GPUs over NVLink (92 %) beats 4 on one tray (78 %): across both trays NCCL uses the NVSwitch-based reduction (NVLS), which is faster per byte at 8 ranks than the 4-rank pattern.</a:t>
+            </a:r>
+          </a:p>
+          <a:p/>
+          <a:p>
+            <a:r>
+              <a:t>The 'comm' figure is NCCL kernel residency over step time from torch.profiler. NCCL kernels overlap with backward compute, so it is an upper bound on exposed communication, not the time the step actually lost - which is why the efficiency numbers, not the comm fractions, are the scaling result.</a:t>
             </a:r>
           </a:p>
         </p:txBody>

</xml_diff>

<commit_message>
Speaker notes: each results slide opens with a bridge from the previous experiment to this one
Co-Authored-By: Claude Fable 5.1 <noreply@anthropic.com>
</commit_message>
<xml_diff>
--- a/slides/compass.pptx
+++ b/slides/compass.pptx
@@ -707,6 +707,12 @@
           <a:lstStyle/>
           <a:p>
             <a:r>
+              <a:t>Bridge from the architecture: we now have three ways to run the very same 8-GPU collective — NVLink, the RDMA rails, TCP. The brief's first job is to measure distributed performance before explaining anything, so this slide is the measurement: one all-reduce, one sweep of message sizes, three paths, and NCCL's own log to prove which path each run took.</a:t>
+            </a:r>
+          </a:p>
+          <a:p/>
+          <a:p>
+            <a:r>
               <a:t>Bus bandwidth is the standard way collective benchmarks report speed: bytes moved per second, adjusted so different numbers of GPUs are comparable. Higher is better.</a:t>
             </a:r>
           </a:p>
@@ -789,6 +795,12 @@
           <a:lstStyle/>
           <a:p>
             <a:r>
+              <a:t>Bridge from the baseline: on the left of the previous curve all three paths collapsed to the same speed, which says the cost there is not bytes but a fixed cost per operation. To see that floor cleanly we re-ran the sweep at small sizes, 4 KiB to 1 MiB, on the two fast paths. The number we get here — tens of microseconds per collective regardless of size — is what the training slide and the bucket-size result are built on.</a:t>
+            </a:r>
+          </a:p>
+          <a:p/>
+          <a:p>
+            <a:r>
               <a:t>This slide exists to make the diagnosis honest: below a few MiB the network bandwidth is irrelevant; what matters is how many operations you issue. It sets up the bucket-size finding.</a:t>
             </a:r>
           </a:p>
@@ -859,6 +871,12 @@
           <a:lstStyle/>
           <a:p>
             <a:r>
+              <a:t>Bridge from the small-message floor: a fixed cost per collective means a workload's speed depends on how many collectives it issues per step as well as on how many bytes it moves. The brief asks for a representative workload at two scales; DDP training is that workload, and at the default bucket size it issues about 19 all-reduces per step — exactly the regime where both the fixed cost and the wire matter, so it is a fair test of what the baseline curve predicts.</a:t>
+            </a:r>
+          </a:p>
+          <a:p/>
+          <a:p>
+            <a:r>
               <a:t>Lead with the bucket size. DDP does not all-reduce each gradient separately: it packs gradients into buckets and launches one all-reduce per bucket as the backward pass fills them. The bucket cap here is PyTorch's default, 25 MiB. The model has 124M parameters kept in fp32 under autocast, so about 474 MiB of gradients per step, which is roughly 19 all-reduces of 25 MiB each.</a:t>
             </a:r>
           </a:p>
@@ -959,6 +977,12 @@
           <a:lstStyle/>
           <a:p>
             <a:r>
+              <a:t>Bridge from scaling: the 8-GPU run lost 23 points of efficiency moving from NVLink to the rails. The tempting story is 'the network is slow'. The brief tells us not to assume that, so this slide takes the RDMA path apart on its own: the same collective with 1, 2 and 4 rails, and a set of sustained runs made only to read the NIC, NVLink and PCIe counters while the collective is in flight. Evidence first, then the diagnosis.</a:t>
+            </a:r>
+          </a:p>
+          <a:p/>
+          <a:p>
+            <a:r>
               <a:t>How we know the rails are 800 Gb/s: we watched the NIC's transmitted-bytes counter during a sustained all-reduce and cross-checked it against ethtool's byte counter (they agree to the byte). One rail moved 411 Gb/s. The physical NIC exposes four 200 Gb/s ports per rail, and the virtual function aggregates them.</a:t>
             </a:r>
           </a:p>
@@ -1047,6 +1071,12 @@
           <a:lstStyle/>
           <a:p>
             <a:r>
+              <a:t>Bridge from the diagnosis: it left us with rails at about 55 % of their capacity, no congestion, no PCIe limit, and one NCCL connection per GPU–NIC pair. If the wire has headroom and each connection is a single flow, the obvious single change is to give each connection more queue pairs. That is the hypothesis we wrote down before running anything, and it is the one controlled change the brief asks for.</a:t>
+            </a:r>
+          </a:p>
+          <a:p/>
+          <a:p>
+            <a:r>
               <a:t>A queue pair is the RDMA equivalent of a connection between two NICs. NCCL opens one per pair of communicating GPUs by default. The knob lets it open several and stripe a message across them; it is a common tuning recommendation on large fabrics where a single flow cannot fill a link because of how switches spread traffic.</a:t>
             </a:r>
           </a:p>
@@ -1129,6 +1159,12 @@
           <a:lstStyle/>
           <a:p>
             <a:r>
+              <a:t>Bridge from the optimization: the queue-pair change went the wrong way, so the RDMA gap is not the transport's flow count. This slide asks what else could be moving the number — the GPUDirect path into the NIC, NCCL's buffers and algorithm choice, the TCP path's threading — and returns to the small-message finding: if the fixed cost per collective is a large share, issue fewer collectives. That is the DDP bucket change, and it is the one that helped.</a:t>
+            </a:r>
+          </a:p>
+          <a:p/>
+          <a:p>
+            <a:r>
               <a:t>The bucket-size result is the practical takeaway for a training team: fewer, larger all-reduces amortise the fixed cost we saw on the small-message slide. It recovers most of the gap between the RDMA and NVLink runs without touching the network.</a:t>
             </a:r>
           </a:p>
@@ -1203,6 +1239,12 @@
         <p:txBody>
           <a:bodyPr/>
           <a:lstStyle/>
+          <a:p>
+            <a:r>
+              <a:t>Bridge from the results: everything so far was two trays. What carries to a production system is the method — claim devices explicitly, prove the transport from NCCL's log, read the counters behind every number, calibrate floors per width and size — and the specific findings about where the fast path exists and how to size the workload's communication to the path it gets.</a:t>
+            </a:r>
+          </a:p>
+          <a:p/>
           <a:p>
             <a:r>
               <a:t>If asked about scheduling at scale: add a gang scheduler (Kueue) so multi-pod Jobs start together, and label nodes with their NVLink domain and fabric block so claims land where the fast path exists. Both are outside the two-tray scope but the manifests already assume one pod per tray and per-pod claims.</a:t>

</xml_diff>

<commit_message>
Training-workload slide (drawn DDP-step diagram, notes on how DDP works and why it needs the network) between the latency floor and the scaling results; docs/code-flow.md walks every Python component; demo runbook anchored to the renumbered slides and to the code entrypoints
Co-Authored-By: Claude Fable 5.1 <noreply@anthropic.com>
</commit_message>
<xml_diff>
--- a/slides/compass.pptx
+++ b/slides/compass.pptx
@@ -15,6 +15,7 @@
     <p:sldId id="263" r:id="rId15"/>
     <p:sldId id="264" r:id="rId16"/>
     <p:sldId id="265" r:id="rId17"/>
+    <p:sldId id="266" r:id="rId18"/>
   </p:sldIdLst>
   <p:sldSz cx="12191695" cy="6858000" type="screen4x3"/>
   <p:notesSz cx="6858000" cy="9144000"/>
@@ -580,6 +581,82 @@
 </p:notes>
 </file>
 
+<file path=ppt/notesSlides/notesSlide10.xml><?xml version="1.0" encoding="utf-8"?>
+<p:notes xmlns:a="http://schemas.openxmlformats.org/drawingml/2006/main" xmlns:p="http://schemas.openxmlformats.org/presentationml/2006/main" xmlns:r="http://schemas.openxmlformats.org/officeDocument/2006/relationships">
+  <p:cSld>
+    <p:spTree>
+      <p:nvGrpSpPr>
+        <p:cNvPr id="1" name=""/>
+        <p:cNvGrpSpPr/>
+        <p:nvPr/>
+      </p:nvGrpSpPr>
+      <p:grpSpPr>
+        <a:xfrm>
+          <a:off x="0" y="0"/>
+          <a:ext cx="0" cy="0"/>
+          <a:chOff x="0" y="0"/>
+          <a:chExt cx="0" cy="0"/>
+        </a:xfrm>
+      </p:grpSpPr>
+      <p:sp>
+        <p:nvSpPr>
+          <p:cNvPr id="2" name="Slide Image Placeholder 1"/>
+          <p:cNvSpPr>
+            <a:spLocks noGrp="1"/>
+          </p:cNvSpPr>
+          <p:nvPr>
+            <p:ph type="sldImg" idx="2"/>
+          </p:nvPr>
+        </p:nvSpPr>
+        <p:spPr/>
+      </p:sp>
+      <p:sp>
+        <p:nvSpPr>
+          <p:cNvPr id="3" name="Notes Placeholder 2"/>
+          <p:cNvSpPr>
+            <a:spLocks noGrp="1"/>
+          </p:cNvSpPr>
+          <p:nvPr>
+            <p:ph type="body" idx="3" sz="quarter"/>
+          </p:nvPr>
+        </p:nvSpPr>
+        <p:spPr/>
+        <p:txBody>
+          <a:bodyPr/>
+          <a:lstStyle/>
+          <a:p>
+            <a:r>
+              <a:t>Bridge from the results: everything so far was two trays. What carries to a production system is the method — claim devices explicitly, prove the transport from NCCL's log, read the counters behind every number, calibrate floors per width and size — and the specific findings about where the fast path exists and how to size the workload's communication to the path it gets.</a:t>
+            </a:r>
+          </a:p>
+          <a:p/>
+          <a:p>
+            <a:r>
+              <a:t>If asked about scheduling at scale: add a gang scheduler (Kueue) so multi-pod Jobs start together, and label nodes with their NVLink domain and fabric block so claims land where the fast path exists. Both are outside the two-tray scope but the manifests already assume one pod per tray and per-pod claims.</a:t>
+            </a:r>
+          </a:p>
+        </p:txBody>
+      </p:sp>
+      <p:sp>
+        <p:nvSpPr>
+          <p:cNvPr id="4" name="Slide Number Placeholder 3"/>
+          <p:cNvSpPr>
+            <a:spLocks noGrp="1"/>
+          </p:cNvSpPr>
+          <p:nvPr>
+            <p:ph type="sldNum" idx="5" sz="quarter"/>
+          </p:nvPr>
+        </p:nvSpPr>
+        <p:spPr/>
+      </p:sp>
+    </p:spTree>
+  </p:cSld>
+  <p:clrMapOvr>
+    <a:masterClrMapping/>
+  </p:clrMapOvr>
+</p:notes>
+</file>
+
 <file path=ppt/notesSlides/notesSlide2.xml><?xml version="1.0" encoding="utf-8"?>
 <p:notes xmlns:a="http://schemas.openxmlformats.org/drawingml/2006/main" xmlns:p="http://schemas.openxmlformats.org/presentationml/2006/main" xmlns:r="http://schemas.openxmlformats.org/officeDocument/2006/relationships">
   <p:cSld>
@@ -871,43 +948,63 @@
           <a:lstStyle/>
           <a:p>
             <a:r>
-              <a:t>Bridge from the small-message floor: a fixed cost per collective means a workload's speed depends on how many collectives it issues per step as well as on how many bytes it moves. The brief asks for a representative workload at two scales; DDP training is that workload, and at the default bucket size it issues about 19 all-reduces per step — exactly the regime where both the fixed cost and the wire matter, so it is a fair test of what the baseline curve predicts.</a:t>
+              <a:t>ON THE SLIDE (say these):</a:t>
             </a:r>
           </a:p>
           <a:p/>
           <a:p>
             <a:r>
-              <a:t>Lead with the bucket size. DDP does not all-reduce each gradient separately: it packs gradients into buckets and launches one all-reduce per bucket as the backward pass fills them. The bucket cap here is PyTorch's default, 25 MiB. The model has 124M parameters kept in fp32 under autocast, so about 474 MiB of gradients per step, which is roughly 19 all-reduces of 25 MiB each.</a:t>
+              <a:t>Eight processes (one per GPU, four per tray) each hold a full copy of a 124M-parameter GPT and train on their own batch of synthetic tokens</a:t>
             </a:r>
           </a:p>
           <a:p/>
           <a:p>
             <a:r>
-              <a:t>Why that size makes the measurement useful: 25 MiB sits at the knee of the message-size curve from the baseline slide. At that size an all-reduce is already bandwidth-sensitive (NVLink and RDMA are clearly apart: ~300 vs ~150 GB/s), but the fixed cost per collective is still a large share of its time (on either path, 16 MiB runs at about a third of the large-message speed). So with the default bucket the step is sensitive to both things at once: the wire speed, and the number of collectives issued per step.</a:t>
+              <a:t>Every step: forward, loss, backward on local data; then the gradients of all eight copies are averaged with an all-reduce, so the optimizer applies the same update everywhere and the copies stay identical</a:t>
             </a:r>
           </a:p>
           <a:p/>
           <a:p>
             <a:r>
-              <a:t>That lets two comparisons separate the two causes. Same bucket size, different transport (8 GPUs over NVLink vs over the rails: 92 % vs 69 %) isolates the wire. Same transport, different bucket size (25 vs 200 MiB over the rails, next-but-one slide: +32 %, communication share 91 % -&gt; 32 %) isolates the per-collective fixed cost. A correction to the intuition 'kernel launch overhead': the fixed cost is more than the CUDA launch - it includes NCCL's per-collective setup and handshake, the DDP reducer waiting for a bucket to be ready, and on RDMA the posting of work requests on every connection. Launch is one part of it.</a:t>
+              <a:t>DDP does this in buckets (about 19 of 25 MiB per step) and starts each bucket's all-reduce while the backward pass is still running on earlier layers</a:t>
             </a:r>
           </a:p>
           <a:p/>
           <a:p>
             <a:r>
-              <a:t>Why efficiency drops on one tray from 2 to 4 GPUs (93 % -&gt; 78 %): no NIC is involved, so it is not the network. The step is only ~21 ms of compute, so the ~19 all-reduces and their fixed costs are a bigger fraction, and the 4-rank intra-tray pattern is less efficient than the 8-rank NVSwitch reduction used across trays. Saying this out loud is the brief's 'do not assume networking is the problem'.</a:t>
+              <a:t>Inside a tray the all-reduce rides NVLink; between the trays it rides whatever the experiment selects — multi-node NVLink, the RDMA rails, or TCP — which is why this workload measures the transport</a:t>
             </a:r>
           </a:p>
           <a:p/>
-          <a:p>
-            <a:r>
-              <a:t>Why 8 GPUs over NVLink (92 %) beats 4 on one tray (78 %): across both trays NCCL uses the NVSwitch-based reduction (NVLS), which is faster per byte at 8 ranks than the 4-rank pattern.</a:t>
-            </a:r>
-          </a:p>
           <a:p/>
-          <a:p>
-            <a:r>
-              <a:t>The 'comm' figure is NCCL kernel residency over step time from torch.profiler. NCCL kernels overlap with backward compute, so it is an upper bound on exposed communication, not the time the step actually lost - which is why the efficiency numbers, not the comm fractions, are the scaling result.</a:t>
+          <a:p/>
+          <a:p>
+            <a:r>
+              <a:t>Bridge from the latency floor: we have just seen that a collective has a fixed cost of tens of microseconds regardless of size. Now we introduce the workload that issues about nineteen of them every step, because the brief asks for a representative workload at two scales and DDP training is what most GPU clusters actually run. Pause here for a moment; the next slide is its results.</a:t>
+            </a:r>
+          </a:p>
+          <a:p/>
+          <a:p>
+            <a:r>
+              <a:t>How it works, in plain terms: data parallelism means every GPU has the whole model and a different slice of the data. After each GPU computes gradients on its slice, the gradients are averaged across all GPUs (that is the all-reduce) and every GPU applies the same averaged update. Because everyone applies the same update to the same starting weights, the copies remain identical without ever copying weights around.</a:t>
+            </a:r>
+          </a:p>
+          <a:p/>
+          <a:p>
+            <a:r>
+              <a:t>What DDP adds: it does not wait for the whole backward pass to finish. It groups gradients into buckets (25 MiB by default) in reverse layer order and launches the all-reduce for a bucket as soon as that bucket is complete, so communication overlaps with the rest of the backward computation. Bigger buckets mean fewer, larger collectives; smaller buckets mean more overlap but more fixed cost. This is the knob the E5 slide turns.</a:t>
+            </a:r>
+          </a:p>
+          <a:p/>
+          <a:p>
+            <a:r>
+              <a:t>Why it uses the network: the eight GPUs are in two trays. Within a tray the gradient averaging travels over NVLink; between trays it must cross either multi-node NVLink (through the IMEX channel), the RDMA rails, or TCP. The training code does not choose; the cell's NCCL environment does. That is what makes this workload a fair probe of the transport: same code, same data volume, different wire.</a:t>
+            </a:r>
+          </a:p>
+          <a:p/>
+          <a:p>
+            <a:r>
+              <a:t>Where to find it: bench/ddp_train.py is the whole application (about 260 lines); docs/code-flow.md walks it step by step. What we record per run: step time on every rank from CUDA events, the NCCL kernel share of a step from the profiler, and NCCL's own connection log to prove which transport carried the gradients.</a:t>
             </a:r>
           </a:p>
         </p:txBody>
@@ -977,31 +1074,43 @@
           <a:lstStyle/>
           <a:p>
             <a:r>
-              <a:t>Bridge from scaling: the 8-GPU run lost 23 points of efficiency moving from NVLink to the rails. The tempting story is 'the network is slow'. The brief tells us not to assume that, so this slide takes the RDMA path apart on its own: the same collective with 1, 2 and 4 rails, and a set of sustained runs made only to read the NIC, NVLink and PCIe counters while the collective is in flight. Evidence first, then the diagnosis.</a:t>
+              <a:t>Bridge from the workload slide: we now know what one DDP step does and that it issues about nineteen all-reduces of 25 MiB each — right at the knee of the size curve from the baseline. Here is what happened when that step ran at 1, 2, 4 and 8 GPUs, and over the two transports.</a:t>
             </a:r>
           </a:p>
           <a:p/>
           <a:p>
             <a:r>
-              <a:t>How we know the rails are 800 Gb/s: we watched the NIC's transmitted-bytes counter during a sustained all-reduce and cross-checked it against ethtool's byte counter (they agree to the byte). One rail moved 411 Gb/s. The physical NIC exposes four 200 Gb/s ports per rail, and the virtual function aggregates them.</a:t>
+              <a:t>Lead with the bucket size. DDP does not all-reduce each gradient separately: it packs gradients into buckets and launches one all-reduce per bucket as the backward pass fills them. The bucket cap here is PyTorch's default, 25 MiB. The model has 124M parameters kept in fp32 under autocast, so about 474 MiB of gradients per step, which is roughly 19 all-reduces of 25 MiB each.</a:t>
             </a:r>
           </a:p>
           <a:p/>
           <a:p>
             <a:r>
-              <a:t>How we know it is not congestion: the same watcher reads the RoCE congestion-control counters (CNPs sent and handled, ECN-marked packets) and the reliability counters (out-of-sequence, sequence errors, ACK timeouts). All flat at zero per second during every run.</a:t>
+              <a:t>Why that size makes the measurement useful: 25 MiB sits at the knee of the message-size curve from the baseline slide. At that size an all-reduce is already bandwidth-sensitive (NVLink and RDMA are clearly apart: ~300 vs ~150 GB/s), but the fixed cost per collective is still a large share of its time (on either path, 16 MiB runs at about a third of the large-message speed). So with the default bucket the step is sensitive to both things at once: the wire speed, and the number of collectives issued per step.</a:t>
             </a:r>
           </a:p>
           <a:p/>
           <a:p>
             <a:r>
-              <a:t>How we know it is not PCIe: lspci shows 64 GT/s x16 on the ConnectX-8 and on the GPU, about 120 GB/s per direction, against about 60 GB/s used per rail.</a:t>
+              <a:t>That lets two comparisons separate the two causes. Same bucket size, different transport (8 GPUs over NVLink vs over the rails: 92 % vs 69 %) isolates the wire. Same transport, different bucket size (25 vs 200 MiB over the rails, next-but-one slide: +32 %, communication share 91 % -&gt; 32 %) isolates the per-collective fixed cost. A correction to the intuition 'kernel launch overhead': the fixed cost is more than the CUDA launch - it includes NCCL's per-collective setup and handshake, the DDP reducer waiting for a bucket to be ready, and on RDMA the posting of work requests on every connection. Launch is one part of it.</a:t>
             </a:r>
           </a:p>
           <a:p/>
           <a:p>
             <a:r>
-              <a:t>The GPUDirect-off run (next slide) shows the same bytes on the wire taking 1.6x longer — that is the cost of bouncing through host memory, not a network effect.</a:t>
+              <a:t>Why efficiency drops on one tray from 2 to 4 GPUs (93 % -&gt; 78 %): no NIC is involved, so it is not the network. The step is only ~21 ms of compute, so the ~19 all-reduces and their fixed costs are a bigger fraction, and the 4-rank intra-tray pattern is less efficient than the 8-rank NVSwitch reduction used across trays. Saying this out loud is the brief's 'do not assume networking is the problem'.</a:t>
+            </a:r>
+          </a:p>
+          <a:p/>
+          <a:p>
+            <a:r>
+              <a:t>Why 8 GPUs over NVLink (92 %) beats 4 on one tray (78 %): across both trays NCCL uses the NVSwitch-based reduction (NVLS), which is faster per byte at 8 ranks than the 4-rank pattern.</a:t>
+            </a:r>
+          </a:p>
+          <a:p/>
+          <a:p>
+            <a:r>
+              <a:t>The 'comm' figure is NCCL kernel residency over step time from torch.profiler. NCCL kernels overlap with backward compute, so it is an upper bound on exposed communication, not the time the step actually lost - which is why the efficiency numbers, not the comm fractions, are the scaling result.</a:t>
             </a:r>
           </a:p>
         </p:txBody>
@@ -1071,25 +1180,31 @@
           <a:lstStyle/>
           <a:p>
             <a:r>
-              <a:t>Bridge from the diagnosis: it left us with rails at about 55 % of their capacity, no congestion, no PCIe limit, and one NCCL connection per GPU–NIC pair. If the wire has headroom and each connection is a single flow, the obvious single change is to give each connection more queue pairs. That is the hypothesis we wrote down before running anything, and it is the one controlled change the brief asks for.</a:t>
+              <a:t>Bridge from scaling: the 8-GPU run lost 23 points of efficiency moving from NVLink to the rails. The tempting story is 'the network is slow'. The brief tells us not to assume that, so this slide takes the RDMA path apart on its own: the same collective with 1, 2 and 4 rails, and a set of sustained runs made only to read the NIC, NVLink and PCIe counters while the collective is in flight. Evidence first, then the diagnosis.</a:t>
             </a:r>
           </a:p>
           <a:p/>
           <a:p>
             <a:r>
-              <a:t>A queue pair is the RDMA equivalent of a connection between two NICs. NCCL opens one per pair of communicating GPUs by default. The knob lets it open several and stripe a message across them; it is a common tuning recommendation on large fabrics where a single flow cannot fill a link because of how switches spread traffic.</a:t>
+              <a:t>How we know the rails are 800 Gb/s: we watched the NIC's transmitted-bytes counter during a sustained all-reduce and cross-checked it against ethtool's byte counter (they agree to the byte). One rail moved 411 Gb/s. The physical NIC exposes four 200 Gb/s ports per rail, and the virtual function aggregates them.</a:t>
             </a:r>
           </a:p>
           <a:p/>
           <a:p>
             <a:r>
-              <a:t>Here there is one switch hop between matching rails, so striping buys nothing and costs overhead. The counters make the explanation concrete: fewer bytes per second on each rail, no errors, no congestion — the sender is simply doing less useful work per unit time.</a:t>
+              <a:t>How we know it is not congestion: the same watcher reads the RoCE congestion-control counters (CNPs sent and handled, ECN-marked packets) and the reliability counters (out-of-sequence, sequence errors, ACK timeouts). All flat at zero per second during every run.</a:t>
             </a:r>
           </a:p>
           <a:p/>
           <a:p>
             <a:r>
-              <a:t>The p-values are from Welch's t-test across the five repeats of baseline versus change; run-to-run spread within a cell is under 2 % except one 4 GiB outlier, so the differences are real.</a:t>
+              <a:t>How we know it is not PCIe: lspci shows 64 GT/s x16 on the ConnectX-8 and on the GPU, about 120 GB/s per direction, against about 60 GB/s used per rail.</a:t>
+            </a:r>
+          </a:p>
+          <a:p/>
+          <a:p>
+            <a:r>
+              <a:t>The GPUDirect-off run (next slide) shows the same bytes on the wire taking 1.6x longer — that is the cost of bouncing through host memory, not a network effect.</a:t>
             </a:r>
           </a:p>
         </p:txBody>
@@ -1159,19 +1274,25 @@
           <a:lstStyle/>
           <a:p>
             <a:r>
-              <a:t>Bridge from the optimization: the queue-pair change went the wrong way, so the RDMA gap is not the transport's flow count. This slide asks what else could be moving the number — the GPUDirect path into the NIC, NCCL's buffers and algorithm choice, the TCP path's threading — and returns to the small-message finding: if the fixed cost per collective is a large share, issue fewer collectives. That is the DDP bucket change, and it is the one that helped.</a:t>
+              <a:t>Bridge from the diagnosis: it left us with rails at about 55 % of their capacity, no congestion, no PCIe limit, and one NCCL connection per GPU–NIC pair. If the wire has headroom and each connection is a single flow, the obvious single change is to give each connection more queue pairs. That is the hypothesis we wrote down before running anything, and it is the one controlled change the brief asks for.</a:t>
             </a:r>
           </a:p>
           <a:p/>
           <a:p>
             <a:r>
-              <a:t>The bucket-size result is the practical takeaway for a training team: fewer, larger all-reduces amortise the fixed cost we saw on the small-message slide. It recovers most of the gap between the RDMA and NVLink runs without touching the network.</a:t>
+              <a:t>A queue pair is the RDMA equivalent of a connection between two NICs. NCCL opens one per pair of communicating GPUs by default. The knob lets it open several and stripe a message across them; it is a common tuning recommendation on large fabrics where a single flow cannot fill a link because of how switches spread traffic.</a:t>
             </a:r>
           </a:p>
           <a:p/>
           <a:p>
             <a:r>
-              <a:t>The Tree entry is kept on purpose: the exercise asks for honest reporting, and 'that configuration is invalid' is a finding too.</a:t>
+              <a:t>Here there is one switch hop between matching rails, so striping buys nothing and costs overhead. The counters make the explanation concrete: fewer bytes per second on each rail, no errors, no congestion — the sender is simply doing less useful work per unit time.</a:t>
+            </a:r>
+          </a:p>
+          <a:p/>
+          <a:p>
+            <a:r>
+              <a:t>The p-values are from Welch's t-test across the five repeats of baseline versus change; run-to-run spread within a cell is under 2 % except one 4 GiB outlier, so the differences are real.</a:t>
             </a:r>
           </a:p>
         </p:txBody>
@@ -1241,13 +1362,19 @@
           <a:lstStyle/>
           <a:p>
             <a:r>
-              <a:t>Bridge from the results: everything so far was two trays. What carries to a production system is the method — claim devices explicitly, prove the transport from NCCL's log, read the counters behind every number, calibrate floors per width and size — and the specific findings about where the fast path exists and how to size the workload's communication to the path it gets.</a:t>
+              <a:t>Bridge from the optimization: the queue-pair change went the wrong way, so the RDMA gap is not the transport's flow count. This slide asks what else could be moving the number — the GPUDirect path into the NIC, NCCL's buffers and algorithm choice, the TCP path's threading — and returns to the small-message finding: if the fixed cost per collective is a large share, issue fewer collectives. That is the DDP bucket change, and it is the one that helped.</a:t>
             </a:r>
           </a:p>
           <a:p/>
           <a:p>
             <a:r>
-              <a:t>If asked about scheduling at scale: add a gang scheduler (Kueue) so multi-pod Jobs start together, and label nodes with their NVLink domain and fabric block so claims land where the fast path exists. Both are outside the two-tray scope but the manifests already assume one pod per tray and per-pod claims.</a:t>
+              <a:t>The bucket-size result is the practical takeaway for a training team: fewer, larger all-reduces amortise the fixed cost we saw on the small-message slide. It recovers most of the gap between the RDMA and NVLink runs without touching the network.</a:t>
+            </a:r>
+          </a:p>
+          <a:p/>
+          <a:p>
+            <a:r>
+              <a:t>The Tree entry is kept on purpose: the exercise asks for honest reporting, and 'that configuration is invalid' is a finding too.</a:t>
             </a:r>
           </a:p>
         </p:txBody>
@@ -4348,6 +4475,914 @@
               </a:defRPr>
             </a:pPr>
             <a:r>
+              <a:t>5 · Other knobs we measured, and the one that actually helps the workload</a:t>
+            </a:r>
+          </a:p>
+        </p:txBody>
+      </p:sp>
+      <p:sp>
+        <p:nvSpPr>
+          <p:cNvPr id="3" name="TextBox 2"/>
+          <p:cNvSpPr txBox="1"/>
+          <p:nvPr/>
+        </p:nvSpPr>
+        <p:spPr>
+          <a:xfrm>
+            <a:off x="548640" y="1188720"/>
+            <a:ext cx="5486400" cy="5029200"/>
+          </a:xfrm>
+          <a:prstGeom prst="rect">
+            <a:avLst/>
+          </a:prstGeom>
+          <a:noFill/>
+        </p:spPr>
+        <p:txBody>
+          <a:bodyPr wrap="square">
+            <a:spAutoFit/>
+          </a:bodyPr>
+          <a:lstStyle/>
+          <a:p>
+            <a:pPr>
+              <a:spcAft>
+                <a:spcPts val="600"/>
+              </a:spcAft>
+              <a:defRPr sz="1400">
+                <a:solidFill>
+                  <a:srgbClr val="0B0B0B"/>
+                </a:solidFill>
+              </a:defRPr>
+            </a:pPr>
+            <a:r>
+              <a:t>• GPUDirect off: −38 % — same bytes on the wire, 1.6× the time; the cost of copying through host memory</a:t>
+            </a:r>
+          </a:p>
+          <a:p>
+            <a:pPr>
+              <a:spcAft>
+                <a:spcPts val="600"/>
+              </a:spcAft>
+              <a:defRPr sz="1400">
+                <a:solidFill>
+                  <a:srgbClr val="0B0B0B"/>
+                </a:solidFill>
+              </a:defRPr>
+            </a:pPr>
+            <a:r>
+              <a:t>• Bigger NCCL buffers: no change. NVLS vs Ring algorithm on NVLink: 474 vs 388 GB/s — the NVSwitch reduction is what keeps the NVLink curve climbing. 'Tree' is not valid for this collective set (NCCL has no tree all-gather)</a:t>
+            </a:r>
+          </a:p>
+          <a:p>
+            <a:pPr>
+              <a:spcAft>
+                <a:spcPts val="600"/>
+              </a:spcAft>
+              <a:defRPr sz="1400">
+                <a:solidFill>
+                  <a:srgbClr val="0B0B0B"/>
+                </a:solidFill>
+              </a:defRPr>
+            </a:pPr>
+            <a:r>
+              <a:t>• TCP with more socket threads: 7× faster than default TCP, still 14× slower than RDMA</a:t>
+            </a:r>
+          </a:p>
+          <a:p>
+            <a:pPr>
+              <a:spcAft>
+                <a:spcPts val="600"/>
+              </a:spcAft>
+              <a:defRPr sz="1400">
+                <a:solidFill>
+                  <a:srgbClr val="0B0B0B"/>
+                </a:solidFill>
+              </a:defRPr>
+            </a:pPr>
+            <a:r>
+              <a:t>• DDP gradient buckets 25 → 200 MiB over the rails: 2090 → 2769 samples/s (+32 %); communication share of the step falls from 91 % to 32 %. On a slower interconnect, change how often you communicate before changing how</a:t>
+            </a:r>
+          </a:p>
+        </p:txBody>
+      </p:sp>
+      <p:graphicFrame>
+        <p:nvGraphicFramePr>
+          <p:cNvPr id="4" name="Table 3"/>
+          <p:cNvGraphicFramePr>
+            <a:graphicFrameLocks noGrp="1"/>
+          </p:cNvGraphicFramePr>
+          <p:nvPr/>
+        </p:nvGraphicFramePr>
+        <p:xfrm>
+          <a:off x="6217920" y="1188720"/>
+          <a:ext cx="5486400" cy="3291839"/>
+        </p:xfrm>
+        <a:graphic>
+          <a:graphicData uri="http://schemas.openxmlformats.org/drawingml/2006/table">
+            <a:tbl>
+              <a:tblPr firstRow="1" bandRow="1">
+                <a:tableStyleId>{5C22544A-7EE6-4342-B048-85BDC9FD1C3A}</a:tableStyleId>
+              </a:tblPr>
+              <a:tblGrid>
+                <a:gridCol w="1371600"/>
+                <a:gridCol w="1371600"/>
+                <a:gridCol w="1371600"/>
+                <a:gridCol w="1371600"/>
+              </a:tblGrid>
+              <a:tr h="274319">
+                <a:tc>
+                  <a:txBody>
+                    <a:bodyPr/>
+                    <a:lstStyle/>
+                    <a:p>
+                      <a:pPr>
+                        <a:defRPr sz="900" b="1"/>
+                      </a:pPr>
+                      <a:r>
+                        <a:t>run_id</a:t>
+                      </a:r>
+                    </a:p>
+                  </a:txBody>
+                  <a:tcPr/>
+                </a:tc>
+                <a:tc>
+                  <a:txBody>
+                    <a:bodyPr/>
+                    <a:lstStyle/>
+                    <a:p>
+                      <a:pPr>
+                        <a:defRPr sz="900" b="1"/>
+                      </a:pPr>
+                      <a:r>
+                        <a:t>16MiB</a:t>
+                      </a:r>
+                    </a:p>
+                  </a:txBody>
+                  <a:tcPr/>
+                </a:tc>
+                <a:tc>
+                  <a:txBody>
+                    <a:bodyPr/>
+                    <a:lstStyle/>
+                    <a:p>
+                      <a:pPr>
+                        <a:defRPr sz="900" b="1"/>
+                      </a:pPr>
+                      <a:r>
+                        <a:t>512MiB</a:t>
+                      </a:r>
+                    </a:p>
+                  </a:txBody>
+                  <a:tcPr/>
+                </a:tc>
+                <a:tc>
+                  <a:txBody>
+                    <a:bodyPr/>
+                    <a:lstStyle/>
+                    <a:p>
+                      <a:pPr>
+                        <a:defRPr sz="900" b="1"/>
+                      </a:pPr>
+                      <a:r>
+                        <a:t>4GiB</a:t>
+                      </a:r>
+                    </a:p>
+                  </a:txBody>
+                  <a:tcPr/>
+                </a:tc>
+              </a:tr>
+              <a:tr h="274319">
+                <a:tc>
+                  <a:txBody>
+                    <a:bodyPr/>
+                    <a:lstStyle/>
+                    <a:p>
+                      <a:pPr>
+                        <a:defRPr sz="900"/>
+                      </a:pPr>
+                      <a:r>
+                        <a:t>e5-algo-nvls</a:t>
+                      </a:r>
+                    </a:p>
+                  </a:txBody>
+                  <a:tcPr/>
+                </a:tc>
+                <a:tc>
+                  <a:txBody>
+                    <a:bodyPr/>
+                    <a:lstStyle/>
+                    <a:p>
+                      <a:pPr>
+                        <a:defRPr sz="900"/>
+                      </a:pPr>
+                      <a:r>
+                        <a:t>297</a:t>
+                      </a:r>
+                    </a:p>
+                  </a:txBody>
+                  <a:tcPr/>
+                </a:tc>
+                <a:tc>
+                  <a:txBody>
+                    <a:bodyPr/>
+                    <a:lstStyle/>
+                    <a:p>
+                      <a:pPr>
+                        <a:defRPr sz="900"/>
+                      </a:pPr>
+                      <a:r>
+                        <a:t>695</a:t>
+                      </a:r>
+                    </a:p>
+                  </a:txBody>
+                  <a:tcPr/>
+                </a:tc>
+                <a:tc>
+                  <a:txBody>
+                    <a:bodyPr/>
+                    <a:lstStyle/>
+                    <a:p>
+                      <a:pPr>
+                        <a:defRPr sz="900"/>
+                      </a:pPr>
+                      <a:r>
+                        <a:t>830</a:t>
+                      </a:r>
+                    </a:p>
+                  </a:txBody>
+                  <a:tcPr/>
+                </a:tc>
+              </a:tr>
+              <a:tr h="274319">
+                <a:tc>
+                  <a:txBody>
+                    <a:bodyPr/>
+                    <a:lstStyle/>
+                    <a:p>
+                      <a:pPr>
+                        <a:defRPr sz="900"/>
+                      </a:pPr>
+                      <a:r>
+                        <a:t>e5-algo-ring</a:t>
+                      </a:r>
+                    </a:p>
+                  </a:txBody>
+                  <a:tcPr/>
+                </a:tc>
+                <a:tc>
+                  <a:txBody>
+                    <a:bodyPr/>
+                    <a:lstStyle/>
+                    <a:p>
+                      <a:pPr>
+                        <a:defRPr sz="900"/>
+                      </a:pPr>
+                      <a:r>
+                        <a:t>327</a:t>
+                      </a:r>
+                    </a:p>
+                  </a:txBody>
+                  <a:tcPr/>
+                </a:tc>
+                <a:tc>
+                  <a:txBody>
+                    <a:bodyPr/>
+                    <a:lstStyle/>
+                    <a:p>
+                      <a:pPr>
+                        <a:defRPr sz="900"/>
+                      </a:pPr>
+                      <a:r>
+                        <a:t>635</a:t>
+                      </a:r>
+                    </a:p>
+                  </a:txBody>
+                  <a:tcPr/>
+                </a:tc>
+                <a:tc>
+                  <a:txBody>
+                    <a:bodyPr/>
+                    <a:lstStyle/>
+                    <a:p>
+                      <a:pPr>
+                        <a:defRPr sz="900"/>
+                      </a:pPr>
+                      <a:r>
+                        <a:t>679</a:t>
+                      </a:r>
+                    </a:p>
+                  </a:txBody>
+                  <a:tcPr/>
+                </a:tc>
+              </a:tr>
+              <a:tr h="274319">
+                <a:tc>
+                  <a:txBody>
+                    <a:bodyPr/>
+                    <a:lstStyle/>
+                    <a:p>
+                      <a:pPr>
+                        <a:defRPr sz="900"/>
+                      </a:pPr>
+                      <a:r>
+                        <a:t>e5-buffsize16m</a:t>
+                      </a:r>
+                    </a:p>
+                  </a:txBody>
+                  <a:tcPr/>
+                </a:tc>
+                <a:tc>
+                  <a:txBody>
+                    <a:bodyPr/>
+                    <a:lstStyle/>
+                    <a:p>
+                      <a:pPr>
+                        <a:defRPr sz="900"/>
+                      </a:pPr>
+                      <a:r>
+                        <a:t>101</a:t>
+                      </a:r>
+                    </a:p>
+                  </a:txBody>
+                  <a:tcPr/>
+                </a:tc>
+                <a:tc>
+                  <a:txBody>
+                    <a:bodyPr/>
+                    <a:lstStyle/>
+                    <a:p>
+                      <a:pPr>
+                        <a:defRPr sz="900"/>
+                      </a:pPr>
+                      <a:r>
+                        <a:t>420</a:t>
+                      </a:r>
+                    </a:p>
+                  </a:txBody>
+                  <a:tcPr/>
+                </a:tc>
+                <a:tc>
+                  <a:txBody>
+                    <a:bodyPr/>
+                    <a:lstStyle/>
+                    <a:p>
+                      <a:pPr>
+                        <a:defRPr sz="900"/>
+                      </a:pPr>
+                      <a:r>
+                        <a:t>393</a:t>
+                      </a:r>
+                    </a:p>
+                  </a:txBody>
+                  <a:tcPr/>
+                </a:tc>
+              </a:tr>
+              <a:tr h="274319">
+                <a:tc>
+                  <a:txBody>
+                    <a:bodyPr/>
+                    <a:lstStyle/>
+                    <a:p>
+                      <a:pPr>
+                        <a:defRPr sz="900"/>
+                      </a:pPr>
+                      <a:r>
+                        <a:t>e5-buffsize4m</a:t>
+                      </a:r>
+                    </a:p>
+                  </a:txBody>
+                  <a:tcPr/>
+                </a:tc>
+                <a:tc>
+                  <a:txBody>
+                    <a:bodyPr/>
+                    <a:lstStyle/>
+                    <a:p>
+                      <a:pPr>
+                        <a:defRPr sz="900"/>
+                      </a:pPr>
+                      <a:r>
+                        <a:t>102</a:t>
+                      </a:r>
+                    </a:p>
+                  </a:txBody>
+                  <a:tcPr/>
+                </a:tc>
+                <a:tc>
+                  <a:txBody>
+                    <a:bodyPr/>
+                    <a:lstStyle/>
+                    <a:p>
+                      <a:pPr>
+                        <a:defRPr sz="900"/>
+                      </a:pPr>
+                      <a:r>
+                        <a:t>402</a:t>
+                      </a:r>
+                    </a:p>
+                  </a:txBody>
+                  <a:tcPr/>
+                </a:tc>
+                <a:tc>
+                  <a:txBody>
+                    <a:bodyPr/>
+                    <a:lstStyle/>
+                    <a:p>
+                      <a:pPr>
+                        <a:defRPr sz="900"/>
+                      </a:pPr>
+                      <a:r>
+                        <a:t>419</a:t>
+                      </a:r>
+                    </a:p>
+                  </a:txBody>
+                  <a:tcPr/>
+                </a:tc>
+              </a:tr>
+              <a:tr h="274319">
+                <a:tc>
+                  <a:txBody>
+                    <a:bodyPr/>
+                    <a:lstStyle/>
+                    <a:p>
+                      <a:pPr>
+                        <a:defRPr sz="900"/>
+                      </a:pPr>
+                      <a:r>
+                        <a:t>e5-counters-gdr-off</a:t>
+                      </a:r>
+                    </a:p>
+                  </a:txBody>
+                  <a:tcPr/>
+                </a:tc>
+                <a:tc>
+                  <a:txBody>
+                    <a:bodyPr/>
+                    <a:lstStyle/>
+                    <a:p>
+                      <a:pPr>
+                        <a:defRPr sz="900"/>
+                      </a:pPr>
+                      <a:r>
+                        <a:t>nan</a:t>
+                      </a:r>
+                    </a:p>
+                  </a:txBody>
+                  <a:tcPr/>
+                </a:tc>
+                <a:tc>
+                  <a:txBody>
+                    <a:bodyPr/>
+                    <a:lstStyle/>
+                    <a:p>
+                      <a:pPr>
+                        <a:defRPr sz="900"/>
+                      </a:pPr>
+                      <a:r>
+                        <a:t>nan</a:t>
+                      </a:r>
+                    </a:p>
+                  </a:txBody>
+                  <a:tcPr/>
+                </a:tc>
+                <a:tc>
+                  <a:txBody>
+                    <a:bodyPr/>
+                    <a:lstStyle/>
+                    <a:p>
+                      <a:pPr>
+                        <a:defRPr sz="900"/>
+                      </a:pPr>
+                      <a:r>
+                        <a:t>253</a:t>
+                      </a:r>
+                    </a:p>
+                  </a:txBody>
+                  <a:tcPr/>
+                </a:tc>
+              </a:tr>
+              <a:tr h="274319">
+                <a:tc>
+                  <a:txBody>
+                    <a:bodyPr/>
+                    <a:lstStyle/>
+                    <a:p>
+                      <a:pPr>
+                        <a:defRPr sz="900"/>
+                      </a:pPr>
+                      <a:r>
+                        <a:t>e5-counters-nvlink</a:t>
+                      </a:r>
+                    </a:p>
+                  </a:txBody>
+                  <a:tcPr/>
+                </a:tc>
+                <a:tc>
+                  <a:txBody>
+                    <a:bodyPr/>
+                    <a:lstStyle/>
+                    <a:p>
+                      <a:pPr>
+                        <a:defRPr sz="900"/>
+                      </a:pPr>
+                      <a:r>
+                        <a:t>nan</a:t>
+                      </a:r>
+                    </a:p>
+                  </a:txBody>
+                  <a:tcPr/>
+                </a:tc>
+                <a:tc>
+                  <a:txBody>
+                    <a:bodyPr/>
+                    <a:lstStyle/>
+                    <a:p>
+                      <a:pPr>
+                        <a:defRPr sz="900"/>
+                      </a:pPr>
+                      <a:r>
+                        <a:t>nan</a:t>
+                      </a:r>
+                    </a:p>
+                  </a:txBody>
+                  <a:tcPr/>
+                </a:tc>
+                <a:tc>
+                  <a:txBody>
+                    <a:bodyPr/>
+                    <a:lstStyle/>
+                    <a:p>
+                      <a:pPr>
+                        <a:defRPr sz="900"/>
+                      </a:pPr>
+                      <a:r>
+                        <a:t>833</a:t>
+                      </a:r>
+                    </a:p>
+                  </a:txBody>
+                  <a:tcPr/>
+                </a:tc>
+              </a:tr>
+              <a:tr h="274319">
+                <a:tc>
+                  <a:txBody>
+                    <a:bodyPr/>
+                    <a:lstStyle/>
+                    <a:p>
+                      <a:pPr>
+                        <a:defRPr sz="900"/>
+                      </a:pPr>
+                      <a:r>
+                        <a:t>e5-counters-rails1</a:t>
+                      </a:r>
+                    </a:p>
+                  </a:txBody>
+                  <a:tcPr/>
+                </a:tc>
+                <a:tc>
+                  <a:txBody>
+                    <a:bodyPr/>
+                    <a:lstStyle/>
+                    <a:p>
+                      <a:pPr>
+                        <a:defRPr sz="900"/>
+                      </a:pPr>
+                      <a:r>
+                        <a:t>nan</a:t>
+                      </a:r>
+                    </a:p>
+                  </a:txBody>
+                  <a:tcPr/>
+                </a:tc>
+                <a:tc>
+                  <a:txBody>
+                    <a:bodyPr/>
+                    <a:lstStyle/>
+                    <a:p>
+                      <a:pPr>
+                        <a:defRPr sz="900"/>
+                      </a:pPr>
+                      <a:r>
+                        <a:t>nan</a:t>
+                      </a:r>
+                    </a:p>
+                  </a:txBody>
+                  <a:tcPr/>
+                </a:tc>
+                <a:tc>
+                  <a:txBody>
+                    <a:bodyPr/>
+                    <a:lstStyle/>
+                    <a:p>
+                      <a:pPr>
+                        <a:defRPr sz="900"/>
+                      </a:pPr>
+                      <a:r>
+                        <a:t>87.8</a:t>
+                      </a:r>
+                    </a:p>
+                  </a:txBody>
+                  <a:tcPr/>
+                </a:tc>
+              </a:tr>
+              <a:tr h="274319">
+                <a:tc>
+                  <a:txBody>
+                    <a:bodyPr/>
+                    <a:lstStyle/>
+                    <a:p>
+                      <a:pPr>
+                        <a:defRPr sz="900"/>
+                      </a:pPr>
+                      <a:r>
+                        <a:t>e5-counters-rdma</a:t>
+                      </a:r>
+                    </a:p>
+                  </a:txBody>
+                  <a:tcPr/>
+                </a:tc>
+                <a:tc>
+                  <a:txBody>
+                    <a:bodyPr/>
+                    <a:lstStyle/>
+                    <a:p>
+                      <a:pPr>
+                        <a:defRPr sz="900"/>
+                      </a:pPr>
+                      <a:r>
+                        <a:t>nan</a:t>
+                      </a:r>
+                    </a:p>
+                  </a:txBody>
+                  <a:tcPr/>
+                </a:tc>
+                <a:tc>
+                  <a:txBody>
+                    <a:bodyPr/>
+                    <a:lstStyle/>
+                    <a:p>
+                      <a:pPr>
+                        <a:defRPr sz="900"/>
+                      </a:pPr>
+                      <a:r>
+                        <a:t>nan</a:t>
+                      </a:r>
+                    </a:p>
+                  </a:txBody>
+                  <a:tcPr/>
+                </a:tc>
+                <a:tc>
+                  <a:txBody>
+                    <a:bodyPr/>
+                    <a:lstStyle/>
+                    <a:p>
+                      <a:pPr>
+                        <a:defRPr sz="900"/>
+                      </a:pPr>
+                      <a:r>
+                        <a:t>410</a:t>
+                      </a:r>
+                    </a:p>
+                  </a:txBody>
+                  <a:tcPr/>
+                </a:tc>
+              </a:tr>
+              <a:tr h="274319">
+                <a:tc>
+                  <a:txBody>
+                    <a:bodyPr/>
+                    <a:lstStyle/>
+                    <a:p>
+                      <a:pPr>
+                        <a:defRPr sz="900"/>
+                      </a:pPr>
+                      <a:r>
+                        <a:t>e5-counters-rdma-qps4</a:t>
+                      </a:r>
+                    </a:p>
+                  </a:txBody>
+                  <a:tcPr/>
+                </a:tc>
+                <a:tc>
+                  <a:txBody>
+                    <a:bodyPr/>
+                    <a:lstStyle/>
+                    <a:p>
+                      <a:pPr>
+                        <a:defRPr sz="900"/>
+                      </a:pPr>
+                      <a:r>
+                        <a:t>nan</a:t>
+                      </a:r>
+                    </a:p>
+                  </a:txBody>
+                  <a:tcPr/>
+                </a:tc>
+                <a:tc>
+                  <a:txBody>
+                    <a:bodyPr/>
+                    <a:lstStyle/>
+                    <a:p>
+                      <a:pPr>
+                        <a:defRPr sz="900"/>
+                      </a:pPr>
+                      <a:r>
+                        <a:t>nan</a:t>
+                      </a:r>
+                    </a:p>
+                  </a:txBody>
+                  <a:tcPr/>
+                </a:tc>
+                <a:tc>
+                  <a:txBody>
+                    <a:bodyPr/>
+                    <a:lstStyle/>
+                    <a:p>
+                      <a:pPr>
+                        <a:defRPr sz="900"/>
+                      </a:pPr>
+                      <a:r>
+                        <a:t>301</a:t>
+                      </a:r>
+                    </a:p>
+                  </a:txBody>
+                  <a:tcPr/>
+                </a:tc>
+              </a:tr>
+              <a:tr h="274319">
+                <a:tc>
+                  <a:txBody>
+                    <a:bodyPr/>
+                    <a:lstStyle/>
+                    <a:p>
+                      <a:pPr>
+                        <a:defRPr sz="900"/>
+                      </a:pPr>
+                      <a:r>
+                        <a:t>e5-gdr-off</a:t>
+                      </a:r>
+                    </a:p>
+                  </a:txBody>
+                  <a:tcPr/>
+                </a:tc>
+                <a:tc>
+                  <a:txBody>
+                    <a:bodyPr/>
+                    <a:lstStyle/>
+                    <a:p>
+                      <a:pPr>
+                        <a:defRPr sz="900"/>
+                      </a:pPr>
+                      <a:r>
+                        <a:t>107</a:t>
+                      </a:r>
+                    </a:p>
+                  </a:txBody>
+                  <a:tcPr/>
+                </a:tc>
+                <a:tc>
+                  <a:txBody>
+                    <a:bodyPr/>
+                    <a:lstStyle/>
+                    <a:p>
+                      <a:pPr>
+                        <a:defRPr sz="900"/>
+                      </a:pPr>
+                      <a:r>
+                        <a:t>222</a:t>
+                      </a:r>
+                    </a:p>
+                  </a:txBody>
+                  <a:tcPr/>
+                </a:tc>
+                <a:tc>
+                  <a:txBody>
+                    <a:bodyPr/>
+                    <a:lstStyle/>
+                    <a:p>
+                      <a:pPr>
+                        <a:defRPr sz="900"/>
+                      </a:pPr>
+                      <a:r>
+                        <a:t>247</a:t>
+                      </a:r>
+                    </a:p>
+                  </a:txBody>
+                  <a:tcPr/>
+                </a:tc>
+              </a:tr>
+              <a:tr h="274330">
+                <a:tc>
+                  <a:txBody>
+                    <a:bodyPr/>
+                    <a:lstStyle/>
+                    <a:p>
+                      <a:pPr>
+                        <a:defRPr sz="900"/>
+                      </a:pPr>
+                      <a:r>
+                        <a:t>e5-sock-nthreads4</a:t>
+                      </a:r>
+                    </a:p>
+                  </a:txBody>
+                  <a:tcPr/>
+                </a:tc>
+                <a:tc>
+                  <a:txBody>
+                    <a:bodyPr/>
+                    <a:lstStyle/>
+                    <a:p>
+                      <a:pPr>
+                        <a:defRPr sz="900"/>
+                      </a:pPr>
+                      <a:r>
+                        <a:t>10.3</a:t>
+                      </a:r>
+                    </a:p>
+                  </a:txBody>
+                  <a:tcPr/>
+                </a:tc>
+                <a:tc>
+                  <a:txBody>
+                    <a:bodyPr/>
+                    <a:lstStyle/>
+                    <a:p>
+                      <a:pPr>
+                        <a:defRPr sz="900"/>
+                      </a:pPr>
+                      <a:r>
+                        <a:t>21.6</a:t>
+                      </a:r>
+                    </a:p>
+                  </a:txBody>
+                  <a:tcPr/>
+                </a:tc>
+                <a:tc>
+                  <a:txBody>
+                    <a:bodyPr/>
+                    <a:lstStyle/>
+                    <a:p>
+                      <a:pPr>
+                        <a:defRPr sz="900"/>
+                      </a:pPr>
+                      <a:r>
+                        <a:t>29.4</a:t>
+                      </a:r>
+                    </a:p>
+                  </a:txBody>
+                  <a:tcPr/>
+                </a:tc>
+              </a:tr>
+            </a:tbl>
+          </a:graphicData>
+        </a:graphic>
+      </p:graphicFrame>
+    </p:spTree>
+  </p:cSld>
+  <p:clrMapOvr>
+    <a:masterClrMapping/>
+  </p:clrMapOvr>
+</p:sld>
+</file>
+
+<file path=ppt/slides/slide11.xml><?xml version="1.0" encoding="utf-8"?>
+<p:sld xmlns:a="http://schemas.openxmlformats.org/drawingml/2006/main" xmlns:p="http://schemas.openxmlformats.org/presentationml/2006/main" xmlns:r="http://schemas.openxmlformats.org/officeDocument/2006/relationships">
+  <p:cSld>
+    <p:spTree>
+      <p:nvGrpSpPr>
+        <p:cNvPr id="1" name=""/>
+        <p:cNvGrpSpPr/>
+        <p:nvPr/>
+      </p:nvGrpSpPr>
+      <p:grpSpPr/>
+      <p:sp>
+        <p:nvSpPr>
+          <p:cNvPr id="2" name="TextBox 1"/>
+          <p:cNvSpPr txBox="1"/>
+          <p:nvPr/>
+        </p:nvSpPr>
+        <p:spPr>
+          <a:xfrm>
+            <a:off x="457200" y="274320"/>
+            <a:ext cx="11247120" cy="822960"/>
+          </a:xfrm>
+          <a:prstGeom prst="rect">
+            <a:avLst/>
+          </a:prstGeom>
+          <a:noFill/>
+        </p:spPr>
+        <p:txBody>
+          <a:bodyPr wrap="none">
+            <a:spAutoFit/>
+          </a:bodyPr>
+          <a:lstStyle/>
+          <a:p>
+            <a:pPr>
+              <a:defRPr sz="2600" b="1">
+                <a:solidFill>
+                  <a:srgbClr val="0B0B0B"/>
+                </a:solidFill>
+              </a:defRPr>
+            </a:pPr>
+            <a:r>
               <a:t>5 · Extending this to production multi-node GPU systems</a:t>
             </a:r>
           </a:p>
@@ -5787,6 +6822,83 @@
               </a:defRPr>
             </a:pPr>
             <a:r>
+              <a:t>2 · The training workload: what one DDP step does, and why it needs the network</a:t>
+            </a:r>
+          </a:p>
+        </p:txBody>
+      </p:sp>
+      <p:pic>
+        <p:nvPicPr>
+          <p:cNvPr id="3" name="Picture 2" descr="training.png"/>
+          <p:cNvPicPr>
+            <a:picLocks noChangeAspect="1"/>
+          </p:cNvPicPr>
+          <p:nvPr/>
+        </p:nvPicPr>
+        <p:blipFill>
+          <a:blip r:embed="rId3"/>
+          <a:stretch>
+            <a:fillRect/>
+          </a:stretch>
+        </p:blipFill>
+        <p:spPr>
+          <a:xfrm>
+            <a:off x="1166914" y="1051560"/>
+            <a:ext cx="9857866" cy="5577840"/>
+          </a:xfrm>
+          <a:prstGeom prst="rect">
+            <a:avLst/>
+          </a:prstGeom>
+        </p:spPr>
+      </p:pic>
+    </p:spTree>
+  </p:cSld>
+  <p:clrMapOvr>
+    <a:masterClrMapping/>
+  </p:clrMapOvr>
+</p:sld>
+</file>
+
+<file path=ppt/slides/slide7.xml><?xml version="1.0" encoding="utf-8"?>
+<p:sld xmlns:a="http://schemas.openxmlformats.org/drawingml/2006/main" xmlns:p="http://schemas.openxmlformats.org/presentationml/2006/main" xmlns:r="http://schemas.openxmlformats.org/officeDocument/2006/relationships">
+  <p:cSld>
+    <p:spTree>
+      <p:nvGrpSpPr>
+        <p:cNvPr id="1" name=""/>
+        <p:cNvGrpSpPr/>
+        <p:nvPr/>
+      </p:nvGrpSpPr>
+      <p:grpSpPr/>
+      <p:sp>
+        <p:nvSpPr>
+          <p:cNvPr id="2" name="TextBox 1"/>
+          <p:cNvSpPr txBox="1"/>
+          <p:nvPr/>
+        </p:nvSpPr>
+        <p:spPr>
+          <a:xfrm>
+            <a:off x="457200" y="274320"/>
+            <a:ext cx="11247120" cy="822960"/>
+          </a:xfrm>
+          <a:prstGeom prst="rect">
+            <a:avLst/>
+          </a:prstGeom>
+          <a:noFill/>
+        </p:spPr>
+        <p:txBody>
+          <a:bodyPr wrap="none">
+            <a:spAutoFit/>
+          </a:bodyPr>
+          <a:lstStyle/>
+          <a:p>
+            <a:pPr>
+              <a:defRPr sz="2600" b="1">
+                <a:solidFill>
+                  <a:srgbClr val="0B0B0B"/>
+                </a:solidFill>
+              </a:defRPr>
+            </a:pPr>
+            <a:r>
               <a:t>2 · Scaling: the training workload from 1 to 8 GPUs</a:t>
             </a:r>
           </a:p>
@@ -7020,7 +8132,7 @@
 </p:sld>
 </file>
 
-<file path=ppt/slides/slide7.xml><?xml version="1.0" encoding="utf-8"?>
+<file path=ppt/slides/slide8.xml><?xml version="1.0" encoding="utf-8"?>
 <p:sld xmlns:a="http://schemas.openxmlformats.org/drawingml/2006/main" xmlns:p="http://schemas.openxmlformats.org/presentationml/2006/main" xmlns:r="http://schemas.openxmlformats.org/officeDocument/2006/relationships">
   <p:cSld>
     <p:spTree>
@@ -7580,7 +8692,7 @@
 </p:sld>
 </file>
 
-<file path=ppt/slides/slide8.xml><?xml version="1.0" encoding="utf-8"?>
+<file path=ppt/slides/slide9.xml><?xml version="1.0" encoding="utf-8"?>
 <p:sld xmlns:a="http://schemas.openxmlformats.org/drawingml/2006/main" xmlns:p="http://schemas.openxmlformats.org/presentationml/2006/main" xmlns:r="http://schemas.openxmlformats.org/officeDocument/2006/relationships">
   <p:cSld>
     <p:spTree>
@@ -8683,914 +9795,6 @@
                       </a:pPr>
                       <a:r>
                         <a:t>0</a:t>
-                      </a:r>
-                    </a:p>
-                  </a:txBody>
-                  <a:tcPr/>
-                </a:tc>
-              </a:tr>
-            </a:tbl>
-          </a:graphicData>
-        </a:graphic>
-      </p:graphicFrame>
-    </p:spTree>
-  </p:cSld>
-  <p:clrMapOvr>
-    <a:masterClrMapping/>
-  </p:clrMapOvr>
-</p:sld>
-</file>
-
-<file path=ppt/slides/slide9.xml><?xml version="1.0" encoding="utf-8"?>
-<p:sld xmlns:a="http://schemas.openxmlformats.org/drawingml/2006/main" xmlns:p="http://schemas.openxmlformats.org/presentationml/2006/main" xmlns:r="http://schemas.openxmlformats.org/officeDocument/2006/relationships">
-  <p:cSld>
-    <p:spTree>
-      <p:nvGrpSpPr>
-        <p:cNvPr id="1" name=""/>
-        <p:cNvGrpSpPr/>
-        <p:nvPr/>
-      </p:nvGrpSpPr>
-      <p:grpSpPr/>
-      <p:sp>
-        <p:nvSpPr>
-          <p:cNvPr id="2" name="TextBox 1"/>
-          <p:cNvSpPr txBox="1"/>
-          <p:nvPr/>
-        </p:nvSpPr>
-        <p:spPr>
-          <a:xfrm>
-            <a:off x="457200" y="274320"/>
-            <a:ext cx="11247120" cy="822960"/>
-          </a:xfrm>
-          <a:prstGeom prst="rect">
-            <a:avLst/>
-          </a:prstGeom>
-          <a:noFill/>
-        </p:spPr>
-        <p:txBody>
-          <a:bodyPr wrap="none">
-            <a:spAutoFit/>
-          </a:bodyPr>
-          <a:lstStyle/>
-          <a:p>
-            <a:pPr>
-              <a:defRPr sz="2600" b="1">
-                <a:solidFill>
-                  <a:srgbClr val="0B0B0B"/>
-                </a:solidFill>
-              </a:defRPr>
-            </a:pPr>
-            <a:r>
-              <a:t>5 · Other knobs we measured, and the one that actually helps the workload</a:t>
-            </a:r>
-          </a:p>
-        </p:txBody>
-      </p:sp>
-      <p:sp>
-        <p:nvSpPr>
-          <p:cNvPr id="3" name="TextBox 2"/>
-          <p:cNvSpPr txBox="1"/>
-          <p:nvPr/>
-        </p:nvSpPr>
-        <p:spPr>
-          <a:xfrm>
-            <a:off x="548640" y="1188720"/>
-            <a:ext cx="5486400" cy="5029200"/>
-          </a:xfrm>
-          <a:prstGeom prst="rect">
-            <a:avLst/>
-          </a:prstGeom>
-          <a:noFill/>
-        </p:spPr>
-        <p:txBody>
-          <a:bodyPr wrap="square">
-            <a:spAutoFit/>
-          </a:bodyPr>
-          <a:lstStyle/>
-          <a:p>
-            <a:pPr>
-              <a:spcAft>
-                <a:spcPts val="600"/>
-              </a:spcAft>
-              <a:defRPr sz="1400">
-                <a:solidFill>
-                  <a:srgbClr val="0B0B0B"/>
-                </a:solidFill>
-              </a:defRPr>
-            </a:pPr>
-            <a:r>
-              <a:t>• GPUDirect off: −38 % — same bytes on the wire, 1.6× the time; the cost of copying through host memory</a:t>
-            </a:r>
-          </a:p>
-          <a:p>
-            <a:pPr>
-              <a:spcAft>
-                <a:spcPts val="600"/>
-              </a:spcAft>
-              <a:defRPr sz="1400">
-                <a:solidFill>
-                  <a:srgbClr val="0B0B0B"/>
-                </a:solidFill>
-              </a:defRPr>
-            </a:pPr>
-            <a:r>
-              <a:t>• Bigger NCCL buffers: no change. NVLS vs Ring algorithm on NVLink: 474 vs 388 GB/s — the NVSwitch reduction is what keeps the NVLink curve climbing. 'Tree' is not valid for this collective set (NCCL has no tree all-gather)</a:t>
-            </a:r>
-          </a:p>
-          <a:p>
-            <a:pPr>
-              <a:spcAft>
-                <a:spcPts val="600"/>
-              </a:spcAft>
-              <a:defRPr sz="1400">
-                <a:solidFill>
-                  <a:srgbClr val="0B0B0B"/>
-                </a:solidFill>
-              </a:defRPr>
-            </a:pPr>
-            <a:r>
-              <a:t>• TCP with more socket threads: 7× faster than default TCP, still 14× slower than RDMA</a:t>
-            </a:r>
-          </a:p>
-          <a:p>
-            <a:pPr>
-              <a:spcAft>
-                <a:spcPts val="600"/>
-              </a:spcAft>
-              <a:defRPr sz="1400">
-                <a:solidFill>
-                  <a:srgbClr val="0B0B0B"/>
-                </a:solidFill>
-              </a:defRPr>
-            </a:pPr>
-            <a:r>
-              <a:t>• DDP gradient buckets 25 → 200 MiB over the rails: 2090 → 2769 samples/s (+32 %); communication share of the step falls from 91 % to 32 %. On a slower interconnect, change how often you communicate before changing how</a:t>
-            </a:r>
-          </a:p>
-        </p:txBody>
-      </p:sp>
-      <p:graphicFrame>
-        <p:nvGraphicFramePr>
-          <p:cNvPr id="4" name="Table 3"/>
-          <p:cNvGraphicFramePr>
-            <a:graphicFrameLocks noGrp="1"/>
-          </p:cNvGraphicFramePr>
-          <p:nvPr/>
-        </p:nvGraphicFramePr>
-        <p:xfrm>
-          <a:off x="6217920" y="1188720"/>
-          <a:ext cx="5486400" cy="3291839"/>
-        </p:xfrm>
-        <a:graphic>
-          <a:graphicData uri="http://schemas.openxmlformats.org/drawingml/2006/table">
-            <a:tbl>
-              <a:tblPr firstRow="1" bandRow="1">
-                <a:tableStyleId>{5C22544A-7EE6-4342-B048-85BDC9FD1C3A}</a:tableStyleId>
-              </a:tblPr>
-              <a:tblGrid>
-                <a:gridCol w="1371600"/>
-                <a:gridCol w="1371600"/>
-                <a:gridCol w="1371600"/>
-                <a:gridCol w="1371600"/>
-              </a:tblGrid>
-              <a:tr h="274319">
-                <a:tc>
-                  <a:txBody>
-                    <a:bodyPr/>
-                    <a:lstStyle/>
-                    <a:p>
-                      <a:pPr>
-                        <a:defRPr sz="900" b="1"/>
-                      </a:pPr>
-                      <a:r>
-                        <a:t>run_id</a:t>
-                      </a:r>
-                    </a:p>
-                  </a:txBody>
-                  <a:tcPr/>
-                </a:tc>
-                <a:tc>
-                  <a:txBody>
-                    <a:bodyPr/>
-                    <a:lstStyle/>
-                    <a:p>
-                      <a:pPr>
-                        <a:defRPr sz="900" b="1"/>
-                      </a:pPr>
-                      <a:r>
-                        <a:t>16MiB</a:t>
-                      </a:r>
-                    </a:p>
-                  </a:txBody>
-                  <a:tcPr/>
-                </a:tc>
-                <a:tc>
-                  <a:txBody>
-                    <a:bodyPr/>
-                    <a:lstStyle/>
-                    <a:p>
-                      <a:pPr>
-                        <a:defRPr sz="900" b="1"/>
-                      </a:pPr>
-                      <a:r>
-                        <a:t>512MiB</a:t>
-                      </a:r>
-                    </a:p>
-                  </a:txBody>
-                  <a:tcPr/>
-                </a:tc>
-                <a:tc>
-                  <a:txBody>
-                    <a:bodyPr/>
-                    <a:lstStyle/>
-                    <a:p>
-                      <a:pPr>
-                        <a:defRPr sz="900" b="1"/>
-                      </a:pPr>
-                      <a:r>
-                        <a:t>4GiB</a:t>
-                      </a:r>
-                    </a:p>
-                  </a:txBody>
-                  <a:tcPr/>
-                </a:tc>
-              </a:tr>
-              <a:tr h="274319">
-                <a:tc>
-                  <a:txBody>
-                    <a:bodyPr/>
-                    <a:lstStyle/>
-                    <a:p>
-                      <a:pPr>
-                        <a:defRPr sz="900"/>
-                      </a:pPr>
-                      <a:r>
-                        <a:t>e5-algo-nvls</a:t>
-                      </a:r>
-                    </a:p>
-                  </a:txBody>
-                  <a:tcPr/>
-                </a:tc>
-                <a:tc>
-                  <a:txBody>
-                    <a:bodyPr/>
-                    <a:lstStyle/>
-                    <a:p>
-                      <a:pPr>
-                        <a:defRPr sz="900"/>
-                      </a:pPr>
-                      <a:r>
-                        <a:t>297</a:t>
-                      </a:r>
-                    </a:p>
-                  </a:txBody>
-                  <a:tcPr/>
-                </a:tc>
-                <a:tc>
-                  <a:txBody>
-                    <a:bodyPr/>
-                    <a:lstStyle/>
-                    <a:p>
-                      <a:pPr>
-                        <a:defRPr sz="900"/>
-                      </a:pPr>
-                      <a:r>
-                        <a:t>695</a:t>
-                      </a:r>
-                    </a:p>
-                  </a:txBody>
-                  <a:tcPr/>
-                </a:tc>
-                <a:tc>
-                  <a:txBody>
-                    <a:bodyPr/>
-                    <a:lstStyle/>
-                    <a:p>
-                      <a:pPr>
-                        <a:defRPr sz="900"/>
-                      </a:pPr>
-                      <a:r>
-                        <a:t>830</a:t>
-                      </a:r>
-                    </a:p>
-                  </a:txBody>
-                  <a:tcPr/>
-                </a:tc>
-              </a:tr>
-              <a:tr h="274319">
-                <a:tc>
-                  <a:txBody>
-                    <a:bodyPr/>
-                    <a:lstStyle/>
-                    <a:p>
-                      <a:pPr>
-                        <a:defRPr sz="900"/>
-                      </a:pPr>
-                      <a:r>
-                        <a:t>e5-algo-ring</a:t>
-                      </a:r>
-                    </a:p>
-                  </a:txBody>
-                  <a:tcPr/>
-                </a:tc>
-                <a:tc>
-                  <a:txBody>
-                    <a:bodyPr/>
-                    <a:lstStyle/>
-                    <a:p>
-                      <a:pPr>
-                        <a:defRPr sz="900"/>
-                      </a:pPr>
-                      <a:r>
-                        <a:t>327</a:t>
-                      </a:r>
-                    </a:p>
-                  </a:txBody>
-                  <a:tcPr/>
-                </a:tc>
-                <a:tc>
-                  <a:txBody>
-                    <a:bodyPr/>
-                    <a:lstStyle/>
-                    <a:p>
-                      <a:pPr>
-                        <a:defRPr sz="900"/>
-                      </a:pPr>
-                      <a:r>
-                        <a:t>635</a:t>
-                      </a:r>
-                    </a:p>
-                  </a:txBody>
-                  <a:tcPr/>
-                </a:tc>
-                <a:tc>
-                  <a:txBody>
-                    <a:bodyPr/>
-                    <a:lstStyle/>
-                    <a:p>
-                      <a:pPr>
-                        <a:defRPr sz="900"/>
-                      </a:pPr>
-                      <a:r>
-                        <a:t>679</a:t>
-                      </a:r>
-                    </a:p>
-                  </a:txBody>
-                  <a:tcPr/>
-                </a:tc>
-              </a:tr>
-              <a:tr h="274319">
-                <a:tc>
-                  <a:txBody>
-                    <a:bodyPr/>
-                    <a:lstStyle/>
-                    <a:p>
-                      <a:pPr>
-                        <a:defRPr sz="900"/>
-                      </a:pPr>
-                      <a:r>
-                        <a:t>e5-buffsize16m</a:t>
-                      </a:r>
-                    </a:p>
-                  </a:txBody>
-                  <a:tcPr/>
-                </a:tc>
-                <a:tc>
-                  <a:txBody>
-                    <a:bodyPr/>
-                    <a:lstStyle/>
-                    <a:p>
-                      <a:pPr>
-                        <a:defRPr sz="900"/>
-                      </a:pPr>
-                      <a:r>
-                        <a:t>101</a:t>
-                      </a:r>
-                    </a:p>
-                  </a:txBody>
-                  <a:tcPr/>
-                </a:tc>
-                <a:tc>
-                  <a:txBody>
-                    <a:bodyPr/>
-                    <a:lstStyle/>
-                    <a:p>
-                      <a:pPr>
-                        <a:defRPr sz="900"/>
-                      </a:pPr>
-                      <a:r>
-                        <a:t>420</a:t>
-                      </a:r>
-                    </a:p>
-                  </a:txBody>
-                  <a:tcPr/>
-                </a:tc>
-                <a:tc>
-                  <a:txBody>
-                    <a:bodyPr/>
-                    <a:lstStyle/>
-                    <a:p>
-                      <a:pPr>
-                        <a:defRPr sz="900"/>
-                      </a:pPr>
-                      <a:r>
-                        <a:t>393</a:t>
-                      </a:r>
-                    </a:p>
-                  </a:txBody>
-                  <a:tcPr/>
-                </a:tc>
-              </a:tr>
-              <a:tr h="274319">
-                <a:tc>
-                  <a:txBody>
-                    <a:bodyPr/>
-                    <a:lstStyle/>
-                    <a:p>
-                      <a:pPr>
-                        <a:defRPr sz="900"/>
-                      </a:pPr>
-                      <a:r>
-                        <a:t>e5-buffsize4m</a:t>
-                      </a:r>
-                    </a:p>
-                  </a:txBody>
-                  <a:tcPr/>
-                </a:tc>
-                <a:tc>
-                  <a:txBody>
-                    <a:bodyPr/>
-                    <a:lstStyle/>
-                    <a:p>
-                      <a:pPr>
-                        <a:defRPr sz="900"/>
-                      </a:pPr>
-                      <a:r>
-                        <a:t>102</a:t>
-                      </a:r>
-                    </a:p>
-                  </a:txBody>
-                  <a:tcPr/>
-                </a:tc>
-                <a:tc>
-                  <a:txBody>
-                    <a:bodyPr/>
-                    <a:lstStyle/>
-                    <a:p>
-                      <a:pPr>
-                        <a:defRPr sz="900"/>
-                      </a:pPr>
-                      <a:r>
-                        <a:t>402</a:t>
-                      </a:r>
-                    </a:p>
-                  </a:txBody>
-                  <a:tcPr/>
-                </a:tc>
-                <a:tc>
-                  <a:txBody>
-                    <a:bodyPr/>
-                    <a:lstStyle/>
-                    <a:p>
-                      <a:pPr>
-                        <a:defRPr sz="900"/>
-                      </a:pPr>
-                      <a:r>
-                        <a:t>419</a:t>
-                      </a:r>
-                    </a:p>
-                  </a:txBody>
-                  <a:tcPr/>
-                </a:tc>
-              </a:tr>
-              <a:tr h="274319">
-                <a:tc>
-                  <a:txBody>
-                    <a:bodyPr/>
-                    <a:lstStyle/>
-                    <a:p>
-                      <a:pPr>
-                        <a:defRPr sz="900"/>
-                      </a:pPr>
-                      <a:r>
-                        <a:t>e5-counters-gdr-off</a:t>
-                      </a:r>
-                    </a:p>
-                  </a:txBody>
-                  <a:tcPr/>
-                </a:tc>
-                <a:tc>
-                  <a:txBody>
-                    <a:bodyPr/>
-                    <a:lstStyle/>
-                    <a:p>
-                      <a:pPr>
-                        <a:defRPr sz="900"/>
-                      </a:pPr>
-                      <a:r>
-                        <a:t>nan</a:t>
-                      </a:r>
-                    </a:p>
-                  </a:txBody>
-                  <a:tcPr/>
-                </a:tc>
-                <a:tc>
-                  <a:txBody>
-                    <a:bodyPr/>
-                    <a:lstStyle/>
-                    <a:p>
-                      <a:pPr>
-                        <a:defRPr sz="900"/>
-                      </a:pPr>
-                      <a:r>
-                        <a:t>nan</a:t>
-                      </a:r>
-                    </a:p>
-                  </a:txBody>
-                  <a:tcPr/>
-                </a:tc>
-                <a:tc>
-                  <a:txBody>
-                    <a:bodyPr/>
-                    <a:lstStyle/>
-                    <a:p>
-                      <a:pPr>
-                        <a:defRPr sz="900"/>
-                      </a:pPr>
-                      <a:r>
-                        <a:t>253</a:t>
-                      </a:r>
-                    </a:p>
-                  </a:txBody>
-                  <a:tcPr/>
-                </a:tc>
-              </a:tr>
-              <a:tr h="274319">
-                <a:tc>
-                  <a:txBody>
-                    <a:bodyPr/>
-                    <a:lstStyle/>
-                    <a:p>
-                      <a:pPr>
-                        <a:defRPr sz="900"/>
-                      </a:pPr>
-                      <a:r>
-                        <a:t>e5-counters-nvlink</a:t>
-                      </a:r>
-                    </a:p>
-                  </a:txBody>
-                  <a:tcPr/>
-                </a:tc>
-                <a:tc>
-                  <a:txBody>
-                    <a:bodyPr/>
-                    <a:lstStyle/>
-                    <a:p>
-                      <a:pPr>
-                        <a:defRPr sz="900"/>
-                      </a:pPr>
-                      <a:r>
-                        <a:t>nan</a:t>
-                      </a:r>
-                    </a:p>
-                  </a:txBody>
-                  <a:tcPr/>
-                </a:tc>
-                <a:tc>
-                  <a:txBody>
-                    <a:bodyPr/>
-                    <a:lstStyle/>
-                    <a:p>
-                      <a:pPr>
-                        <a:defRPr sz="900"/>
-                      </a:pPr>
-                      <a:r>
-                        <a:t>nan</a:t>
-                      </a:r>
-                    </a:p>
-                  </a:txBody>
-                  <a:tcPr/>
-                </a:tc>
-                <a:tc>
-                  <a:txBody>
-                    <a:bodyPr/>
-                    <a:lstStyle/>
-                    <a:p>
-                      <a:pPr>
-                        <a:defRPr sz="900"/>
-                      </a:pPr>
-                      <a:r>
-                        <a:t>833</a:t>
-                      </a:r>
-                    </a:p>
-                  </a:txBody>
-                  <a:tcPr/>
-                </a:tc>
-              </a:tr>
-              <a:tr h="274319">
-                <a:tc>
-                  <a:txBody>
-                    <a:bodyPr/>
-                    <a:lstStyle/>
-                    <a:p>
-                      <a:pPr>
-                        <a:defRPr sz="900"/>
-                      </a:pPr>
-                      <a:r>
-                        <a:t>e5-counters-rails1</a:t>
-                      </a:r>
-                    </a:p>
-                  </a:txBody>
-                  <a:tcPr/>
-                </a:tc>
-                <a:tc>
-                  <a:txBody>
-                    <a:bodyPr/>
-                    <a:lstStyle/>
-                    <a:p>
-                      <a:pPr>
-                        <a:defRPr sz="900"/>
-                      </a:pPr>
-                      <a:r>
-                        <a:t>nan</a:t>
-                      </a:r>
-                    </a:p>
-                  </a:txBody>
-                  <a:tcPr/>
-                </a:tc>
-                <a:tc>
-                  <a:txBody>
-                    <a:bodyPr/>
-                    <a:lstStyle/>
-                    <a:p>
-                      <a:pPr>
-                        <a:defRPr sz="900"/>
-                      </a:pPr>
-                      <a:r>
-                        <a:t>nan</a:t>
-                      </a:r>
-                    </a:p>
-                  </a:txBody>
-                  <a:tcPr/>
-                </a:tc>
-                <a:tc>
-                  <a:txBody>
-                    <a:bodyPr/>
-                    <a:lstStyle/>
-                    <a:p>
-                      <a:pPr>
-                        <a:defRPr sz="900"/>
-                      </a:pPr>
-                      <a:r>
-                        <a:t>87.8</a:t>
-                      </a:r>
-                    </a:p>
-                  </a:txBody>
-                  <a:tcPr/>
-                </a:tc>
-              </a:tr>
-              <a:tr h="274319">
-                <a:tc>
-                  <a:txBody>
-                    <a:bodyPr/>
-                    <a:lstStyle/>
-                    <a:p>
-                      <a:pPr>
-                        <a:defRPr sz="900"/>
-                      </a:pPr>
-                      <a:r>
-                        <a:t>e5-counters-rdma</a:t>
-                      </a:r>
-                    </a:p>
-                  </a:txBody>
-                  <a:tcPr/>
-                </a:tc>
-                <a:tc>
-                  <a:txBody>
-                    <a:bodyPr/>
-                    <a:lstStyle/>
-                    <a:p>
-                      <a:pPr>
-                        <a:defRPr sz="900"/>
-                      </a:pPr>
-                      <a:r>
-                        <a:t>nan</a:t>
-                      </a:r>
-                    </a:p>
-                  </a:txBody>
-                  <a:tcPr/>
-                </a:tc>
-                <a:tc>
-                  <a:txBody>
-                    <a:bodyPr/>
-                    <a:lstStyle/>
-                    <a:p>
-                      <a:pPr>
-                        <a:defRPr sz="900"/>
-                      </a:pPr>
-                      <a:r>
-                        <a:t>nan</a:t>
-                      </a:r>
-                    </a:p>
-                  </a:txBody>
-                  <a:tcPr/>
-                </a:tc>
-                <a:tc>
-                  <a:txBody>
-                    <a:bodyPr/>
-                    <a:lstStyle/>
-                    <a:p>
-                      <a:pPr>
-                        <a:defRPr sz="900"/>
-                      </a:pPr>
-                      <a:r>
-                        <a:t>410</a:t>
-                      </a:r>
-                    </a:p>
-                  </a:txBody>
-                  <a:tcPr/>
-                </a:tc>
-              </a:tr>
-              <a:tr h="274319">
-                <a:tc>
-                  <a:txBody>
-                    <a:bodyPr/>
-                    <a:lstStyle/>
-                    <a:p>
-                      <a:pPr>
-                        <a:defRPr sz="900"/>
-                      </a:pPr>
-                      <a:r>
-                        <a:t>e5-counters-rdma-qps4</a:t>
-                      </a:r>
-                    </a:p>
-                  </a:txBody>
-                  <a:tcPr/>
-                </a:tc>
-                <a:tc>
-                  <a:txBody>
-                    <a:bodyPr/>
-                    <a:lstStyle/>
-                    <a:p>
-                      <a:pPr>
-                        <a:defRPr sz="900"/>
-                      </a:pPr>
-                      <a:r>
-                        <a:t>nan</a:t>
-                      </a:r>
-                    </a:p>
-                  </a:txBody>
-                  <a:tcPr/>
-                </a:tc>
-                <a:tc>
-                  <a:txBody>
-                    <a:bodyPr/>
-                    <a:lstStyle/>
-                    <a:p>
-                      <a:pPr>
-                        <a:defRPr sz="900"/>
-                      </a:pPr>
-                      <a:r>
-                        <a:t>nan</a:t>
-                      </a:r>
-                    </a:p>
-                  </a:txBody>
-                  <a:tcPr/>
-                </a:tc>
-                <a:tc>
-                  <a:txBody>
-                    <a:bodyPr/>
-                    <a:lstStyle/>
-                    <a:p>
-                      <a:pPr>
-                        <a:defRPr sz="900"/>
-                      </a:pPr>
-                      <a:r>
-                        <a:t>301</a:t>
-                      </a:r>
-                    </a:p>
-                  </a:txBody>
-                  <a:tcPr/>
-                </a:tc>
-              </a:tr>
-              <a:tr h="274319">
-                <a:tc>
-                  <a:txBody>
-                    <a:bodyPr/>
-                    <a:lstStyle/>
-                    <a:p>
-                      <a:pPr>
-                        <a:defRPr sz="900"/>
-                      </a:pPr>
-                      <a:r>
-                        <a:t>e5-gdr-off</a:t>
-                      </a:r>
-                    </a:p>
-                  </a:txBody>
-                  <a:tcPr/>
-                </a:tc>
-                <a:tc>
-                  <a:txBody>
-                    <a:bodyPr/>
-                    <a:lstStyle/>
-                    <a:p>
-                      <a:pPr>
-                        <a:defRPr sz="900"/>
-                      </a:pPr>
-                      <a:r>
-                        <a:t>107</a:t>
-                      </a:r>
-                    </a:p>
-                  </a:txBody>
-                  <a:tcPr/>
-                </a:tc>
-                <a:tc>
-                  <a:txBody>
-                    <a:bodyPr/>
-                    <a:lstStyle/>
-                    <a:p>
-                      <a:pPr>
-                        <a:defRPr sz="900"/>
-                      </a:pPr>
-                      <a:r>
-                        <a:t>222</a:t>
-                      </a:r>
-                    </a:p>
-                  </a:txBody>
-                  <a:tcPr/>
-                </a:tc>
-                <a:tc>
-                  <a:txBody>
-                    <a:bodyPr/>
-                    <a:lstStyle/>
-                    <a:p>
-                      <a:pPr>
-                        <a:defRPr sz="900"/>
-                      </a:pPr>
-                      <a:r>
-                        <a:t>247</a:t>
-                      </a:r>
-                    </a:p>
-                  </a:txBody>
-                  <a:tcPr/>
-                </a:tc>
-              </a:tr>
-              <a:tr h="274330">
-                <a:tc>
-                  <a:txBody>
-                    <a:bodyPr/>
-                    <a:lstStyle/>
-                    <a:p>
-                      <a:pPr>
-                        <a:defRPr sz="900"/>
-                      </a:pPr>
-                      <a:r>
-                        <a:t>e5-sock-nthreads4</a:t>
-                      </a:r>
-                    </a:p>
-                  </a:txBody>
-                  <a:tcPr/>
-                </a:tc>
-                <a:tc>
-                  <a:txBody>
-                    <a:bodyPr/>
-                    <a:lstStyle/>
-                    <a:p>
-                      <a:pPr>
-                        <a:defRPr sz="900"/>
-                      </a:pPr>
-                      <a:r>
-                        <a:t>10.3</a:t>
-                      </a:r>
-                    </a:p>
-                  </a:txBody>
-                  <a:tcPr/>
-                </a:tc>
-                <a:tc>
-                  <a:txBody>
-                    <a:bodyPr/>
-                    <a:lstStyle/>
-                    <a:p>
-                      <a:pPr>
-                        <a:defRPr sz="900"/>
-                      </a:pPr>
-                      <a:r>
-                        <a:t>21.6</a:t>
-                      </a:r>
-                    </a:p>
-                  </a:txBody>
-                  <a:tcPr/>
-                </a:tc>
-                <a:tc>
-                  <a:txBody>
-                    <a:bodyPr/>
-                    <a:lstStyle/>
-                    <a:p>
-                      <a:pPr>
-                        <a:defRPr sz="900"/>
-                      </a:pPr>
-                      <a:r>
-                        <a:t>29.4</a:t>
                       </a:r>
                     </a:p>
                   </a:txBody>

</xml_diff>

<commit_message>
Rails: state link rates per direction, show receive matched transmit (411/412 and 482/483 Gb/s per rail), rule out the 800-bidirectional reading; blog, findings, slide 8 notes
Co-Authored-By: Claude Fable 5.1 <noreply@anthropic.com>
</commit_message>
<xml_diff>
--- a/slides/compass.pptx
+++ b/slides/compass.pptx
@@ -1186,7 +1186,7 @@
           <a:p/>
           <a:p>
             <a:r>
-              <a:t>How we know the rails are 800 Gb/s: we watched the NIC's transmitted-bytes counter during a sustained all-reduce and cross-checked it against ethtool's byte counter (they agree to the byte). One rail moved 411 Gb/s. The physical NIC exposes four 200 Gb/s ports per rail, and the virtual function aggregates them.</a:t>
+              <a:t>How we know the rails are 800 Gb/s per direction: we watched the NIC's transmitted-bytes and received-bytes counters during a sustained all-reduce and cross-checked them against ethtool's byte counters (they agree to the byte). One rail moved 411 Gb/s out and 412 Gb/s in at the same time. Link rates in sysfs and ethtool are per direction (200 Gb/s = 2 lanes x 100 Gb/s each way), so one 200 Gb/s link cannot carry that; the physical NIC exposes four 200 Gb/s ports per rail and the virtual function aggregates them. If someone suggests 800 is a bidirectional figure (400 each way), the four-rail window answers it: 482 out plus 483 in, about 965 Gb/s through one rail at once. Utilisation is therefore 51-60 % in each direction.</a:t>
             </a:r>
           </a:p>
           <a:p/>
@@ -8249,7 +8249,7 @@
               </a:defRPr>
             </a:pPr>
             <a:r>
-              <a:t>• The bytes counted on each rail match the theoretical minimum for a two-node all-reduce exactly — and one rail carried 411 Gb/s, which a 200 Gb/s link cannot do. So a rail is really a 4-plane 800 Gb/s port; sysfs and ethtool report a single plane</a:t>
+              <a:t>• The bytes counted on each rail match the theoretical minimum for a two-node all-reduce exactly, in both directions — and one rail carried 411 Gb/s out and 412 Gb/s in at once, which a 200 Gb/s link cannot do. A rail is really a 4-plane 800 Gb/s-per-direction port; sysfs and ethtool report a single plane</a:t>
             </a:r>
           </a:p>
           <a:p>

</xml_diff>